<commit_message>
editing images, small fixes
</commit_message>
<xml_diff>
--- a/LaTeX M.Sc. LRT/Aerodynamik/images/AER-Images.pptx
+++ b/LaTeX M.Sc. LRT/Aerodynamik/images/AER-Images.pptx
@@ -5,16 +5,18 @@
     <p:sldMasterId id="2147483660" r:id="rId1"/>
   </p:sldMasterIdLst>
   <p:notesMasterIdLst>
-    <p:notesMasterId r:id="rId9"/>
+    <p:notesMasterId r:id="rId11"/>
   </p:notesMasterIdLst>
   <p:sldIdLst>
     <p:sldId id="261" r:id="rId2"/>
     <p:sldId id="262" r:id="rId3"/>
-    <p:sldId id="256" r:id="rId4"/>
-    <p:sldId id="257" r:id="rId5"/>
-    <p:sldId id="258" r:id="rId6"/>
-    <p:sldId id="259" r:id="rId7"/>
-    <p:sldId id="260" r:id="rId8"/>
+    <p:sldId id="264" r:id="rId4"/>
+    <p:sldId id="263" r:id="rId5"/>
+    <p:sldId id="256" r:id="rId6"/>
+    <p:sldId id="257" r:id="rId7"/>
+    <p:sldId id="258" r:id="rId8"/>
+    <p:sldId id="259" r:id="rId9"/>
+    <p:sldId id="260" r:id="rId10"/>
   </p:sldIdLst>
   <p:sldSz cx="3600450" cy="3600450"/>
   <p:notesSz cx="6858000" cy="9144000"/>
@@ -203,7 +205,7 @@
           <a:p>
             <a:fld id="{0C596C2D-C72C-406E-B79E-9BAC142DD20E}" type="datetimeFigureOut">
               <a:rPr lang="de-DE" smtClean="0"/>
-              <a:t>12.06.2026</a:t>
+              <a:t>21.08.2026</a:t>
             </a:fld>
             <a:endParaRPr lang="de-DE" dirty="0"/>
           </a:p>
@@ -601,7 +603,7 @@
           <a:p>
             <a:fld id="{6EAE28AA-0912-4DA0-8B30-7F3CA3FE6671}" type="datetimeFigureOut">
               <a:rPr lang="de-DE" smtClean="0"/>
-              <a:t>12.06.2026</a:t>
+              <a:t>21.08.2026</a:t>
             </a:fld>
             <a:endParaRPr lang="de-DE" dirty="0"/>
           </a:p>
@@ -771,7 +773,7 @@
           <a:p>
             <a:fld id="{6EAE28AA-0912-4DA0-8B30-7F3CA3FE6671}" type="datetimeFigureOut">
               <a:rPr lang="de-DE" smtClean="0"/>
-              <a:t>12.06.2026</a:t>
+              <a:t>21.08.2026</a:t>
             </a:fld>
             <a:endParaRPr lang="de-DE" dirty="0"/>
           </a:p>
@@ -951,7 +953,7 @@
           <a:p>
             <a:fld id="{6EAE28AA-0912-4DA0-8B30-7F3CA3FE6671}" type="datetimeFigureOut">
               <a:rPr lang="de-DE" smtClean="0"/>
-              <a:t>12.06.2026</a:t>
+              <a:t>21.08.2026</a:t>
             </a:fld>
             <a:endParaRPr lang="de-DE" dirty="0"/>
           </a:p>
@@ -1121,7 +1123,7 @@
           <a:p>
             <a:fld id="{6EAE28AA-0912-4DA0-8B30-7F3CA3FE6671}" type="datetimeFigureOut">
               <a:rPr lang="de-DE" smtClean="0"/>
-              <a:t>12.06.2026</a:t>
+              <a:t>21.08.2026</a:t>
             </a:fld>
             <a:endParaRPr lang="de-DE" dirty="0"/>
           </a:p>
@@ -1367,7 +1369,7 @@
           <a:p>
             <a:fld id="{6EAE28AA-0912-4DA0-8B30-7F3CA3FE6671}" type="datetimeFigureOut">
               <a:rPr lang="de-DE" smtClean="0"/>
-              <a:t>12.06.2026</a:t>
+              <a:t>21.08.2026</a:t>
             </a:fld>
             <a:endParaRPr lang="de-DE" dirty="0"/>
           </a:p>
@@ -1599,7 +1601,7 @@
           <a:p>
             <a:fld id="{6EAE28AA-0912-4DA0-8B30-7F3CA3FE6671}" type="datetimeFigureOut">
               <a:rPr lang="de-DE" smtClean="0"/>
-              <a:t>12.06.2026</a:t>
+              <a:t>21.08.2026</a:t>
             </a:fld>
             <a:endParaRPr lang="de-DE" dirty="0"/>
           </a:p>
@@ -1966,7 +1968,7 @@
           <a:p>
             <a:fld id="{6EAE28AA-0912-4DA0-8B30-7F3CA3FE6671}" type="datetimeFigureOut">
               <a:rPr lang="de-DE" smtClean="0"/>
-              <a:t>12.06.2026</a:t>
+              <a:t>21.08.2026</a:t>
             </a:fld>
             <a:endParaRPr lang="de-DE" dirty="0"/>
           </a:p>
@@ -2084,7 +2086,7 @@
           <a:p>
             <a:fld id="{6EAE28AA-0912-4DA0-8B30-7F3CA3FE6671}" type="datetimeFigureOut">
               <a:rPr lang="de-DE" smtClean="0"/>
-              <a:t>12.06.2026</a:t>
+              <a:t>21.08.2026</a:t>
             </a:fld>
             <a:endParaRPr lang="de-DE" dirty="0"/>
           </a:p>
@@ -2179,7 +2181,7 @@
           <a:p>
             <a:fld id="{6EAE28AA-0912-4DA0-8B30-7F3CA3FE6671}" type="datetimeFigureOut">
               <a:rPr lang="de-DE" smtClean="0"/>
-              <a:t>12.06.2026</a:t>
+              <a:t>21.08.2026</a:t>
             </a:fld>
             <a:endParaRPr lang="de-DE" dirty="0"/>
           </a:p>
@@ -2456,7 +2458,7 @@
           <a:p>
             <a:fld id="{6EAE28AA-0912-4DA0-8B30-7F3CA3FE6671}" type="datetimeFigureOut">
               <a:rPr lang="de-DE" smtClean="0"/>
-              <a:t>12.06.2026</a:t>
+              <a:t>21.08.2026</a:t>
             </a:fld>
             <a:endParaRPr lang="de-DE" dirty="0"/>
           </a:p>
@@ -2713,7 +2715,7 @@
           <a:p>
             <a:fld id="{6EAE28AA-0912-4DA0-8B30-7F3CA3FE6671}" type="datetimeFigureOut">
               <a:rPr lang="de-DE" smtClean="0"/>
-              <a:t>12.06.2026</a:t>
+              <a:t>21.08.2026</a:t>
             </a:fld>
             <a:endParaRPr lang="de-DE" dirty="0"/>
           </a:p>
@@ -2926,7 +2928,7 @@
           <a:p>
             <a:fld id="{6EAE28AA-0912-4DA0-8B30-7F3CA3FE6671}" type="datetimeFigureOut">
               <a:rPr lang="de-DE" smtClean="0"/>
-              <a:t>12.06.2026</a:t>
+              <a:t>21.08.2026</a:t>
             </a:fld>
             <a:endParaRPr lang="de-DE" dirty="0"/>
           </a:p>
@@ -5111,6 +5113,2788 @@
           <a:chExt cx="0" cy="0"/>
         </a:xfrm>
       </p:grpSpPr>
+      <p:sp>
+        <p:nvSpPr>
+          <p:cNvPr id="112" name="Bogen 111">
+            <a:extLst>
+              <a:ext uri="{FF2B5EF4-FFF2-40B4-BE49-F238E27FC236}">
+                <a16:creationId xmlns:a16="http://schemas.microsoft.com/office/drawing/2014/main" id="{04F5DCF1-C6BC-42B7-903D-4F37214858B7}"/>
+              </a:ext>
+            </a:extLst>
+          </p:cNvPr>
+          <p:cNvSpPr/>
+          <p:nvPr/>
+        </p:nvSpPr>
+        <p:spPr>
+          <a:xfrm>
+            <a:off x="-1244893" y="-20248"/>
+            <a:ext cx="3973754" cy="3973754"/>
+          </a:xfrm>
+          <a:prstGeom prst="arc">
+            <a:avLst>
+              <a:gd name="adj1" fmla="val 2897"/>
+              <a:gd name="adj2" fmla="val 808961"/>
+            </a:avLst>
+          </a:prstGeom>
+          <a:ln w="12700" cap="rnd">
+            <a:solidFill>
+              <a:schemeClr val="accent2">
+                <a:lumMod val="75000"/>
+              </a:schemeClr>
+            </a:solidFill>
+            <a:round/>
+            <a:headEnd type="none" w="sm" len="sm"/>
+            <a:tailEnd type="triangle" w="med" len="med"/>
+          </a:ln>
+        </p:spPr>
+        <p:style>
+          <a:lnRef idx="2">
+            <a:schemeClr val="accent1"/>
+          </a:lnRef>
+          <a:fillRef idx="0">
+            <a:schemeClr val="accent1"/>
+          </a:fillRef>
+          <a:effectRef idx="1">
+            <a:schemeClr val="accent1"/>
+          </a:effectRef>
+          <a:fontRef idx="minor">
+            <a:schemeClr val="tx1"/>
+          </a:fontRef>
+        </p:style>
+        <p:txBody>
+          <a:bodyPr rtlCol="0" anchor="ctr"/>
+          <a:lstStyle/>
+          <a:p>
+            <a:pPr algn="ctr"/>
+            <a:endParaRPr lang="de-DE"/>
+          </a:p>
+        </p:txBody>
+      </p:sp>
+      <p:sp>
+        <p:nvSpPr>
+          <p:cNvPr id="107" name="Bogen 106">
+            <a:extLst>
+              <a:ext uri="{FF2B5EF4-FFF2-40B4-BE49-F238E27FC236}">
+                <a16:creationId xmlns:a16="http://schemas.microsoft.com/office/drawing/2014/main" id="{3BCE6A63-2FA3-1C09-1191-931D1C9A3616}"/>
+              </a:ext>
+            </a:extLst>
+          </p:cNvPr>
+          <p:cNvSpPr/>
+          <p:nvPr/>
+        </p:nvSpPr>
+        <p:spPr>
+          <a:xfrm>
+            <a:off x="1976645" y="930831"/>
+            <a:ext cx="2072278" cy="2072278"/>
+          </a:xfrm>
+          <a:prstGeom prst="arc">
+            <a:avLst>
+              <a:gd name="adj1" fmla="val 10799897"/>
+              <a:gd name="adj2" fmla="val 11773488"/>
+            </a:avLst>
+          </a:prstGeom>
+          <a:ln w="12700" cap="rnd">
+            <a:solidFill>
+              <a:schemeClr val="tx2">
+                <a:lumMod val="75000"/>
+                <a:lumOff val="25000"/>
+              </a:schemeClr>
+            </a:solidFill>
+            <a:round/>
+            <a:headEnd type="none" w="sm" len="sm"/>
+            <a:tailEnd type="triangle" w="med" len="med"/>
+          </a:ln>
+        </p:spPr>
+        <p:style>
+          <a:lnRef idx="2">
+            <a:schemeClr val="accent1"/>
+          </a:lnRef>
+          <a:fillRef idx="0">
+            <a:schemeClr val="accent1"/>
+          </a:fillRef>
+          <a:effectRef idx="1">
+            <a:schemeClr val="accent1"/>
+          </a:effectRef>
+          <a:fontRef idx="minor">
+            <a:schemeClr val="tx1"/>
+          </a:fontRef>
+        </p:style>
+        <p:txBody>
+          <a:bodyPr rtlCol="0" anchor="ctr"/>
+          <a:lstStyle/>
+          <a:p>
+            <a:pPr algn="ctr"/>
+            <a:endParaRPr lang="de-DE"/>
+          </a:p>
+        </p:txBody>
+      </p:sp>
+      <p:cxnSp>
+        <p:nvCxnSpPr>
+          <p:cNvPr id="27" name="Gerader Verbinder 26">
+            <a:extLst>
+              <a:ext uri="{FF2B5EF4-FFF2-40B4-BE49-F238E27FC236}">
+                <a16:creationId xmlns:a16="http://schemas.microsoft.com/office/drawing/2014/main" id="{453BC48D-6BD2-D25B-237D-0C3EAE2A0000}"/>
+              </a:ext>
+            </a:extLst>
+          </p:cNvPr>
+          <p:cNvCxnSpPr>
+            <a:cxnSpLocks/>
+          </p:cNvCxnSpPr>
+          <p:nvPr/>
+        </p:nvCxnSpPr>
+        <p:spPr>
+          <a:xfrm>
+            <a:off x="767228" y="1493701"/>
+            <a:ext cx="1094910" cy="0"/>
+          </a:xfrm>
+          <a:prstGeom prst="line">
+            <a:avLst/>
+          </a:prstGeom>
+          <a:ln w="9525" cap="rnd">
+            <a:solidFill>
+              <a:schemeClr val="accent6">
+                <a:lumMod val="75000"/>
+              </a:schemeClr>
+            </a:solidFill>
+            <a:prstDash val="sysDash"/>
+            <a:round/>
+          </a:ln>
+        </p:spPr>
+        <p:style>
+          <a:lnRef idx="2">
+            <a:schemeClr val="accent1"/>
+          </a:lnRef>
+          <a:fillRef idx="0">
+            <a:schemeClr val="accent1"/>
+          </a:fillRef>
+          <a:effectRef idx="1">
+            <a:schemeClr val="accent1"/>
+          </a:effectRef>
+          <a:fontRef idx="minor">
+            <a:schemeClr val="tx1"/>
+          </a:fontRef>
+        </p:style>
+      </p:cxnSp>
+      <p:grpSp>
+        <p:nvGrpSpPr>
+          <p:cNvPr id="14" name="Gruppieren 13">
+            <a:extLst>
+              <a:ext uri="{FF2B5EF4-FFF2-40B4-BE49-F238E27FC236}">
+                <a16:creationId xmlns:a16="http://schemas.microsoft.com/office/drawing/2014/main" id="{89B54080-D4D6-AA94-A2FB-CFCAD04DE0A0}"/>
+              </a:ext>
+            </a:extLst>
+          </p:cNvPr>
+          <p:cNvGrpSpPr/>
+          <p:nvPr/>
+        </p:nvGrpSpPr>
+        <p:grpSpPr>
+          <a:xfrm>
+            <a:off x="3217688" y="1726119"/>
+            <a:ext cx="297655" cy="495659"/>
+            <a:chOff x="2818943" y="1913621"/>
+            <a:chExt cx="297655" cy="495659"/>
+          </a:xfrm>
+        </p:grpSpPr>
+        <p:cxnSp>
+          <p:nvCxnSpPr>
+            <p:cNvPr id="7" name="Gerader Verbinder 6">
+              <a:extLst>
+                <a:ext uri="{FF2B5EF4-FFF2-40B4-BE49-F238E27FC236}">
+                  <a16:creationId xmlns:a16="http://schemas.microsoft.com/office/drawing/2014/main" id="{937F024C-E0CE-29AD-4A69-50C7D45F4728}"/>
+                </a:ext>
+              </a:extLst>
+            </p:cNvPr>
+            <p:cNvCxnSpPr>
+              <a:cxnSpLocks/>
+            </p:cNvCxnSpPr>
+            <p:nvPr/>
+          </p:nvCxnSpPr>
+          <p:spPr>
+            <a:xfrm>
+              <a:off x="2917031" y="2152650"/>
+              <a:ext cx="132274" cy="0"/>
+            </a:xfrm>
+            <a:prstGeom prst="line">
+              <a:avLst/>
+            </a:prstGeom>
+            <a:ln w="9525" cap="rnd">
+              <a:round/>
+            </a:ln>
+          </p:spPr>
+          <p:style>
+            <a:lnRef idx="2">
+              <a:schemeClr val="dk1"/>
+            </a:lnRef>
+            <a:fillRef idx="0">
+              <a:schemeClr val="dk1"/>
+            </a:fillRef>
+            <a:effectRef idx="1">
+              <a:schemeClr val="dk1"/>
+            </a:effectRef>
+            <a:fontRef idx="minor">
+              <a:schemeClr val="tx1"/>
+            </a:fontRef>
+          </p:style>
+        </p:cxnSp>
+        <p:sp>
+          <p:nvSpPr>
+            <p:cNvPr id="9" name="Textfeld 8">
+              <a:extLst>
+                <a:ext uri="{FF2B5EF4-FFF2-40B4-BE49-F238E27FC236}">
+                  <a16:creationId xmlns:a16="http://schemas.microsoft.com/office/drawing/2014/main" id="{BAF698DC-FA0C-426C-9404-BD71C453BA1F}"/>
+                </a:ext>
+              </a:extLst>
+            </p:cNvPr>
+            <p:cNvSpPr txBox="1"/>
+            <p:nvPr/>
+          </p:nvSpPr>
+          <p:spPr>
+            <a:xfrm>
+              <a:off x="2821323" y="1913621"/>
+              <a:ext cx="295275" cy="307777"/>
+            </a:xfrm>
+            <a:prstGeom prst="rect">
+              <a:avLst/>
+            </a:prstGeom>
+            <a:noFill/>
+          </p:spPr>
+          <p:txBody>
+            <a:bodyPr wrap="square" rtlCol="0">
+              <a:spAutoFit/>
+            </a:bodyPr>
+            <a:lstStyle/>
+            <a:p>
+              <a:pPr algn="ctr"/>
+              <a:r>
+                <a:rPr lang="de-DE" sz="1400" i="1" dirty="0">
+                  <a:latin typeface="CMU Serif" panose="02000603000000000000" pitchFamily="2" charset="0"/>
+                  <a:ea typeface="CMU Serif" panose="02000603000000000000" pitchFamily="2" charset="0"/>
+                  <a:cs typeface="CMU Serif" panose="02000603000000000000" pitchFamily="2" charset="0"/>
+                </a:rPr>
+                <a:t>x</a:t>
+              </a:r>
+            </a:p>
+          </p:txBody>
+        </p:sp>
+        <p:sp>
+          <p:nvSpPr>
+            <p:cNvPr id="11" name="Textfeld 10">
+              <a:extLst>
+                <a:ext uri="{FF2B5EF4-FFF2-40B4-BE49-F238E27FC236}">
+                  <a16:creationId xmlns:a16="http://schemas.microsoft.com/office/drawing/2014/main" id="{D8AAA2D7-F45A-DB20-FFFD-04070662CF77}"/>
+                </a:ext>
+              </a:extLst>
+            </p:cNvPr>
+            <p:cNvSpPr txBox="1"/>
+            <p:nvPr/>
+          </p:nvSpPr>
+          <p:spPr>
+            <a:xfrm>
+              <a:off x="2818943" y="2101503"/>
+              <a:ext cx="295275" cy="307777"/>
+            </a:xfrm>
+            <a:prstGeom prst="rect">
+              <a:avLst/>
+            </a:prstGeom>
+            <a:noFill/>
+          </p:spPr>
+          <p:txBody>
+            <a:bodyPr wrap="square" rtlCol="0">
+              <a:spAutoFit/>
+            </a:bodyPr>
+            <a:lstStyle/>
+            <a:p>
+              <a:pPr algn="ctr"/>
+              <a:r>
+                <a:rPr lang="de-DE" sz="1400" i="1" dirty="0">
+                  <a:latin typeface="CMU Serif" panose="02000603000000000000" pitchFamily="2" charset="0"/>
+                  <a:ea typeface="CMU Serif" panose="02000603000000000000" pitchFamily="2" charset="0"/>
+                  <a:cs typeface="CMU Serif" panose="02000603000000000000" pitchFamily="2" charset="0"/>
+                </a:rPr>
+                <a:t>t</a:t>
+              </a:r>
+            </a:p>
+          </p:txBody>
+        </p:sp>
+        <p:cxnSp>
+          <p:nvCxnSpPr>
+            <p:cNvPr id="12" name="Gerader Verbinder 11">
+              <a:extLst>
+                <a:ext uri="{FF2B5EF4-FFF2-40B4-BE49-F238E27FC236}">
+                  <a16:creationId xmlns:a16="http://schemas.microsoft.com/office/drawing/2014/main" id="{331DD641-0D8D-BECA-7277-6338168DD72B}"/>
+                </a:ext>
+              </a:extLst>
+            </p:cNvPr>
+            <p:cNvCxnSpPr>
+              <a:cxnSpLocks/>
+            </p:cNvCxnSpPr>
+            <p:nvPr/>
+          </p:nvCxnSpPr>
+          <p:spPr>
+            <a:xfrm>
+              <a:off x="2961354" y="2006371"/>
+              <a:ext cx="45088" cy="0"/>
+            </a:xfrm>
+            <a:prstGeom prst="line">
+              <a:avLst/>
+            </a:prstGeom>
+            <a:ln w="6350" cap="sq">
+              <a:round/>
+            </a:ln>
+          </p:spPr>
+          <p:style>
+            <a:lnRef idx="2">
+              <a:schemeClr val="dk1"/>
+            </a:lnRef>
+            <a:fillRef idx="0">
+              <a:schemeClr val="dk1"/>
+            </a:fillRef>
+            <a:effectRef idx="1">
+              <a:schemeClr val="dk1"/>
+            </a:effectRef>
+            <a:fontRef idx="minor">
+              <a:schemeClr val="tx1"/>
+            </a:fontRef>
+          </p:style>
+        </p:cxnSp>
+      </p:grpSp>
+      <p:grpSp>
+        <p:nvGrpSpPr>
+          <p:cNvPr id="15" name="Gruppieren 14">
+            <a:extLst>
+              <a:ext uri="{FF2B5EF4-FFF2-40B4-BE49-F238E27FC236}">
+                <a16:creationId xmlns:a16="http://schemas.microsoft.com/office/drawing/2014/main" id="{645D39D7-F402-76FE-0B00-05165234E951}"/>
+              </a:ext>
+            </a:extLst>
+          </p:cNvPr>
+          <p:cNvGrpSpPr/>
+          <p:nvPr/>
+        </p:nvGrpSpPr>
+        <p:grpSpPr>
+          <a:xfrm>
+            <a:off x="749367" y="670774"/>
+            <a:ext cx="370706" cy="509527"/>
+            <a:chOff x="2794809" y="1896424"/>
+            <a:chExt cx="370706" cy="509527"/>
+          </a:xfrm>
+        </p:grpSpPr>
+        <p:cxnSp>
+          <p:nvCxnSpPr>
+            <p:cNvPr id="16" name="Gerader Verbinder 15">
+              <a:extLst>
+                <a:ext uri="{FF2B5EF4-FFF2-40B4-BE49-F238E27FC236}">
+                  <a16:creationId xmlns:a16="http://schemas.microsoft.com/office/drawing/2014/main" id="{B0408617-AFEC-0F84-FCFF-6B687B21CA0C}"/>
+                </a:ext>
+              </a:extLst>
+            </p:cNvPr>
+            <p:cNvCxnSpPr>
+              <a:cxnSpLocks/>
+            </p:cNvCxnSpPr>
+            <p:nvPr/>
+          </p:nvCxnSpPr>
+          <p:spPr>
+            <a:xfrm>
+              <a:off x="2917031" y="2152650"/>
+              <a:ext cx="134145" cy="0"/>
+            </a:xfrm>
+            <a:prstGeom prst="line">
+              <a:avLst/>
+            </a:prstGeom>
+            <a:ln w="9525" cap="rnd">
+              <a:round/>
+            </a:ln>
+          </p:spPr>
+          <p:style>
+            <a:lnRef idx="2">
+              <a:schemeClr val="dk1"/>
+            </a:lnRef>
+            <a:fillRef idx="0">
+              <a:schemeClr val="dk1"/>
+            </a:fillRef>
+            <a:effectRef idx="1">
+              <a:schemeClr val="dk1"/>
+            </a:effectRef>
+            <a:fontRef idx="minor">
+              <a:schemeClr val="tx1"/>
+            </a:fontRef>
+          </p:style>
+        </p:cxnSp>
+        <p:sp>
+          <p:nvSpPr>
+            <p:cNvPr id="17" name="Textfeld 16">
+              <a:extLst>
+                <a:ext uri="{FF2B5EF4-FFF2-40B4-BE49-F238E27FC236}">
+                  <a16:creationId xmlns:a16="http://schemas.microsoft.com/office/drawing/2014/main" id="{9BAFC275-6F8C-7B94-8ECE-02D43025F532}"/>
+                </a:ext>
+              </a:extLst>
+            </p:cNvPr>
+            <p:cNvSpPr txBox="1"/>
+            <p:nvPr/>
+          </p:nvSpPr>
+          <p:spPr>
+            <a:xfrm>
+              <a:off x="2794809" y="1896424"/>
+              <a:ext cx="370706" cy="307777"/>
+            </a:xfrm>
+            <a:prstGeom prst="rect">
+              <a:avLst/>
+            </a:prstGeom>
+            <a:noFill/>
+          </p:spPr>
+          <p:txBody>
+            <a:bodyPr wrap="square" rtlCol="0">
+              <a:spAutoFit/>
+            </a:bodyPr>
+            <a:lstStyle/>
+            <a:p>
+              <a:pPr algn="ctr"/>
+              <a:r>
+                <a:rPr lang="de-DE" sz="1400" i="1" dirty="0" err="1">
+                  <a:latin typeface="CMU Serif" panose="02000603000000000000" pitchFamily="2" charset="0"/>
+                  <a:ea typeface="CMU Serif" panose="02000603000000000000" pitchFamily="2" charset="0"/>
+                  <a:cs typeface="CMU Serif" panose="02000603000000000000" pitchFamily="2" charset="0"/>
+                </a:rPr>
+                <a:t>z</a:t>
+              </a:r>
+              <a:r>
+                <a:rPr lang="de-DE" sz="1400" i="1" baseline="-25000" dirty="0" err="1">
+                  <a:latin typeface="CMU Serif" panose="02000603000000000000" pitchFamily="2" charset="0"/>
+                  <a:ea typeface="CMU Serif" panose="02000603000000000000" pitchFamily="2" charset="0"/>
+                  <a:cs typeface="CMU Serif" panose="02000603000000000000" pitchFamily="2" charset="0"/>
+                </a:rPr>
+                <a:t>i</a:t>
+              </a:r>
+              <a:endParaRPr lang="de-DE" sz="1400" i="1" baseline="-25000" dirty="0">
+                <a:latin typeface="CMU Serif" panose="02000603000000000000" pitchFamily="2" charset="0"/>
+                <a:ea typeface="CMU Serif" panose="02000603000000000000" pitchFamily="2" charset="0"/>
+                <a:cs typeface="CMU Serif" panose="02000603000000000000" pitchFamily="2" charset="0"/>
+              </a:endParaRPr>
+            </a:p>
+          </p:txBody>
+        </p:sp>
+        <p:sp>
+          <p:nvSpPr>
+            <p:cNvPr id="18" name="Textfeld 17">
+              <a:extLst>
+                <a:ext uri="{FF2B5EF4-FFF2-40B4-BE49-F238E27FC236}">
+                  <a16:creationId xmlns:a16="http://schemas.microsoft.com/office/drawing/2014/main" id="{B4F68DF5-FCED-DD46-C21F-0FBE6EB6AD40}"/>
+                </a:ext>
+              </a:extLst>
+            </p:cNvPr>
+            <p:cNvSpPr txBox="1"/>
+            <p:nvPr/>
+          </p:nvSpPr>
+          <p:spPr>
+            <a:xfrm>
+              <a:off x="2815033" y="2098174"/>
+              <a:ext cx="295275" cy="307777"/>
+            </a:xfrm>
+            <a:prstGeom prst="rect">
+              <a:avLst/>
+            </a:prstGeom>
+            <a:noFill/>
+          </p:spPr>
+          <p:txBody>
+            <a:bodyPr wrap="square" rtlCol="0">
+              <a:spAutoFit/>
+            </a:bodyPr>
+            <a:lstStyle/>
+            <a:p>
+              <a:pPr algn="ctr"/>
+              <a:r>
+                <a:rPr lang="de-DE" sz="1400" i="1" dirty="0">
+                  <a:latin typeface="CMU Serif" panose="02000603000000000000" pitchFamily="2" charset="0"/>
+                  <a:ea typeface="CMU Serif" panose="02000603000000000000" pitchFamily="2" charset="0"/>
+                  <a:cs typeface="CMU Serif" panose="02000603000000000000" pitchFamily="2" charset="0"/>
+                </a:rPr>
+                <a:t>t</a:t>
+              </a:r>
+            </a:p>
+          </p:txBody>
+        </p:sp>
+        <p:cxnSp>
+          <p:nvCxnSpPr>
+            <p:cNvPr id="19" name="Gerader Verbinder 18">
+              <a:extLst>
+                <a:ext uri="{FF2B5EF4-FFF2-40B4-BE49-F238E27FC236}">
+                  <a16:creationId xmlns:a16="http://schemas.microsoft.com/office/drawing/2014/main" id="{AD13F007-62EA-3298-F1BD-A0D6B01C3E94}"/>
+                </a:ext>
+              </a:extLst>
+            </p:cNvPr>
+            <p:cNvCxnSpPr>
+              <a:cxnSpLocks/>
+            </p:cNvCxnSpPr>
+            <p:nvPr/>
+          </p:nvCxnSpPr>
+          <p:spPr>
+            <a:xfrm>
+              <a:off x="2961982" y="1992880"/>
+              <a:ext cx="38341" cy="0"/>
+            </a:xfrm>
+            <a:prstGeom prst="line">
+              <a:avLst/>
+            </a:prstGeom>
+            <a:ln w="6350" cap="sq">
+              <a:round/>
+            </a:ln>
+          </p:spPr>
+          <p:style>
+            <a:lnRef idx="2">
+              <a:schemeClr val="dk1"/>
+            </a:lnRef>
+            <a:fillRef idx="0">
+              <a:schemeClr val="dk1"/>
+            </a:fillRef>
+            <a:effectRef idx="1">
+              <a:schemeClr val="dk1"/>
+            </a:effectRef>
+            <a:fontRef idx="minor">
+              <a:schemeClr val="tx1"/>
+            </a:fontRef>
+          </p:style>
+        </p:cxnSp>
+      </p:grpSp>
+      <p:cxnSp>
+        <p:nvCxnSpPr>
+          <p:cNvPr id="32" name="Gerader Verbinder 31">
+            <a:extLst>
+              <a:ext uri="{FF2B5EF4-FFF2-40B4-BE49-F238E27FC236}">
+                <a16:creationId xmlns:a16="http://schemas.microsoft.com/office/drawing/2014/main" id="{CAD4F6CE-908C-CADC-4B1C-F148A3018359}"/>
+              </a:ext>
+            </a:extLst>
+          </p:cNvPr>
+          <p:cNvCxnSpPr>
+            <a:cxnSpLocks/>
+          </p:cNvCxnSpPr>
+          <p:nvPr/>
+        </p:nvCxnSpPr>
+        <p:spPr>
+          <a:xfrm>
+            <a:off x="767228" y="2510493"/>
+            <a:ext cx="2247435" cy="0"/>
+          </a:xfrm>
+          <a:prstGeom prst="line">
+            <a:avLst/>
+          </a:prstGeom>
+          <a:ln w="9525" cap="rnd">
+            <a:solidFill>
+              <a:schemeClr val="accent2">
+                <a:lumMod val="75000"/>
+              </a:schemeClr>
+            </a:solidFill>
+            <a:prstDash val="sysDash"/>
+            <a:round/>
+          </a:ln>
+        </p:spPr>
+        <p:style>
+          <a:lnRef idx="2">
+            <a:schemeClr val="accent1"/>
+          </a:lnRef>
+          <a:fillRef idx="0">
+            <a:schemeClr val="accent1"/>
+          </a:fillRef>
+          <a:effectRef idx="1">
+            <a:schemeClr val="accent1"/>
+          </a:effectRef>
+          <a:fontRef idx="minor">
+            <a:schemeClr val="tx1"/>
+          </a:fontRef>
+        </p:style>
+      </p:cxnSp>
+      <p:cxnSp>
+        <p:nvCxnSpPr>
+          <p:cNvPr id="34" name="Gerader Verbinder 33">
+            <a:extLst>
+              <a:ext uri="{FF2B5EF4-FFF2-40B4-BE49-F238E27FC236}">
+                <a16:creationId xmlns:a16="http://schemas.microsoft.com/office/drawing/2014/main" id="{8A79E886-09FA-D72B-7905-596213EBBF7B}"/>
+              </a:ext>
+            </a:extLst>
+          </p:cNvPr>
+          <p:cNvCxnSpPr>
+            <a:cxnSpLocks/>
+          </p:cNvCxnSpPr>
+          <p:nvPr/>
+        </p:nvCxnSpPr>
+        <p:spPr>
+          <a:xfrm>
+            <a:off x="738648" y="1965148"/>
+            <a:ext cx="2276013" cy="544689"/>
+          </a:xfrm>
+          <a:prstGeom prst="line">
+            <a:avLst/>
+          </a:prstGeom>
+          <a:ln w="9525" cap="rnd">
+            <a:solidFill>
+              <a:schemeClr val="accent2">
+                <a:lumMod val="75000"/>
+              </a:schemeClr>
+            </a:solidFill>
+            <a:prstDash val="sysDash"/>
+            <a:round/>
+          </a:ln>
+        </p:spPr>
+        <p:style>
+          <a:lnRef idx="2">
+            <a:schemeClr val="accent1"/>
+          </a:lnRef>
+          <a:fillRef idx="0">
+            <a:schemeClr val="accent1"/>
+          </a:fillRef>
+          <a:effectRef idx="1">
+            <a:schemeClr val="accent1"/>
+          </a:effectRef>
+          <a:fontRef idx="minor">
+            <a:schemeClr val="tx1"/>
+          </a:fontRef>
+        </p:style>
+      </p:cxnSp>
+      <p:cxnSp>
+        <p:nvCxnSpPr>
+          <p:cNvPr id="3" name="Gerade Verbindung mit Pfeil 2">
+            <a:extLst>
+              <a:ext uri="{FF2B5EF4-FFF2-40B4-BE49-F238E27FC236}">
+                <a16:creationId xmlns:a16="http://schemas.microsoft.com/office/drawing/2014/main" id="{20077038-76F6-0F2E-C7A6-C76EABDDD354}"/>
+              </a:ext>
+            </a:extLst>
+          </p:cNvPr>
+          <p:cNvCxnSpPr>
+            <a:cxnSpLocks/>
+          </p:cNvCxnSpPr>
+          <p:nvPr/>
+        </p:nvCxnSpPr>
+        <p:spPr>
+          <a:xfrm flipV="1">
+            <a:off x="738648" y="888205"/>
+            <a:ext cx="0" cy="1824039"/>
+          </a:xfrm>
+          <a:prstGeom prst="straightConnector1">
+            <a:avLst/>
+          </a:prstGeom>
+          <a:ln cap="rnd">
+            <a:round/>
+            <a:tailEnd type="triangle"/>
+          </a:ln>
+        </p:spPr>
+        <p:style>
+          <a:lnRef idx="2">
+            <a:schemeClr val="dk1"/>
+          </a:lnRef>
+          <a:fillRef idx="0">
+            <a:schemeClr val="dk1"/>
+          </a:fillRef>
+          <a:effectRef idx="1">
+            <a:schemeClr val="dk1"/>
+          </a:effectRef>
+          <a:fontRef idx="minor">
+            <a:schemeClr val="tx1"/>
+          </a:fontRef>
+        </p:style>
+      </p:cxnSp>
+      <p:cxnSp>
+        <p:nvCxnSpPr>
+          <p:cNvPr id="4" name="Gerade Verbindung mit Pfeil 3">
+            <a:extLst>
+              <a:ext uri="{FF2B5EF4-FFF2-40B4-BE49-F238E27FC236}">
+                <a16:creationId xmlns:a16="http://schemas.microsoft.com/office/drawing/2014/main" id="{D00EDF71-6A13-262B-5688-4580747AC6A5}"/>
+              </a:ext>
+            </a:extLst>
+          </p:cNvPr>
+          <p:cNvCxnSpPr>
+            <a:cxnSpLocks/>
+          </p:cNvCxnSpPr>
+          <p:nvPr/>
+        </p:nvCxnSpPr>
+        <p:spPr>
+          <a:xfrm>
+            <a:off x="738648" y="1966682"/>
+            <a:ext cx="2506536" cy="0"/>
+          </a:xfrm>
+          <a:prstGeom prst="straightConnector1">
+            <a:avLst/>
+          </a:prstGeom>
+          <a:ln cap="rnd">
+            <a:round/>
+            <a:tailEnd type="triangle"/>
+          </a:ln>
+        </p:spPr>
+        <p:style>
+          <a:lnRef idx="2">
+            <a:schemeClr val="dk1"/>
+          </a:lnRef>
+          <a:fillRef idx="0">
+            <a:schemeClr val="dk1"/>
+          </a:fillRef>
+          <a:effectRef idx="1">
+            <a:schemeClr val="dk1"/>
+          </a:effectRef>
+          <a:fontRef idx="minor">
+            <a:schemeClr val="tx1"/>
+          </a:fontRef>
+        </p:style>
+      </p:cxnSp>
+      <p:cxnSp>
+        <p:nvCxnSpPr>
+          <p:cNvPr id="35" name="Gerader Verbinder 34">
+            <a:extLst>
+              <a:ext uri="{FF2B5EF4-FFF2-40B4-BE49-F238E27FC236}">
+                <a16:creationId xmlns:a16="http://schemas.microsoft.com/office/drawing/2014/main" id="{5D821EC9-6D0A-96BA-B6EA-F80A1D9F2C33}"/>
+              </a:ext>
+            </a:extLst>
+          </p:cNvPr>
+          <p:cNvCxnSpPr>
+            <a:cxnSpLocks/>
+          </p:cNvCxnSpPr>
+          <p:nvPr/>
+        </p:nvCxnSpPr>
+        <p:spPr>
+          <a:xfrm flipV="1">
+            <a:off x="3012281" y="1909779"/>
+            <a:ext cx="0" cy="109521"/>
+          </a:xfrm>
+          <a:prstGeom prst="line">
+            <a:avLst/>
+          </a:prstGeom>
+          <a:ln w="12700" cap="rnd">
+            <a:solidFill>
+              <a:schemeClr val="tx1"/>
+            </a:solidFill>
+            <a:prstDash val="solid"/>
+            <a:round/>
+          </a:ln>
+        </p:spPr>
+        <p:style>
+          <a:lnRef idx="2">
+            <a:schemeClr val="accent1"/>
+          </a:lnRef>
+          <a:fillRef idx="0">
+            <a:schemeClr val="accent1"/>
+          </a:fillRef>
+          <a:effectRef idx="1">
+            <a:schemeClr val="accent1"/>
+          </a:effectRef>
+          <a:fontRef idx="minor">
+            <a:schemeClr val="tx1"/>
+          </a:fontRef>
+        </p:style>
+      </p:cxnSp>
+      <p:sp>
+        <p:nvSpPr>
+          <p:cNvPr id="41" name="Freihandform: Form 40">
+            <a:extLst>
+              <a:ext uri="{FF2B5EF4-FFF2-40B4-BE49-F238E27FC236}">
+                <a16:creationId xmlns:a16="http://schemas.microsoft.com/office/drawing/2014/main" id="{E8E14171-6560-FF27-1C62-146DED2131B9}"/>
+              </a:ext>
+            </a:extLst>
+          </p:cNvPr>
+          <p:cNvSpPr/>
+          <p:nvPr/>
+        </p:nvSpPr>
+        <p:spPr>
+          <a:xfrm>
+            <a:off x="741029" y="1850185"/>
+            <a:ext cx="2271251" cy="784599"/>
+          </a:xfrm>
+          <a:custGeom>
+            <a:avLst/>
+            <a:gdLst>
+              <a:gd name="csX0" fmla="*/ 0 w 2278857"/>
+              <a:gd name="csY0" fmla="*/ 145011 h 836190"/>
+              <a:gd name="csX1" fmla="*/ 504825 w 2278857"/>
+              <a:gd name="csY1" fmla="*/ 11661 h 836190"/>
+              <a:gd name="csX2" fmla="*/ 1116807 w 2278857"/>
+              <a:gd name="csY2" fmla="*/ 409330 h 836190"/>
+              <a:gd name="csX3" fmla="*/ 1671638 w 2278857"/>
+              <a:gd name="csY3" fmla="*/ 823668 h 836190"/>
+              <a:gd name="csX4" fmla="*/ 2278857 w 2278857"/>
+              <a:gd name="csY4" fmla="*/ 687936 h 836190"/>
+              <a:gd name="csX0" fmla="*/ 0 w 2278857"/>
+              <a:gd name="csY0" fmla="*/ 145011 h 836190"/>
+              <a:gd name="csX1" fmla="*/ 504825 w 2278857"/>
+              <a:gd name="csY1" fmla="*/ 11661 h 836190"/>
+              <a:gd name="csX2" fmla="*/ 1116807 w 2278857"/>
+              <a:gd name="csY2" fmla="*/ 409330 h 836190"/>
+              <a:gd name="csX3" fmla="*/ 1671638 w 2278857"/>
+              <a:gd name="csY3" fmla="*/ 823668 h 836190"/>
+              <a:gd name="csX4" fmla="*/ 2278857 w 2278857"/>
+              <a:gd name="csY4" fmla="*/ 687936 h 836190"/>
+              <a:gd name="csX0" fmla="*/ 0 w 2278857"/>
+              <a:gd name="csY0" fmla="*/ 117505 h 808684"/>
+              <a:gd name="csX1" fmla="*/ 609600 w 2278857"/>
+              <a:gd name="csY1" fmla="*/ 15112 h 808684"/>
+              <a:gd name="csX2" fmla="*/ 1116807 w 2278857"/>
+              <a:gd name="csY2" fmla="*/ 381824 h 808684"/>
+              <a:gd name="csX3" fmla="*/ 1671638 w 2278857"/>
+              <a:gd name="csY3" fmla="*/ 796162 h 808684"/>
+              <a:gd name="csX4" fmla="*/ 2278857 w 2278857"/>
+              <a:gd name="csY4" fmla="*/ 660430 h 808684"/>
+              <a:gd name="csX0" fmla="*/ 0 w 2278857"/>
+              <a:gd name="csY0" fmla="*/ 117505 h 771236"/>
+              <a:gd name="csX1" fmla="*/ 609600 w 2278857"/>
+              <a:gd name="csY1" fmla="*/ 15112 h 771236"/>
+              <a:gd name="csX2" fmla="*/ 1116807 w 2278857"/>
+              <a:gd name="csY2" fmla="*/ 381824 h 771236"/>
+              <a:gd name="csX3" fmla="*/ 1588294 w 2278857"/>
+              <a:gd name="csY3" fmla="*/ 753299 h 771236"/>
+              <a:gd name="csX4" fmla="*/ 2278857 w 2278857"/>
+              <a:gd name="csY4" fmla="*/ 660430 h 771236"/>
+              <a:gd name="csX0" fmla="*/ 0 w 2278857"/>
+              <a:gd name="csY0" fmla="*/ 117505 h 779235"/>
+              <a:gd name="csX1" fmla="*/ 609600 w 2278857"/>
+              <a:gd name="csY1" fmla="*/ 15112 h 779235"/>
+              <a:gd name="csX2" fmla="*/ 1116807 w 2278857"/>
+              <a:gd name="csY2" fmla="*/ 381824 h 779235"/>
+              <a:gd name="csX3" fmla="*/ 1624013 w 2278857"/>
+              <a:gd name="csY3" fmla="*/ 762824 h 779235"/>
+              <a:gd name="csX4" fmla="*/ 2278857 w 2278857"/>
+              <a:gd name="csY4" fmla="*/ 660430 h 779235"/>
+              <a:gd name="csX0" fmla="*/ 0 w 2278857"/>
+              <a:gd name="csY0" fmla="*/ 117505 h 785376"/>
+              <a:gd name="csX1" fmla="*/ 609600 w 2278857"/>
+              <a:gd name="csY1" fmla="*/ 15112 h 785376"/>
+              <a:gd name="csX2" fmla="*/ 1116807 w 2278857"/>
+              <a:gd name="csY2" fmla="*/ 381824 h 785376"/>
+              <a:gd name="csX3" fmla="*/ 1628775 w 2278857"/>
+              <a:gd name="csY3" fmla="*/ 769968 h 785376"/>
+              <a:gd name="csX4" fmla="*/ 2278857 w 2278857"/>
+              <a:gd name="csY4" fmla="*/ 660430 h 785376"/>
+              <a:gd name="csX0" fmla="*/ 0 w 2278857"/>
+              <a:gd name="csY0" fmla="*/ 117505 h 785376"/>
+              <a:gd name="csX1" fmla="*/ 609600 w 2278857"/>
+              <a:gd name="csY1" fmla="*/ 15112 h 785376"/>
+              <a:gd name="csX2" fmla="*/ 1116807 w 2278857"/>
+              <a:gd name="csY2" fmla="*/ 381824 h 785376"/>
+              <a:gd name="csX3" fmla="*/ 1628775 w 2278857"/>
+              <a:gd name="csY3" fmla="*/ 769968 h 785376"/>
+              <a:gd name="csX4" fmla="*/ 2278857 w 2278857"/>
+              <a:gd name="csY4" fmla="*/ 660430 h 785376"/>
+              <a:gd name="csX0" fmla="*/ 0 w 2278857"/>
+              <a:gd name="csY0" fmla="*/ 117505 h 785376"/>
+              <a:gd name="csX1" fmla="*/ 609600 w 2278857"/>
+              <a:gd name="csY1" fmla="*/ 15112 h 785376"/>
+              <a:gd name="csX2" fmla="*/ 1116807 w 2278857"/>
+              <a:gd name="csY2" fmla="*/ 381824 h 785376"/>
+              <a:gd name="csX3" fmla="*/ 1628775 w 2278857"/>
+              <a:gd name="csY3" fmla="*/ 769968 h 785376"/>
+              <a:gd name="csX4" fmla="*/ 2278857 w 2278857"/>
+              <a:gd name="csY4" fmla="*/ 660430 h 785376"/>
+              <a:gd name="csX0" fmla="*/ 0 w 2278857"/>
+              <a:gd name="csY0" fmla="*/ 117505 h 785376"/>
+              <a:gd name="csX1" fmla="*/ 609600 w 2278857"/>
+              <a:gd name="csY1" fmla="*/ 15112 h 785376"/>
+              <a:gd name="csX2" fmla="*/ 1116807 w 2278857"/>
+              <a:gd name="csY2" fmla="*/ 381824 h 785376"/>
+              <a:gd name="csX3" fmla="*/ 1628775 w 2278857"/>
+              <a:gd name="csY3" fmla="*/ 769968 h 785376"/>
+              <a:gd name="csX4" fmla="*/ 2278857 w 2278857"/>
+              <a:gd name="csY4" fmla="*/ 660430 h 785376"/>
+              <a:gd name="csX0" fmla="*/ 0 w 2278857"/>
+              <a:gd name="csY0" fmla="*/ 117505 h 785376"/>
+              <a:gd name="csX1" fmla="*/ 609600 w 2278857"/>
+              <a:gd name="csY1" fmla="*/ 15112 h 785376"/>
+              <a:gd name="csX2" fmla="*/ 1116807 w 2278857"/>
+              <a:gd name="csY2" fmla="*/ 381824 h 785376"/>
+              <a:gd name="csX3" fmla="*/ 1628775 w 2278857"/>
+              <a:gd name="csY3" fmla="*/ 769968 h 785376"/>
+              <a:gd name="csX4" fmla="*/ 2278857 w 2278857"/>
+              <a:gd name="csY4" fmla="*/ 660430 h 785376"/>
+              <a:gd name="csX0" fmla="*/ 0 w 2278857"/>
+              <a:gd name="csY0" fmla="*/ 116728 h 784599"/>
+              <a:gd name="csX1" fmla="*/ 609600 w 2278857"/>
+              <a:gd name="csY1" fmla="*/ 14335 h 784599"/>
+              <a:gd name="csX2" fmla="*/ 1116807 w 2278857"/>
+              <a:gd name="csY2" fmla="*/ 381047 h 784599"/>
+              <a:gd name="csX3" fmla="*/ 1628775 w 2278857"/>
+              <a:gd name="csY3" fmla="*/ 769191 h 784599"/>
+              <a:gd name="csX4" fmla="*/ 2278857 w 2278857"/>
+              <a:gd name="csY4" fmla="*/ 659653 h 784599"/>
+            </a:gdLst>
+            <a:ahLst/>
+            <a:cxnLst>
+              <a:cxn ang="0">
+                <a:pos x="csX0" y="csY0"/>
+              </a:cxn>
+              <a:cxn ang="0">
+                <a:pos x="csX1" y="csY1"/>
+              </a:cxn>
+              <a:cxn ang="0">
+                <a:pos x="csX2" y="csY2"/>
+              </a:cxn>
+              <a:cxn ang="0">
+                <a:pos x="csX3" y="csY3"/>
+              </a:cxn>
+              <a:cxn ang="0">
+                <a:pos x="csX4" y="csY4"/>
+              </a:cxn>
+            </a:cxnLst>
+            <a:rect l="l" t="t" r="r" b="b"/>
+            <a:pathLst>
+              <a:path w="2278857" h="784599">
+                <a:moveTo>
+                  <a:pt x="0" y="116728"/>
+                </a:moveTo>
+                <a:cubicBezTo>
+                  <a:pt x="178459" y="34376"/>
+                  <a:pt x="423466" y="-29718"/>
+                  <a:pt x="609600" y="14335"/>
+                </a:cubicBezTo>
+                <a:cubicBezTo>
+                  <a:pt x="795735" y="58388"/>
+                  <a:pt x="949325" y="202850"/>
+                  <a:pt x="1116807" y="381047"/>
+                </a:cubicBezTo>
+                <a:cubicBezTo>
+                  <a:pt x="1284289" y="559244"/>
+                  <a:pt x="1435100" y="722757"/>
+                  <a:pt x="1628775" y="769191"/>
+                </a:cubicBezTo>
+                <a:cubicBezTo>
+                  <a:pt x="1822450" y="815625"/>
+                  <a:pt x="2072085" y="750736"/>
+                  <a:pt x="2278857" y="659653"/>
+                </a:cubicBezTo>
+              </a:path>
+            </a:pathLst>
+          </a:custGeom>
+          <a:noFill/>
+          <a:ln cap="rnd">
+            <a:solidFill>
+              <a:schemeClr val="accent2">
+                <a:lumMod val="75000"/>
+              </a:schemeClr>
+            </a:solidFill>
+            <a:round/>
+          </a:ln>
+        </p:spPr>
+        <p:style>
+          <a:lnRef idx="2">
+            <a:schemeClr val="accent1">
+              <a:shade val="15000"/>
+            </a:schemeClr>
+          </a:lnRef>
+          <a:fillRef idx="1">
+            <a:schemeClr val="accent1"/>
+          </a:fillRef>
+          <a:effectRef idx="0">
+            <a:schemeClr val="accent1"/>
+          </a:effectRef>
+          <a:fontRef idx="minor">
+            <a:schemeClr val="lt1"/>
+          </a:fontRef>
+        </p:style>
+        <p:txBody>
+          <a:bodyPr rtlCol="0" anchor="ctr"/>
+          <a:lstStyle/>
+          <a:p>
+            <a:pPr algn="ctr"/>
+            <a:endParaRPr lang="de-DE" sz="1400"/>
+          </a:p>
+        </p:txBody>
+      </p:sp>
+      <p:sp>
+        <p:nvSpPr>
+          <p:cNvPr id="30" name="Freihandform: Form 29">
+            <a:extLst>
+              <a:ext uri="{FF2B5EF4-FFF2-40B4-BE49-F238E27FC236}">
+                <a16:creationId xmlns:a16="http://schemas.microsoft.com/office/drawing/2014/main" id="{37B3E4A2-869B-375B-123E-030E3259FB0C}"/>
+              </a:ext>
+            </a:extLst>
+          </p:cNvPr>
+          <p:cNvSpPr/>
+          <p:nvPr/>
+        </p:nvSpPr>
+        <p:spPr>
+          <a:xfrm>
+            <a:off x="741029" y="1495115"/>
+            <a:ext cx="2271252" cy="471950"/>
+          </a:xfrm>
+          <a:custGeom>
+            <a:avLst/>
+            <a:gdLst>
+              <a:gd name="csX0" fmla="*/ 0 w 2271252"/>
+              <a:gd name="csY0" fmla="*/ 471949 h 471949"/>
+              <a:gd name="csX1" fmla="*/ 1165123 w 2271252"/>
+              <a:gd name="csY1" fmla="*/ 1 h 471949"/>
+              <a:gd name="csX2" fmla="*/ 2271252 w 2271252"/>
+              <a:gd name="csY2" fmla="*/ 467033 h 471949"/>
+              <a:gd name="csX0" fmla="*/ 0 w 2271252"/>
+              <a:gd name="csY0" fmla="*/ 471950 h 471950"/>
+              <a:gd name="csX1" fmla="*/ 1165123 w 2271252"/>
+              <a:gd name="csY1" fmla="*/ 2 h 471950"/>
+              <a:gd name="csX2" fmla="*/ 2271252 w 2271252"/>
+              <a:gd name="csY2" fmla="*/ 467034 h 471950"/>
+              <a:gd name="csX0" fmla="*/ 0 w 2271252"/>
+              <a:gd name="csY0" fmla="*/ 471950 h 471950"/>
+              <a:gd name="csX1" fmla="*/ 1165123 w 2271252"/>
+              <a:gd name="csY1" fmla="*/ 2 h 471950"/>
+              <a:gd name="csX2" fmla="*/ 2271252 w 2271252"/>
+              <a:gd name="csY2" fmla="*/ 467034 h 471950"/>
+              <a:gd name="csX0" fmla="*/ 0 w 2271252"/>
+              <a:gd name="csY0" fmla="*/ 471950 h 471950"/>
+              <a:gd name="csX1" fmla="*/ 1138929 w 2271252"/>
+              <a:gd name="csY1" fmla="*/ 2 h 471950"/>
+              <a:gd name="csX2" fmla="*/ 2271252 w 2271252"/>
+              <a:gd name="csY2" fmla="*/ 467034 h 471950"/>
+              <a:gd name="csX0" fmla="*/ 0 w 2271252"/>
+              <a:gd name="csY0" fmla="*/ 471950 h 471950"/>
+              <a:gd name="csX1" fmla="*/ 1127023 w 2271252"/>
+              <a:gd name="csY1" fmla="*/ 2 h 471950"/>
+              <a:gd name="csX2" fmla="*/ 2271252 w 2271252"/>
+              <a:gd name="csY2" fmla="*/ 467034 h 471950"/>
+              <a:gd name="csX0" fmla="*/ 0 w 2271252"/>
+              <a:gd name="csY0" fmla="*/ 471950 h 471950"/>
+              <a:gd name="csX1" fmla="*/ 1127023 w 2271252"/>
+              <a:gd name="csY1" fmla="*/ 2 h 471950"/>
+              <a:gd name="csX2" fmla="*/ 2271252 w 2271252"/>
+              <a:gd name="csY2" fmla="*/ 467034 h 471950"/>
+            </a:gdLst>
+            <a:ahLst/>
+            <a:cxnLst>
+              <a:cxn ang="0">
+                <a:pos x="csX0" y="csY0"/>
+              </a:cxn>
+              <a:cxn ang="0">
+                <a:pos x="csX1" y="csY1"/>
+              </a:cxn>
+              <a:cxn ang="0">
+                <a:pos x="csX2" y="csY2"/>
+              </a:cxn>
+            </a:cxnLst>
+            <a:rect l="l" t="t" r="r" b="b"/>
+            <a:pathLst>
+              <a:path w="2271252" h="471950">
+                <a:moveTo>
+                  <a:pt x="0" y="471950"/>
+                </a:moveTo>
+                <a:cubicBezTo>
+                  <a:pt x="255177" y="236385"/>
+                  <a:pt x="598463" y="821"/>
+                  <a:pt x="1127023" y="2"/>
+                </a:cubicBezTo>
+                <a:cubicBezTo>
+                  <a:pt x="1655583" y="-817"/>
+                  <a:pt x="2020017" y="244451"/>
+                  <a:pt x="2271252" y="467034"/>
+                </a:cubicBezTo>
+              </a:path>
+            </a:pathLst>
+          </a:custGeom>
+          <a:noFill/>
+          <a:ln cap="rnd">
+            <a:solidFill>
+              <a:schemeClr val="accent6">
+                <a:lumMod val="75000"/>
+              </a:schemeClr>
+            </a:solidFill>
+            <a:round/>
+          </a:ln>
+        </p:spPr>
+        <p:style>
+          <a:lnRef idx="2">
+            <a:schemeClr val="accent1">
+              <a:shade val="15000"/>
+            </a:schemeClr>
+          </a:lnRef>
+          <a:fillRef idx="1">
+            <a:schemeClr val="accent1"/>
+          </a:fillRef>
+          <a:effectRef idx="0">
+            <a:schemeClr val="accent1"/>
+          </a:effectRef>
+          <a:fontRef idx="minor">
+            <a:schemeClr val="lt1"/>
+          </a:fontRef>
+        </p:style>
+        <p:txBody>
+          <a:bodyPr rtlCol="0" anchor="ctr"/>
+          <a:lstStyle/>
+          <a:p>
+            <a:pPr algn="ctr"/>
+            <a:endParaRPr lang="de-DE" sz="1400" dirty="0"/>
+          </a:p>
+        </p:txBody>
+      </p:sp>
+      <p:cxnSp>
+        <p:nvCxnSpPr>
+          <p:cNvPr id="26" name="Gerader Verbinder 25">
+            <a:extLst>
+              <a:ext uri="{FF2B5EF4-FFF2-40B4-BE49-F238E27FC236}">
+                <a16:creationId xmlns:a16="http://schemas.microsoft.com/office/drawing/2014/main" id="{EE292886-2442-A765-7EEC-271C7E80AC9A}"/>
+              </a:ext>
+            </a:extLst>
+          </p:cNvPr>
+          <p:cNvCxnSpPr>
+            <a:cxnSpLocks/>
+          </p:cNvCxnSpPr>
+          <p:nvPr/>
+        </p:nvCxnSpPr>
+        <p:spPr>
+          <a:xfrm>
+            <a:off x="741029" y="1307306"/>
+            <a:ext cx="2273787" cy="657842"/>
+          </a:xfrm>
+          <a:prstGeom prst="line">
+            <a:avLst/>
+          </a:prstGeom>
+          <a:ln cap="rnd">
+            <a:solidFill>
+              <a:schemeClr val="tx2">
+                <a:lumMod val="75000"/>
+                <a:lumOff val="25000"/>
+              </a:schemeClr>
+            </a:solidFill>
+            <a:round/>
+          </a:ln>
+        </p:spPr>
+        <p:style>
+          <a:lnRef idx="2">
+            <a:schemeClr val="accent1"/>
+          </a:lnRef>
+          <a:fillRef idx="0">
+            <a:schemeClr val="accent1"/>
+          </a:fillRef>
+          <a:effectRef idx="1">
+            <a:schemeClr val="accent1"/>
+          </a:effectRef>
+          <a:fontRef idx="minor">
+            <a:schemeClr val="tx1"/>
+          </a:fontRef>
+        </p:style>
+      </p:cxnSp>
+      <p:sp>
+        <p:nvSpPr>
+          <p:cNvPr id="47" name="Textfeld 46">
+            <a:extLst>
+              <a:ext uri="{FF2B5EF4-FFF2-40B4-BE49-F238E27FC236}">
+                <a16:creationId xmlns:a16="http://schemas.microsoft.com/office/drawing/2014/main" id="{6EA20DC9-08D9-7982-4B05-219673E02F94}"/>
+              </a:ext>
+            </a:extLst>
+          </p:cNvPr>
+          <p:cNvSpPr txBox="1"/>
+          <p:nvPr/>
+        </p:nvSpPr>
+        <p:spPr>
+          <a:xfrm>
+            <a:off x="2866827" y="2005322"/>
+            <a:ext cx="295275" cy="307777"/>
+          </a:xfrm>
+          <a:prstGeom prst="rect">
+            <a:avLst/>
+          </a:prstGeom>
+          <a:noFill/>
+        </p:spPr>
+        <p:txBody>
+          <a:bodyPr wrap="square" rtlCol="0">
+            <a:spAutoFit/>
+          </a:bodyPr>
+          <a:lstStyle/>
+          <a:p>
+            <a:pPr algn="ctr"/>
+            <a:r>
+              <a:rPr lang="de-DE" sz="1400" dirty="0">
+                <a:latin typeface="CMU Serif" panose="02000603000000000000" pitchFamily="2" charset="0"/>
+                <a:ea typeface="CMU Serif" panose="02000603000000000000" pitchFamily="2" charset="0"/>
+                <a:cs typeface="CMU Serif" panose="02000603000000000000" pitchFamily="2" charset="0"/>
+              </a:rPr>
+              <a:t>1</a:t>
+            </a:r>
+          </a:p>
+        </p:txBody>
+      </p:sp>
+      <p:sp>
+        <p:nvSpPr>
+          <p:cNvPr id="56" name="Textfeld 55">
+            <a:extLst>
+              <a:ext uri="{FF2B5EF4-FFF2-40B4-BE49-F238E27FC236}">
+                <a16:creationId xmlns:a16="http://schemas.microsoft.com/office/drawing/2014/main" id="{B97206D2-138F-0735-FDD0-784B0AB88B32}"/>
+              </a:ext>
+            </a:extLst>
+          </p:cNvPr>
+          <p:cNvSpPr txBox="1"/>
+          <p:nvPr/>
+        </p:nvSpPr>
+        <p:spPr>
+          <a:xfrm>
+            <a:off x="-179360" y="1126519"/>
+            <a:ext cx="1165694" cy="261610"/>
+          </a:xfrm>
+          <a:prstGeom prst="rect">
+            <a:avLst/>
+          </a:prstGeom>
+          <a:noFill/>
+        </p:spPr>
+        <p:txBody>
+          <a:bodyPr wrap="square" rtlCol="0">
+            <a:spAutoFit/>
+          </a:bodyPr>
+          <a:lstStyle/>
+          <a:p>
+            <a:pPr algn="ctr"/>
+            <a:r>
+              <a:rPr lang="de-DE" sz="1100" i="1" dirty="0">
+                <a:solidFill>
+                  <a:schemeClr val="tx2">
+                    <a:lumMod val="75000"/>
+                    <a:lumOff val="25000"/>
+                  </a:schemeClr>
+                </a:solidFill>
+                <a:latin typeface="CMU Serif" panose="02000603000000000000" pitchFamily="2" charset="0"/>
+                <a:ea typeface="CMU Serif" panose="02000603000000000000" pitchFamily="2" charset="0"/>
+                <a:cs typeface="CMU Serif" panose="02000603000000000000" pitchFamily="2" charset="0"/>
+              </a:rPr>
+              <a:t>A</a:t>
+            </a:r>
+            <a:r>
+              <a:rPr lang="de-DE" sz="1100" baseline="-25000" dirty="0">
+                <a:solidFill>
+                  <a:schemeClr val="tx2">
+                    <a:lumMod val="75000"/>
+                    <a:lumOff val="25000"/>
+                  </a:schemeClr>
+                </a:solidFill>
+                <a:latin typeface="CMU Serif" panose="02000603000000000000" pitchFamily="2" charset="0"/>
+                <a:ea typeface="CMU Serif" panose="02000603000000000000" pitchFamily="2" charset="0"/>
+                <a:cs typeface="CMU Serif" panose="02000603000000000000" pitchFamily="2" charset="0"/>
+              </a:rPr>
+              <a:t>0 </a:t>
+            </a:r>
+            <a:r>
+              <a:rPr lang="de-DE" sz="1100" dirty="0">
+                <a:solidFill>
+                  <a:schemeClr val="tx2">
+                    <a:lumMod val="75000"/>
+                    <a:lumOff val="25000"/>
+                  </a:schemeClr>
+                </a:solidFill>
+                <a:latin typeface="CMU Serif" panose="02000603000000000000" pitchFamily="2" charset="0"/>
+                <a:ea typeface="CMU Serif" panose="02000603000000000000" pitchFamily="2" charset="0"/>
+                <a:cs typeface="CMU Serif" panose="02000603000000000000" pitchFamily="2" charset="0"/>
+              </a:rPr>
+              <a:t>− </a:t>
+            </a:r>
+            <a:r>
+              <a:rPr lang="de-DE" sz="1100" i="1" dirty="0">
+                <a:solidFill>
+                  <a:schemeClr val="tx2">
+                    <a:lumMod val="75000"/>
+                    <a:lumOff val="25000"/>
+                  </a:schemeClr>
+                </a:solidFill>
+                <a:latin typeface="Latin Modern Math" panose="02000503000000000000" pitchFamily="50" charset="0"/>
+                <a:ea typeface="Latin Modern Math" panose="02000503000000000000" pitchFamily="50" charset="0"/>
+                <a:cs typeface="CMU Serif" panose="02000603000000000000" pitchFamily="2" charset="0"/>
+              </a:rPr>
+              <a:t>α</a:t>
+            </a:r>
+            <a:r>
+              <a:rPr lang="de-DE" sz="1100" dirty="0">
+                <a:solidFill>
+                  <a:schemeClr val="tx2">
+                    <a:lumMod val="75000"/>
+                    <a:lumOff val="25000"/>
+                  </a:schemeClr>
+                </a:solidFill>
+                <a:latin typeface="CMU Serif" panose="02000603000000000000" pitchFamily="2" charset="0"/>
+                <a:ea typeface="CMU Serif" panose="02000603000000000000" pitchFamily="2" charset="0"/>
+                <a:cs typeface="CMU Serif" panose="02000603000000000000" pitchFamily="2" charset="0"/>
+              </a:rPr>
+              <a:t>*</a:t>
+            </a:r>
+          </a:p>
+        </p:txBody>
+      </p:sp>
+      <p:grpSp>
+        <p:nvGrpSpPr>
+          <p:cNvPr id="63" name="Gruppieren 62">
+            <a:extLst>
+              <a:ext uri="{FF2B5EF4-FFF2-40B4-BE49-F238E27FC236}">
+                <a16:creationId xmlns:a16="http://schemas.microsoft.com/office/drawing/2014/main" id="{713D471E-01EB-A78C-F933-16E1D979DFCF}"/>
+              </a:ext>
+            </a:extLst>
+          </p:cNvPr>
+          <p:cNvGrpSpPr/>
+          <p:nvPr/>
+        </p:nvGrpSpPr>
+        <p:grpSpPr>
+          <a:xfrm>
+            <a:off x="324341" y="1292925"/>
+            <a:ext cx="361102" cy="459140"/>
+            <a:chOff x="250934" y="1346504"/>
+            <a:chExt cx="361102" cy="459140"/>
+          </a:xfrm>
+        </p:grpSpPr>
+        <p:sp>
+          <p:nvSpPr>
+            <p:cNvPr id="58" name="Textfeld 57">
+              <a:extLst>
+                <a:ext uri="{FF2B5EF4-FFF2-40B4-BE49-F238E27FC236}">
+                  <a16:creationId xmlns:a16="http://schemas.microsoft.com/office/drawing/2014/main" id="{DD556F77-DA42-9F3D-49CD-28518B720246}"/>
+                </a:ext>
+              </a:extLst>
+            </p:cNvPr>
+            <p:cNvSpPr txBox="1"/>
+            <p:nvPr/>
+          </p:nvSpPr>
+          <p:spPr>
+            <a:xfrm>
+              <a:off x="251088" y="1346504"/>
+              <a:ext cx="360948" cy="261610"/>
+            </a:xfrm>
+            <a:prstGeom prst="rect">
+              <a:avLst/>
+            </a:prstGeom>
+            <a:noFill/>
+          </p:spPr>
+          <p:txBody>
+            <a:bodyPr wrap="square" rtlCol="0">
+              <a:spAutoFit/>
+            </a:bodyPr>
+            <a:lstStyle/>
+            <a:p>
+              <a:pPr algn="ctr"/>
+              <a:r>
+                <a:rPr lang="de-DE" sz="1100" i="1" dirty="0">
+                  <a:solidFill>
+                    <a:schemeClr val="accent6">
+                      <a:lumMod val="75000"/>
+                    </a:schemeClr>
+                  </a:solidFill>
+                  <a:latin typeface="CMU Serif" panose="02000603000000000000" pitchFamily="2" charset="0"/>
+                  <a:ea typeface="CMU Serif" panose="02000603000000000000" pitchFamily="2" charset="0"/>
+                  <a:cs typeface="CMU Serif" panose="02000603000000000000" pitchFamily="2" charset="0"/>
+                </a:rPr>
+                <a:t>A</a:t>
+              </a:r>
+              <a:r>
+                <a:rPr lang="de-DE" sz="1100" baseline="-25000" dirty="0">
+                  <a:solidFill>
+                    <a:schemeClr val="accent6">
+                      <a:lumMod val="75000"/>
+                    </a:schemeClr>
+                  </a:solidFill>
+                  <a:latin typeface="CMU Serif" panose="02000603000000000000" pitchFamily="2" charset="0"/>
+                  <a:ea typeface="CMU Serif" panose="02000603000000000000" pitchFamily="2" charset="0"/>
+                  <a:cs typeface="CMU Serif" panose="02000603000000000000" pitchFamily="2" charset="0"/>
+                </a:rPr>
+                <a:t>1</a:t>
+              </a:r>
+              <a:endParaRPr lang="de-DE" sz="1100" dirty="0">
+                <a:solidFill>
+                  <a:schemeClr val="accent6">
+                    <a:lumMod val="75000"/>
+                  </a:schemeClr>
+                </a:solidFill>
+                <a:latin typeface="CMU Serif" panose="02000603000000000000" pitchFamily="2" charset="0"/>
+                <a:ea typeface="CMU Serif" panose="02000603000000000000" pitchFamily="2" charset="0"/>
+                <a:cs typeface="CMU Serif" panose="02000603000000000000" pitchFamily="2" charset="0"/>
+              </a:endParaRPr>
+            </a:p>
+          </p:txBody>
+        </p:sp>
+        <p:sp>
+          <p:nvSpPr>
+            <p:cNvPr id="60" name="Textfeld 59">
+              <a:extLst>
+                <a:ext uri="{FF2B5EF4-FFF2-40B4-BE49-F238E27FC236}">
+                  <a16:creationId xmlns:a16="http://schemas.microsoft.com/office/drawing/2014/main" id="{10122D72-9D41-5FF4-F7EB-884CDA4A41B2}"/>
+                </a:ext>
+              </a:extLst>
+            </p:cNvPr>
+            <p:cNvSpPr txBox="1"/>
+            <p:nvPr/>
+          </p:nvSpPr>
+          <p:spPr>
+            <a:xfrm>
+              <a:off x="250934" y="1544034"/>
+              <a:ext cx="360948" cy="261610"/>
+            </a:xfrm>
+            <a:prstGeom prst="rect">
+              <a:avLst/>
+            </a:prstGeom>
+            <a:noFill/>
+          </p:spPr>
+          <p:txBody>
+            <a:bodyPr wrap="square" rtlCol="0">
+              <a:spAutoFit/>
+            </a:bodyPr>
+            <a:lstStyle/>
+            <a:p>
+              <a:pPr algn="ctr"/>
+              <a:r>
+                <a:rPr lang="de-DE" sz="1100" dirty="0">
+                  <a:solidFill>
+                    <a:schemeClr val="accent6">
+                      <a:lumMod val="75000"/>
+                    </a:schemeClr>
+                  </a:solidFill>
+                  <a:latin typeface="CMU Serif" panose="02000603000000000000" pitchFamily="2" charset="0"/>
+                  <a:ea typeface="CMU Serif" panose="02000603000000000000" pitchFamily="2" charset="0"/>
+                  <a:cs typeface="CMU Serif" panose="02000603000000000000" pitchFamily="2" charset="0"/>
+                </a:rPr>
+                <a:t>4</a:t>
+              </a:r>
+            </a:p>
+          </p:txBody>
+        </p:sp>
+        <p:cxnSp>
+          <p:nvCxnSpPr>
+            <p:cNvPr id="61" name="Gerader Verbinder 60">
+              <a:extLst>
+                <a:ext uri="{FF2B5EF4-FFF2-40B4-BE49-F238E27FC236}">
+                  <a16:creationId xmlns:a16="http://schemas.microsoft.com/office/drawing/2014/main" id="{7D380A19-5FD4-7BA4-762A-6D4671E438A2}"/>
+                </a:ext>
+              </a:extLst>
+            </p:cNvPr>
+            <p:cNvCxnSpPr>
+              <a:cxnSpLocks/>
+            </p:cNvCxnSpPr>
+            <p:nvPr/>
+          </p:nvCxnSpPr>
+          <p:spPr>
+            <a:xfrm>
+              <a:off x="345603" y="1572093"/>
+              <a:ext cx="173510" cy="0"/>
+            </a:xfrm>
+            <a:prstGeom prst="line">
+              <a:avLst/>
+            </a:prstGeom>
+            <a:ln w="9525" cap="rnd">
+              <a:solidFill>
+                <a:schemeClr val="accent6">
+                  <a:lumMod val="75000"/>
+                </a:schemeClr>
+              </a:solidFill>
+              <a:round/>
+            </a:ln>
+          </p:spPr>
+          <p:style>
+            <a:lnRef idx="2">
+              <a:schemeClr val="dk1"/>
+            </a:lnRef>
+            <a:fillRef idx="0">
+              <a:schemeClr val="dk1"/>
+            </a:fillRef>
+            <a:effectRef idx="1">
+              <a:schemeClr val="dk1"/>
+            </a:effectRef>
+            <a:fontRef idx="minor">
+              <a:schemeClr val="tx1"/>
+            </a:fontRef>
+          </p:style>
+        </p:cxnSp>
+      </p:grpSp>
+      <p:cxnSp>
+        <p:nvCxnSpPr>
+          <p:cNvPr id="64" name="Gerader Verbinder 63">
+            <a:extLst>
+              <a:ext uri="{FF2B5EF4-FFF2-40B4-BE49-F238E27FC236}">
+                <a16:creationId xmlns:a16="http://schemas.microsoft.com/office/drawing/2014/main" id="{C5DF7631-2738-394C-17AB-80FDE6E4101C}"/>
+              </a:ext>
+            </a:extLst>
+          </p:cNvPr>
+          <p:cNvCxnSpPr>
+            <a:cxnSpLocks/>
+          </p:cNvCxnSpPr>
+          <p:nvPr/>
+        </p:nvCxnSpPr>
+        <p:spPr>
+          <a:xfrm>
+            <a:off x="678924" y="1493701"/>
+            <a:ext cx="114686" cy="0"/>
+          </a:xfrm>
+          <a:prstGeom prst="line">
+            <a:avLst/>
+          </a:prstGeom>
+          <a:ln w="19050" cap="rnd">
+            <a:solidFill>
+              <a:schemeClr val="accent6">
+                <a:lumMod val="75000"/>
+              </a:schemeClr>
+            </a:solidFill>
+            <a:prstDash val="solid"/>
+            <a:round/>
+          </a:ln>
+        </p:spPr>
+        <p:style>
+          <a:lnRef idx="2">
+            <a:schemeClr val="accent1"/>
+          </a:lnRef>
+          <a:fillRef idx="0">
+            <a:schemeClr val="accent1"/>
+          </a:fillRef>
+          <a:effectRef idx="1">
+            <a:schemeClr val="accent1"/>
+          </a:effectRef>
+          <a:fontRef idx="minor">
+            <a:schemeClr val="tx1"/>
+          </a:fontRef>
+        </p:style>
+      </p:cxnSp>
+      <p:cxnSp>
+        <p:nvCxnSpPr>
+          <p:cNvPr id="66" name="Gerader Verbinder 65">
+            <a:extLst>
+              <a:ext uri="{FF2B5EF4-FFF2-40B4-BE49-F238E27FC236}">
+                <a16:creationId xmlns:a16="http://schemas.microsoft.com/office/drawing/2014/main" id="{108AE4B0-CEF5-85F8-D472-A742D53A551C}"/>
+              </a:ext>
+            </a:extLst>
+          </p:cNvPr>
+          <p:cNvCxnSpPr>
+            <a:cxnSpLocks/>
+          </p:cNvCxnSpPr>
+          <p:nvPr/>
+        </p:nvCxnSpPr>
+        <p:spPr>
+          <a:xfrm>
+            <a:off x="678924" y="1310344"/>
+            <a:ext cx="114686" cy="0"/>
+          </a:xfrm>
+          <a:prstGeom prst="line">
+            <a:avLst/>
+          </a:prstGeom>
+          <a:ln w="19050" cap="rnd">
+            <a:solidFill>
+              <a:schemeClr val="tx2">
+                <a:lumMod val="75000"/>
+                <a:lumOff val="25000"/>
+              </a:schemeClr>
+            </a:solidFill>
+            <a:prstDash val="solid"/>
+            <a:round/>
+          </a:ln>
+        </p:spPr>
+        <p:style>
+          <a:lnRef idx="2">
+            <a:schemeClr val="accent1"/>
+          </a:lnRef>
+          <a:fillRef idx="0">
+            <a:schemeClr val="accent1"/>
+          </a:fillRef>
+          <a:effectRef idx="1">
+            <a:schemeClr val="accent1"/>
+          </a:effectRef>
+          <a:fontRef idx="minor">
+            <a:schemeClr val="tx1"/>
+          </a:fontRef>
+        </p:style>
+      </p:cxnSp>
+      <p:grpSp>
+        <p:nvGrpSpPr>
+          <p:cNvPr id="68" name="Gruppieren 67">
+            <a:extLst>
+              <a:ext uri="{FF2B5EF4-FFF2-40B4-BE49-F238E27FC236}">
+                <a16:creationId xmlns:a16="http://schemas.microsoft.com/office/drawing/2014/main" id="{96A71507-2FF4-ADBE-C89A-F449215E80F7}"/>
+              </a:ext>
+            </a:extLst>
+          </p:cNvPr>
+          <p:cNvGrpSpPr/>
+          <p:nvPr/>
+        </p:nvGrpSpPr>
+        <p:grpSpPr>
+          <a:xfrm>
+            <a:off x="347684" y="2348920"/>
+            <a:ext cx="361102" cy="459140"/>
+            <a:chOff x="250934" y="1346504"/>
+            <a:chExt cx="361102" cy="459140"/>
+          </a:xfrm>
+        </p:grpSpPr>
+        <p:sp>
+          <p:nvSpPr>
+            <p:cNvPr id="69" name="Textfeld 68">
+              <a:extLst>
+                <a:ext uri="{FF2B5EF4-FFF2-40B4-BE49-F238E27FC236}">
+                  <a16:creationId xmlns:a16="http://schemas.microsoft.com/office/drawing/2014/main" id="{D7D69520-2A8A-B1F5-2450-7E3FA2DB0719}"/>
+                </a:ext>
+              </a:extLst>
+            </p:cNvPr>
+            <p:cNvSpPr txBox="1"/>
+            <p:nvPr/>
+          </p:nvSpPr>
+          <p:spPr>
+            <a:xfrm>
+              <a:off x="251088" y="1346504"/>
+              <a:ext cx="360948" cy="261610"/>
+            </a:xfrm>
+            <a:prstGeom prst="rect">
+              <a:avLst/>
+            </a:prstGeom>
+            <a:noFill/>
+          </p:spPr>
+          <p:txBody>
+            <a:bodyPr wrap="square" rtlCol="0">
+              <a:spAutoFit/>
+            </a:bodyPr>
+            <a:lstStyle/>
+            <a:p>
+              <a:pPr algn="ctr"/>
+              <a:r>
+                <a:rPr lang="de-DE" sz="1100" i="1" dirty="0">
+                  <a:solidFill>
+                    <a:schemeClr val="accent2">
+                      <a:lumMod val="75000"/>
+                    </a:schemeClr>
+                  </a:solidFill>
+                  <a:latin typeface="CMU Serif" panose="02000603000000000000" pitchFamily="2" charset="0"/>
+                  <a:ea typeface="CMU Serif" panose="02000603000000000000" pitchFamily="2" charset="0"/>
+                  <a:cs typeface="CMU Serif" panose="02000603000000000000" pitchFamily="2" charset="0"/>
+                </a:rPr>
+                <a:t>A</a:t>
+              </a:r>
+              <a:r>
+                <a:rPr lang="de-DE" sz="1100" baseline="-25000" dirty="0">
+                  <a:solidFill>
+                    <a:schemeClr val="accent2">
+                      <a:lumMod val="75000"/>
+                    </a:schemeClr>
+                  </a:solidFill>
+                  <a:latin typeface="CMU Serif" panose="02000603000000000000" pitchFamily="2" charset="0"/>
+                  <a:ea typeface="CMU Serif" panose="02000603000000000000" pitchFamily="2" charset="0"/>
+                  <a:cs typeface="CMU Serif" panose="02000603000000000000" pitchFamily="2" charset="0"/>
+                </a:rPr>
+                <a:t>2</a:t>
+              </a:r>
+              <a:endParaRPr lang="de-DE" sz="1100" dirty="0">
+                <a:solidFill>
+                  <a:schemeClr val="accent2">
+                    <a:lumMod val="75000"/>
+                  </a:schemeClr>
+                </a:solidFill>
+                <a:latin typeface="CMU Serif" panose="02000603000000000000" pitchFamily="2" charset="0"/>
+                <a:ea typeface="CMU Serif" panose="02000603000000000000" pitchFamily="2" charset="0"/>
+                <a:cs typeface="CMU Serif" panose="02000603000000000000" pitchFamily="2" charset="0"/>
+              </a:endParaRPr>
+            </a:p>
+          </p:txBody>
+        </p:sp>
+        <p:sp>
+          <p:nvSpPr>
+            <p:cNvPr id="70" name="Textfeld 69">
+              <a:extLst>
+                <a:ext uri="{FF2B5EF4-FFF2-40B4-BE49-F238E27FC236}">
+                  <a16:creationId xmlns:a16="http://schemas.microsoft.com/office/drawing/2014/main" id="{A1FE0EEB-CE4A-6344-9878-73C30C0072D7}"/>
+                </a:ext>
+              </a:extLst>
+            </p:cNvPr>
+            <p:cNvSpPr txBox="1"/>
+            <p:nvPr/>
+          </p:nvSpPr>
+          <p:spPr>
+            <a:xfrm>
+              <a:off x="250934" y="1544034"/>
+              <a:ext cx="360948" cy="261610"/>
+            </a:xfrm>
+            <a:prstGeom prst="rect">
+              <a:avLst/>
+            </a:prstGeom>
+            <a:noFill/>
+          </p:spPr>
+          <p:txBody>
+            <a:bodyPr wrap="square" rtlCol="0">
+              <a:spAutoFit/>
+            </a:bodyPr>
+            <a:lstStyle/>
+            <a:p>
+              <a:pPr algn="ctr"/>
+              <a:r>
+                <a:rPr lang="de-DE" sz="1100" dirty="0">
+                  <a:solidFill>
+                    <a:schemeClr val="accent2">
+                      <a:lumMod val="75000"/>
+                    </a:schemeClr>
+                  </a:solidFill>
+                  <a:latin typeface="CMU Serif" panose="02000603000000000000" pitchFamily="2" charset="0"/>
+                  <a:ea typeface="CMU Serif" panose="02000603000000000000" pitchFamily="2" charset="0"/>
+                  <a:cs typeface="CMU Serif" panose="02000603000000000000" pitchFamily="2" charset="0"/>
+                </a:rPr>
+                <a:t>3</a:t>
+              </a:r>
+            </a:p>
+          </p:txBody>
+        </p:sp>
+        <p:cxnSp>
+          <p:nvCxnSpPr>
+            <p:cNvPr id="71" name="Gerader Verbinder 70">
+              <a:extLst>
+                <a:ext uri="{FF2B5EF4-FFF2-40B4-BE49-F238E27FC236}">
+                  <a16:creationId xmlns:a16="http://schemas.microsoft.com/office/drawing/2014/main" id="{339AEEE7-F688-7EFF-EB85-76378834C9B0}"/>
+                </a:ext>
+              </a:extLst>
+            </p:cNvPr>
+            <p:cNvCxnSpPr>
+              <a:cxnSpLocks/>
+            </p:cNvCxnSpPr>
+            <p:nvPr/>
+          </p:nvCxnSpPr>
+          <p:spPr>
+            <a:xfrm>
+              <a:off x="345603" y="1572093"/>
+              <a:ext cx="173510" cy="0"/>
+            </a:xfrm>
+            <a:prstGeom prst="line">
+              <a:avLst/>
+            </a:prstGeom>
+            <a:ln w="9525" cap="rnd">
+              <a:solidFill>
+                <a:schemeClr val="accent2">
+                  <a:lumMod val="75000"/>
+                </a:schemeClr>
+              </a:solidFill>
+              <a:round/>
+            </a:ln>
+          </p:spPr>
+          <p:style>
+            <a:lnRef idx="2">
+              <a:schemeClr val="dk1"/>
+            </a:lnRef>
+            <a:fillRef idx="0">
+              <a:schemeClr val="dk1"/>
+            </a:fillRef>
+            <a:effectRef idx="1">
+              <a:schemeClr val="dk1"/>
+            </a:effectRef>
+            <a:fontRef idx="minor">
+              <a:schemeClr val="tx1"/>
+            </a:fontRef>
+          </p:style>
+        </p:cxnSp>
+      </p:grpSp>
+      <p:cxnSp>
+        <p:nvCxnSpPr>
+          <p:cNvPr id="72" name="Gerader Verbinder 71">
+            <a:extLst>
+              <a:ext uri="{FF2B5EF4-FFF2-40B4-BE49-F238E27FC236}">
+                <a16:creationId xmlns:a16="http://schemas.microsoft.com/office/drawing/2014/main" id="{B917696B-0EED-EC17-47AD-B14488BDBB2C}"/>
+              </a:ext>
+            </a:extLst>
+          </p:cNvPr>
+          <p:cNvCxnSpPr>
+            <a:cxnSpLocks/>
+          </p:cNvCxnSpPr>
+          <p:nvPr/>
+        </p:nvCxnSpPr>
+        <p:spPr>
+          <a:xfrm>
+            <a:off x="678924" y="2509837"/>
+            <a:ext cx="114686" cy="0"/>
+          </a:xfrm>
+          <a:prstGeom prst="line">
+            <a:avLst/>
+          </a:prstGeom>
+          <a:ln w="19050" cap="rnd">
+            <a:solidFill>
+              <a:schemeClr val="accent2">
+                <a:lumMod val="75000"/>
+              </a:schemeClr>
+            </a:solidFill>
+            <a:prstDash val="solid"/>
+            <a:round/>
+          </a:ln>
+        </p:spPr>
+        <p:style>
+          <a:lnRef idx="2">
+            <a:schemeClr val="accent1"/>
+          </a:lnRef>
+          <a:fillRef idx="0">
+            <a:schemeClr val="accent1"/>
+          </a:fillRef>
+          <a:effectRef idx="1">
+            <a:schemeClr val="accent1"/>
+          </a:effectRef>
+          <a:fontRef idx="minor">
+            <a:schemeClr val="tx1"/>
+          </a:fontRef>
+        </p:style>
+      </p:cxnSp>
+      <p:cxnSp>
+        <p:nvCxnSpPr>
+          <p:cNvPr id="74" name="Gerade Verbindung mit Pfeil 73">
+            <a:extLst>
+              <a:ext uri="{FF2B5EF4-FFF2-40B4-BE49-F238E27FC236}">
+                <a16:creationId xmlns:a16="http://schemas.microsoft.com/office/drawing/2014/main" id="{B312C4DE-8640-0F6F-29C9-690DCD651DBA}"/>
+              </a:ext>
+            </a:extLst>
+          </p:cNvPr>
+          <p:cNvCxnSpPr>
+            <a:cxnSpLocks/>
+          </p:cNvCxnSpPr>
+          <p:nvPr/>
+        </p:nvCxnSpPr>
+        <p:spPr>
+          <a:xfrm>
+            <a:off x="281892" y="1964539"/>
+            <a:ext cx="321008" cy="0"/>
+          </a:xfrm>
+          <a:prstGeom prst="straightConnector1">
+            <a:avLst/>
+          </a:prstGeom>
+          <a:ln w="12700" cap="rnd">
+            <a:round/>
+            <a:tailEnd type="triangle"/>
+          </a:ln>
+        </p:spPr>
+        <p:style>
+          <a:lnRef idx="2">
+            <a:schemeClr val="dk1"/>
+          </a:lnRef>
+          <a:fillRef idx="0">
+            <a:schemeClr val="dk1"/>
+          </a:fillRef>
+          <a:effectRef idx="1">
+            <a:schemeClr val="dk1"/>
+          </a:effectRef>
+          <a:fontRef idx="minor">
+            <a:schemeClr val="tx1"/>
+          </a:fontRef>
+        </p:style>
+      </p:cxnSp>
+      <p:cxnSp>
+        <p:nvCxnSpPr>
+          <p:cNvPr id="76" name="Gerade Verbindung mit Pfeil 75">
+            <a:extLst>
+              <a:ext uri="{FF2B5EF4-FFF2-40B4-BE49-F238E27FC236}">
+                <a16:creationId xmlns:a16="http://schemas.microsoft.com/office/drawing/2014/main" id="{AAABCFCA-DCF3-7B03-6801-1FAD0C3DE912}"/>
+              </a:ext>
+            </a:extLst>
+          </p:cNvPr>
+          <p:cNvCxnSpPr>
+            <a:cxnSpLocks/>
+          </p:cNvCxnSpPr>
+          <p:nvPr/>
+        </p:nvCxnSpPr>
+        <p:spPr>
+          <a:xfrm flipV="1">
+            <a:off x="354806" y="2035975"/>
+            <a:ext cx="273388" cy="191790"/>
+          </a:xfrm>
+          <a:prstGeom prst="straightConnector1">
+            <a:avLst/>
+          </a:prstGeom>
+          <a:ln w="12700" cap="rnd">
+            <a:round/>
+            <a:tailEnd type="triangle"/>
+          </a:ln>
+        </p:spPr>
+        <p:style>
+          <a:lnRef idx="2">
+            <a:schemeClr val="dk1"/>
+          </a:lnRef>
+          <a:fillRef idx="0">
+            <a:schemeClr val="dk1"/>
+          </a:fillRef>
+          <a:effectRef idx="1">
+            <a:schemeClr val="dk1"/>
+          </a:effectRef>
+          <a:fontRef idx="minor">
+            <a:schemeClr val="tx1"/>
+          </a:fontRef>
+        </p:style>
+      </p:cxnSp>
+      <p:sp>
+        <p:nvSpPr>
+          <p:cNvPr id="82" name="Textfeld 81">
+            <a:extLst>
+              <a:ext uri="{FF2B5EF4-FFF2-40B4-BE49-F238E27FC236}">
+                <a16:creationId xmlns:a16="http://schemas.microsoft.com/office/drawing/2014/main" id="{7AFD5268-EAEB-C5F9-6551-D9104CD813B1}"/>
+              </a:ext>
+            </a:extLst>
+          </p:cNvPr>
+          <p:cNvSpPr txBox="1"/>
+          <p:nvPr/>
+        </p:nvSpPr>
+        <p:spPr>
+          <a:xfrm>
+            <a:off x="7178" y="1711045"/>
+            <a:ext cx="703677" cy="430887"/>
+          </a:xfrm>
+          <a:prstGeom prst="rect">
+            <a:avLst/>
+          </a:prstGeom>
+          <a:noFill/>
+        </p:spPr>
+        <p:txBody>
+          <a:bodyPr wrap="square" rtlCol="0">
+            <a:spAutoFit/>
+          </a:bodyPr>
+          <a:lstStyle/>
+          <a:p>
+            <a:pPr algn="ctr"/>
+            <a:r>
+              <a:rPr lang="de-DE" sz="1100" i="1" dirty="0">
+                <a:solidFill>
+                  <a:schemeClr val="accent6">
+                    <a:lumMod val="75000"/>
+                  </a:schemeClr>
+                </a:solidFill>
+                <a:latin typeface="CMU Serif" panose="02000603000000000000" pitchFamily="2" charset="0"/>
+                <a:ea typeface="CMU Serif" panose="02000603000000000000" pitchFamily="2" charset="0"/>
+                <a:cs typeface="CMU Serif" panose="02000603000000000000" pitchFamily="2" charset="0"/>
+              </a:rPr>
+              <a:t>U</a:t>
+            </a:r>
+            <a:r>
+              <a:rPr lang="de-DE" sz="1100" baseline="-25000" dirty="0">
+                <a:solidFill>
+                  <a:schemeClr val="accent6">
+                    <a:lumMod val="75000"/>
+                  </a:schemeClr>
+                </a:solidFill>
+                <a:latin typeface="CMU Serif" panose="02000603000000000000" pitchFamily="2" charset="0"/>
+                <a:ea typeface="CMU Serif" panose="02000603000000000000" pitchFamily="2" charset="0"/>
+                <a:cs typeface="CMU Serif" panose="02000603000000000000" pitchFamily="2" charset="0"/>
+              </a:rPr>
+              <a:t>∞</a:t>
+            </a:r>
+            <a:r>
+              <a:rPr lang="de-DE" sz="1100" dirty="0">
+                <a:solidFill>
+                  <a:schemeClr val="accent6">
+                    <a:lumMod val="75000"/>
+                  </a:schemeClr>
+                </a:solidFill>
+                <a:latin typeface="CMU Serif" panose="02000603000000000000" pitchFamily="2" charset="0"/>
+                <a:ea typeface="CMU Serif" panose="02000603000000000000" pitchFamily="2" charset="0"/>
+                <a:cs typeface="CMU Serif" panose="02000603000000000000" pitchFamily="2" charset="0"/>
+              </a:rPr>
+              <a:t> </a:t>
+            </a:r>
+            <a:r>
+              <a:rPr lang="de-DE" sz="1100" dirty="0">
+                <a:latin typeface="CMU Serif" panose="02000603000000000000" pitchFamily="2" charset="0"/>
+                <a:ea typeface="CMU Serif" panose="02000603000000000000" pitchFamily="2" charset="0"/>
+                <a:cs typeface="CMU Serif" panose="02000603000000000000" pitchFamily="2" charset="0"/>
+              </a:rPr>
+              <a:t>/</a:t>
+            </a:r>
+            <a:r>
+              <a:rPr lang="de-DE" sz="1100" i="1" dirty="0">
+                <a:solidFill>
+                  <a:schemeClr val="accent2">
+                    <a:lumMod val="75000"/>
+                  </a:schemeClr>
+                </a:solidFill>
+                <a:latin typeface="CMU Serif" panose="02000603000000000000" pitchFamily="2" charset="0"/>
+                <a:ea typeface="CMU Serif" panose="02000603000000000000" pitchFamily="2" charset="0"/>
+                <a:cs typeface="CMU Serif" panose="02000603000000000000" pitchFamily="2" charset="0"/>
+              </a:rPr>
+              <a:t>U</a:t>
+            </a:r>
+            <a:r>
+              <a:rPr lang="de-DE" sz="1100" baseline="-25000" dirty="0">
+                <a:solidFill>
+                  <a:schemeClr val="accent2">
+                    <a:lumMod val="75000"/>
+                  </a:schemeClr>
+                </a:solidFill>
+                <a:latin typeface="CMU Serif" panose="02000603000000000000" pitchFamily="2" charset="0"/>
+                <a:ea typeface="CMU Serif" panose="02000603000000000000" pitchFamily="2" charset="0"/>
+                <a:cs typeface="CMU Serif" panose="02000603000000000000" pitchFamily="2" charset="0"/>
+              </a:rPr>
+              <a:t>∞</a:t>
+            </a:r>
+            <a:endParaRPr lang="de-DE" sz="1100" dirty="0">
+              <a:solidFill>
+                <a:schemeClr val="accent2">
+                  <a:lumMod val="75000"/>
+                </a:schemeClr>
+              </a:solidFill>
+              <a:latin typeface="CMU Serif" panose="02000603000000000000" pitchFamily="2" charset="0"/>
+              <a:ea typeface="CMU Serif" panose="02000603000000000000" pitchFamily="2" charset="0"/>
+              <a:cs typeface="CMU Serif" panose="02000603000000000000" pitchFamily="2" charset="0"/>
+            </a:endParaRPr>
+          </a:p>
+          <a:p>
+            <a:pPr algn="ctr"/>
+            <a:endParaRPr lang="de-DE" sz="1100" dirty="0">
+              <a:solidFill>
+                <a:schemeClr val="accent6">
+                  <a:lumMod val="75000"/>
+                </a:schemeClr>
+              </a:solidFill>
+              <a:latin typeface="CMU Serif" panose="02000603000000000000" pitchFamily="2" charset="0"/>
+              <a:ea typeface="CMU Serif" panose="02000603000000000000" pitchFamily="2" charset="0"/>
+              <a:cs typeface="CMU Serif" panose="02000603000000000000" pitchFamily="2" charset="0"/>
+            </a:endParaRPr>
+          </a:p>
+        </p:txBody>
+      </p:sp>
+      <p:sp>
+        <p:nvSpPr>
+          <p:cNvPr id="84" name="Textfeld 83">
+            <a:extLst>
+              <a:ext uri="{FF2B5EF4-FFF2-40B4-BE49-F238E27FC236}">
+                <a16:creationId xmlns:a16="http://schemas.microsoft.com/office/drawing/2014/main" id="{3C707EEF-AC0F-B5A4-B08D-6A1583344E7B}"/>
+              </a:ext>
+            </a:extLst>
+          </p:cNvPr>
+          <p:cNvSpPr txBox="1"/>
+          <p:nvPr/>
+        </p:nvSpPr>
+        <p:spPr>
+          <a:xfrm>
+            <a:off x="96869" y="2200105"/>
+            <a:ext cx="374452" cy="261610"/>
+          </a:xfrm>
+          <a:prstGeom prst="rect">
+            <a:avLst/>
+          </a:prstGeom>
+          <a:noFill/>
+        </p:spPr>
+        <p:txBody>
+          <a:bodyPr wrap="square">
+            <a:spAutoFit/>
+          </a:bodyPr>
+          <a:lstStyle/>
+          <a:p>
+            <a:r>
+              <a:rPr lang="de-DE" sz="1100" i="1" dirty="0">
+                <a:solidFill>
+                  <a:schemeClr val="tx2">
+                    <a:lumMod val="75000"/>
+                    <a:lumOff val="25000"/>
+                  </a:schemeClr>
+                </a:solidFill>
+                <a:latin typeface="CMU Serif" panose="02000603000000000000" pitchFamily="2" charset="0"/>
+                <a:ea typeface="CMU Serif" panose="02000603000000000000" pitchFamily="2" charset="0"/>
+                <a:cs typeface="CMU Serif" panose="02000603000000000000" pitchFamily="2" charset="0"/>
+              </a:rPr>
+              <a:t>U</a:t>
+            </a:r>
+            <a:r>
+              <a:rPr lang="de-DE" sz="1100" baseline="-25000" dirty="0">
+                <a:solidFill>
+                  <a:schemeClr val="tx2">
+                    <a:lumMod val="75000"/>
+                    <a:lumOff val="25000"/>
+                  </a:schemeClr>
+                </a:solidFill>
+                <a:latin typeface="CMU Serif" panose="02000603000000000000" pitchFamily="2" charset="0"/>
+                <a:ea typeface="CMU Serif" panose="02000603000000000000" pitchFamily="2" charset="0"/>
+                <a:cs typeface="CMU Serif" panose="02000603000000000000" pitchFamily="2" charset="0"/>
+              </a:rPr>
+              <a:t>∞</a:t>
+            </a:r>
+            <a:endParaRPr lang="de-DE" dirty="0">
+              <a:solidFill>
+                <a:schemeClr val="tx2">
+                  <a:lumMod val="75000"/>
+                  <a:lumOff val="25000"/>
+                </a:schemeClr>
+              </a:solidFill>
+            </a:endParaRPr>
+          </a:p>
+        </p:txBody>
+      </p:sp>
+      <p:sp>
+        <p:nvSpPr>
+          <p:cNvPr id="85" name="Bogen 84">
+            <a:extLst>
+              <a:ext uri="{FF2B5EF4-FFF2-40B4-BE49-F238E27FC236}">
+                <a16:creationId xmlns:a16="http://schemas.microsoft.com/office/drawing/2014/main" id="{0B6D7B31-023B-B3C1-EEE3-C2CF9016B86A}"/>
+              </a:ext>
+            </a:extLst>
+          </p:cNvPr>
+          <p:cNvSpPr/>
+          <p:nvPr/>
+        </p:nvSpPr>
+        <p:spPr>
+          <a:xfrm>
+            <a:off x="392906" y="1621178"/>
+            <a:ext cx="686722" cy="686722"/>
+          </a:xfrm>
+          <a:prstGeom prst="arc">
+            <a:avLst>
+              <a:gd name="adj1" fmla="val 8858262"/>
+              <a:gd name="adj2" fmla="val 10621352"/>
+            </a:avLst>
+          </a:prstGeom>
+          <a:ln w="12700" cap="rnd">
+            <a:solidFill>
+              <a:schemeClr val="accent5"/>
+            </a:solidFill>
+            <a:round/>
+            <a:headEnd type="triangle" w="sm" len="sm"/>
+          </a:ln>
+        </p:spPr>
+        <p:style>
+          <a:lnRef idx="2">
+            <a:schemeClr val="accent1"/>
+          </a:lnRef>
+          <a:fillRef idx="0">
+            <a:schemeClr val="accent1"/>
+          </a:fillRef>
+          <a:effectRef idx="1">
+            <a:schemeClr val="accent1"/>
+          </a:effectRef>
+          <a:fontRef idx="minor">
+            <a:schemeClr val="tx1"/>
+          </a:fontRef>
+        </p:style>
+        <p:txBody>
+          <a:bodyPr rtlCol="0" anchor="ctr"/>
+          <a:lstStyle/>
+          <a:p>
+            <a:pPr algn="ctr"/>
+            <a:endParaRPr lang="de-DE"/>
+          </a:p>
+        </p:txBody>
+      </p:sp>
+      <p:sp>
+        <p:nvSpPr>
+          <p:cNvPr id="87" name="Textfeld 86">
+            <a:extLst>
+              <a:ext uri="{FF2B5EF4-FFF2-40B4-BE49-F238E27FC236}">
+                <a16:creationId xmlns:a16="http://schemas.microsoft.com/office/drawing/2014/main" id="{D6B011DB-B875-B25A-24F5-767EAAAEDD70}"/>
+              </a:ext>
+            </a:extLst>
+          </p:cNvPr>
+          <p:cNvSpPr txBox="1"/>
+          <p:nvPr/>
+        </p:nvSpPr>
+        <p:spPr>
+          <a:xfrm>
+            <a:off x="107121" y="1990857"/>
+            <a:ext cx="366666" cy="261610"/>
+          </a:xfrm>
+          <a:prstGeom prst="rect">
+            <a:avLst/>
+          </a:prstGeom>
+          <a:noFill/>
+        </p:spPr>
+        <p:txBody>
+          <a:bodyPr wrap="square">
+            <a:spAutoFit/>
+          </a:bodyPr>
+          <a:lstStyle/>
+          <a:p>
+            <a:r>
+              <a:rPr lang="de-DE" sz="1100" i="1" dirty="0">
+                <a:solidFill>
+                  <a:schemeClr val="accent5"/>
+                </a:solidFill>
+                <a:latin typeface="Latin Modern Math" panose="02000503000000000000" pitchFamily="50" charset="0"/>
+                <a:ea typeface="Latin Modern Math" panose="02000503000000000000" pitchFamily="50" charset="0"/>
+                <a:cs typeface="CMU Serif" panose="02000603000000000000" pitchFamily="2" charset="0"/>
+              </a:rPr>
+              <a:t>α</a:t>
+            </a:r>
+            <a:r>
+              <a:rPr lang="de-DE" sz="1100" dirty="0">
+                <a:solidFill>
+                  <a:schemeClr val="accent5"/>
+                </a:solidFill>
+                <a:latin typeface="CMU Serif" panose="02000603000000000000" pitchFamily="2" charset="0"/>
+                <a:ea typeface="CMU Serif" panose="02000603000000000000" pitchFamily="2" charset="0"/>
+                <a:cs typeface="CMU Serif" panose="02000603000000000000" pitchFamily="2" charset="0"/>
+              </a:rPr>
+              <a:t>*</a:t>
+            </a:r>
+            <a:endParaRPr lang="de-DE" dirty="0">
+              <a:solidFill>
+                <a:schemeClr val="accent5"/>
+              </a:solidFill>
+            </a:endParaRPr>
+          </a:p>
+        </p:txBody>
+      </p:sp>
+      <p:sp>
+        <p:nvSpPr>
+          <p:cNvPr id="89" name="Textfeld 88">
+            <a:extLst>
+              <a:ext uri="{FF2B5EF4-FFF2-40B4-BE49-F238E27FC236}">
+                <a16:creationId xmlns:a16="http://schemas.microsoft.com/office/drawing/2014/main" id="{E49A7E6C-C58A-C10C-14FF-E975C0DA7BD5}"/>
+              </a:ext>
+            </a:extLst>
+          </p:cNvPr>
+          <p:cNvSpPr txBox="1"/>
+          <p:nvPr/>
+        </p:nvSpPr>
+        <p:spPr>
+          <a:xfrm>
+            <a:off x="1165810" y="1012124"/>
+            <a:ext cx="512970" cy="261610"/>
+          </a:xfrm>
+          <a:prstGeom prst="rect">
+            <a:avLst/>
+          </a:prstGeom>
+          <a:noFill/>
+        </p:spPr>
+        <p:txBody>
+          <a:bodyPr wrap="square" rtlCol="0">
+            <a:spAutoFit/>
+          </a:bodyPr>
+          <a:lstStyle/>
+          <a:p>
+            <a:pPr algn="ctr"/>
+            <a:r>
+              <a:rPr lang="de-DE" sz="1100" i="1" dirty="0">
+                <a:solidFill>
+                  <a:schemeClr val="tx2">
+                    <a:lumMod val="75000"/>
+                    <a:lumOff val="25000"/>
+                  </a:schemeClr>
+                </a:solidFill>
+                <a:latin typeface="CMU Serif" panose="02000603000000000000" pitchFamily="2" charset="0"/>
+                <a:ea typeface="CMU Serif" panose="02000603000000000000" pitchFamily="2" charset="0"/>
+                <a:cs typeface="CMU Serif" panose="02000603000000000000" pitchFamily="2" charset="0"/>
+              </a:rPr>
+              <a:t>i</a:t>
+            </a:r>
+            <a:r>
+              <a:rPr lang="de-DE" sz="1100" dirty="0">
+                <a:solidFill>
+                  <a:schemeClr val="tx2">
+                    <a:lumMod val="75000"/>
+                    <a:lumOff val="25000"/>
+                  </a:schemeClr>
+                </a:solidFill>
+                <a:latin typeface="CMU Serif" panose="02000603000000000000" pitchFamily="2" charset="0"/>
+                <a:ea typeface="CMU Serif" panose="02000603000000000000" pitchFamily="2" charset="0"/>
+                <a:cs typeface="CMU Serif" panose="02000603000000000000" pitchFamily="2" charset="0"/>
+              </a:rPr>
+              <a:t> = 0</a:t>
+            </a:r>
+          </a:p>
+        </p:txBody>
+      </p:sp>
+      <p:sp>
+        <p:nvSpPr>
+          <p:cNvPr id="91" name="Textfeld 90">
+            <a:extLst>
+              <a:ext uri="{FF2B5EF4-FFF2-40B4-BE49-F238E27FC236}">
+                <a16:creationId xmlns:a16="http://schemas.microsoft.com/office/drawing/2014/main" id="{15019017-63D1-ED4A-FF20-F6FB3D206934}"/>
+              </a:ext>
+            </a:extLst>
+          </p:cNvPr>
+          <p:cNvSpPr txBox="1"/>
+          <p:nvPr/>
+        </p:nvSpPr>
+        <p:spPr>
+          <a:xfrm>
+            <a:off x="1696828" y="1012124"/>
+            <a:ext cx="512970" cy="261610"/>
+          </a:xfrm>
+          <a:prstGeom prst="rect">
+            <a:avLst/>
+          </a:prstGeom>
+          <a:noFill/>
+        </p:spPr>
+        <p:txBody>
+          <a:bodyPr wrap="square" rtlCol="0">
+            <a:spAutoFit/>
+          </a:bodyPr>
+          <a:lstStyle/>
+          <a:p>
+            <a:pPr algn="ctr"/>
+            <a:r>
+              <a:rPr lang="de-DE" sz="1100" i="1" dirty="0">
+                <a:solidFill>
+                  <a:schemeClr val="accent6">
+                    <a:lumMod val="75000"/>
+                  </a:schemeClr>
+                </a:solidFill>
+                <a:latin typeface="CMU Serif" panose="02000603000000000000" pitchFamily="2" charset="0"/>
+                <a:ea typeface="CMU Serif" panose="02000603000000000000" pitchFamily="2" charset="0"/>
+                <a:cs typeface="CMU Serif" panose="02000603000000000000" pitchFamily="2" charset="0"/>
+              </a:rPr>
+              <a:t>i</a:t>
+            </a:r>
+            <a:r>
+              <a:rPr lang="de-DE" sz="1100" dirty="0">
+                <a:solidFill>
+                  <a:schemeClr val="accent6">
+                    <a:lumMod val="75000"/>
+                  </a:schemeClr>
+                </a:solidFill>
+                <a:latin typeface="CMU Serif" panose="02000603000000000000" pitchFamily="2" charset="0"/>
+                <a:ea typeface="CMU Serif" panose="02000603000000000000" pitchFamily="2" charset="0"/>
+                <a:cs typeface="CMU Serif" panose="02000603000000000000" pitchFamily="2" charset="0"/>
+              </a:rPr>
+              <a:t> = 1</a:t>
+            </a:r>
+          </a:p>
+        </p:txBody>
+      </p:sp>
+      <p:sp>
+        <p:nvSpPr>
+          <p:cNvPr id="93" name="Textfeld 92">
+            <a:extLst>
+              <a:ext uri="{FF2B5EF4-FFF2-40B4-BE49-F238E27FC236}">
+                <a16:creationId xmlns:a16="http://schemas.microsoft.com/office/drawing/2014/main" id="{B9993E86-959C-6AE3-65EA-F90303403977}"/>
+              </a:ext>
+            </a:extLst>
+          </p:cNvPr>
+          <p:cNvSpPr txBox="1"/>
+          <p:nvPr/>
+        </p:nvSpPr>
+        <p:spPr>
+          <a:xfrm>
+            <a:off x="1165810" y="2631527"/>
+            <a:ext cx="512970" cy="261610"/>
+          </a:xfrm>
+          <a:prstGeom prst="rect">
+            <a:avLst/>
+          </a:prstGeom>
+          <a:noFill/>
+        </p:spPr>
+        <p:txBody>
+          <a:bodyPr wrap="square" rtlCol="0">
+            <a:spAutoFit/>
+          </a:bodyPr>
+          <a:lstStyle/>
+          <a:p>
+            <a:pPr algn="ctr"/>
+            <a:r>
+              <a:rPr lang="de-DE" sz="1100" i="1" dirty="0">
+                <a:solidFill>
+                  <a:schemeClr val="accent2">
+                    <a:lumMod val="75000"/>
+                  </a:schemeClr>
+                </a:solidFill>
+                <a:latin typeface="CMU Serif" panose="02000603000000000000" pitchFamily="2" charset="0"/>
+                <a:ea typeface="CMU Serif" panose="02000603000000000000" pitchFamily="2" charset="0"/>
+                <a:cs typeface="CMU Serif" panose="02000603000000000000" pitchFamily="2" charset="0"/>
+              </a:rPr>
+              <a:t>i</a:t>
+            </a:r>
+            <a:r>
+              <a:rPr lang="de-DE" sz="1100" dirty="0">
+                <a:solidFill>
+                  <a:schemeClr val="accent2">
+                    <a:lumMod val="75000"/>
+                  </a:schemeClr>
+                </a:solidFill>
+                <a:latin typeface="CMU Serif" panose="02000603000000000000" pitchFamily="2" charset="0"/>
+                <a:ea typeface="CMU Serif" panose="02000603000000000000" pitchFamily="2" charset="0"/>
+                <a:cs typeface="CMU Serif" panose="02000603000000000000" pitchFamily="2" charset="0"/>
+              </a:rPr>
+              <a:t> = 2</a:t>
+            </a:r>
+          </a:p>
+        </p:txBody>
+      </p:sp>
+      <p:cxnSp>
+        <p:nvCxnSpPr>
+          <p:cNvPr id="94" name="Gerader Verbinder 93">
+            <a:extLst>
+              <a:ext uri="{FF2B5EF4-FFF2-40B4-BE49-F238E27FC236}">
+                <a16:creationId xmlns:a16="http://schemas.microsoft.com/office/drawing/2014/main" id="{F5D3A26A-AD07-C4C6-4C64-089BF3EC611B}"/>
+              </a:ext>
+            </a:extLst>
+          </p:cNvPr>
+          <p:cNvCxnSpPr>
+            <a:cxnSpLocks/>
+            <a:stCxn id="30" idx="1"/>
+          </p:cNvCxnSpPr>
+          <p:nvPr/>
+        </p:nvCxnSpPr>
+        <p:spPr>
+          <a:xfrm flipV="1">
+            <a:off x="1868052" y="1222706"/>
+            <a:ext cx="72423" cy="272411"/>
+          </a:xfrm>
+          <a:prstGeom prst="line">
+            <a:avLst/>
+          </a:prstGeom>
+          <a:ln w="6350" cap="rnd">
+            <a:solidFill>
+              <a:schemeClr val="accent6">
+                <a:lumMod val="75000"/>
+              </a:schemeClr>
+            </a:solidFill>
+            <a:prstDash val="solid"/>
+            <a:round/>
+          </a:ln>
+        </p:spPr>
+        <p:style>
+          <a:lnRef idx="2">
+            <a:schemeClr val="accent1"/>
+          </a:lnRef>
+          <a:fillRef idx="0">
+            <a:schemeClr val="accent1"/>
+          </a:fillRef>
+          <a:effectRef idx="1">
+            <a:schemeClr val="accent1"/>
+          </a:effectRef>
+          <a:fontRef idx="minor">
+            <a:schemeClr val="tx1"/>
+          </a:fontRef>
+        </p:style>
+      </p:cxnSp>
+      <p:cxnSp>
+        <p:nvCxnSpPr>
+          <p:cNvPr id="97" name="Gerader Verbinder 96">
+            <a:extLst>
+              <a:ext uri="{FF2B5EF4-FFF2-40B4-BE49-F238E27FC236}">
+                <a16:creationId xmlns:a16="http://schemas.microsoft.com/office/drawing/2014/main" id="{FCA54879-7E73-9417-929D-2B745A82576C}"/>
+              </a:ext>
+            </a:extLst>
+          </p:cNvPr>
+          <p:cNvCxnSpPr>
+            <a:cxnSpLocks/>
+          </p:cNvCxnSpPr>
+          <p:nvPr/>
+        </p:nvCxnSpPr>
+        <p:spPr>
+          <a:xfrm flipV="1">
+            <a:off x="1223963" y="1219756"/>
+            <a:ext cx="167018" cy="225663"/>
+          </a:xfrm>
+          <a:prstGeom prst="line">
+            <a:avLst/>
+          </a:prstGeom>
+          <a:ln w="6350" cap="rnd">
+            <a:solidFill>
+              <a:schemeClr val="tx2">
+                <a:lumMod val="75000"/>
+                <a:lumOff val="25000"/>
+              </a:schemeClr>
+            </a:solidFill>
+            <a:prstDash val="solid"/>
+            <a:round/>
+          </a:ln>
+        </p:spPr>
+        <p:style>
+          <a:lnRef idx="2">
+            <a:schemeClr val="accent1"/>
+          </a:lnRef>
+          <a:fillRef idx="0">
+            <a:schemeClr val="accent1"/>
+          </a:fillRef>
+          <a:effectRef idx="1">
+            <a:schemeClr val="accent1"/>
+          </a:effectRef>
+          <a:fontRef idx="minor">
+            <a:schemeClr val="tx1"/>
+          </a:fontRef>
+        </p:style>
+      </p:cxnSp>
+      <p:cxnSp>
+        <p:nvCxnSpPr>
+          <p:cNvPr id="99" name="Gerader Verbinder 98">
+            <a:extLst>
+              <a:ext uri="{FF2B5EF4-FFF2-40B4-BE49-F238E27FC236}">
+                <a16:creationId xmlns:a16="http://schemas.microsoft.com/office/drawing/2014/main" id="{1772B2E7-A891-FD8D-9B1C-E650CC810C09}"/>
+              </a:ext>
+            </a:extLst>
+          </p:cNvPr>
+          <p:cNvCxnSpPr>
+            <a:cxnSpLocks/>
+          </p:cNvCxnSpPr>
+          <p:nvPr/>
+        </p:nvCxnSpPr>
+        <p:spPr>
+          <a:xfrm flipV="1">
+            <a:off x="1463675" y="2298700"/>
+            <a:ext cx="450850" cy="377825"/>
+          </a:xfrm>
+          <a:prstGeom prst="line">
+            <a:avLst/>
+          </a:prstGeom>
+          <a:ln w="6350" cap="rnd">
+            <a:solidFill>
+              <a:schemeClr val="accent2">
+                <a:lumMod val="75000"/>
+              </a:schemeClr>
+            </a:solidFill>
+            <a:prstDash val="solid"/>
+            <a:round/>
+          </a:ln>
+        </p:spPr>
+        <p:style>
+          <a:lnRef idx="2">
+            <a:schemeClr val="accent1"/>
+          </a:lnRef>
+          <a:fillRef idx="0">
+            <a:schemeClr val="accent1"/>
+          </a:fillRef>
+          <a:effectRef idx="1">
+            <a:schemeClr val="accent1"/>
+          </a:effectRef>
+          <a:fontRef idx="minor">
+            <a:schemeClr val="tx1"/>
+          </a:fontRef>
+        </p:style>
+      </p:cxnSp>
+      <p:sp>
+        <p:nvSpPr>
+          <p:cNvPr id="105" name="Textfeld 104">
+            <a:extLst>
+              <a:ext uri="{FF2B5EF4-FFF2-40B4-BE49-F238E27FC236}">
+                <a16:creationId xmlns:a16="http://schemas.microsoft.com/office/drawing/2014/main" id="{3A11952F-744E-4740-773F-7374777233CE}"/>
+              </a:ext>
+            </a:extLst>
+          </p:cNvPr>
+          <p:cNvSpPr txBox="1"/>
+          <p:nvPr/>
+        </p:nvSpPr>
+        <p:spPr>
+          <a:xfrm>
+            <a:off x="952616" y="1627408"/>
+            <a:ext cx="1165694" cy="261610"/>
+          </a:xfrm>
+          <a:prstGeom prst="rect">
+            <a:avLst/>
+          </a:prstGeom>
+          <a:noFill/>
+        </p:spPr>
+        <p:txBody>
+          <a:bodyPr wrap="square" rtlCol="0">
+            <a:spAutoFit/>
+          </a:bodyPr>
+          <a:lstStyle/>
+          <a:p>
+            <a:pPr algn="ctr"/>
+            <a:r>
+              <a:rPr lang="de-DE" sz="1100" i="1" dirty="0">
+                <a:solidFill>
+                  <a:schemeClr val="tx2">
+                    <a:lumMod val="75000"/>
+                    <a:lumOff val="25000"/>
+                  </a:schemeClr>
+                </a:solidFill>
+                <a:latin typeface="Latin Modern Math" panose="02000503000000000000" pitchFamily="50" charset="0"/>
+                <a:ea typeface="Latin Modern Math" panose="02000503000000000000" pitchFamily="50" charset="0"/>
+                <a:cs typeface="CMU Serif" panose="02000603000000000000" pitchFamily="2" charset="0"/>
+              </a:rPr>
+              <a:t>α</a:t>
+            </a:r>
+            <a:r>
+              <a:rPr lang="de-DE" sz="1100" baseline="-25000" dirty="0">
+                <a:solidFill>
+                  <a:schemeClr val="tx2">
+                    <a:lumMod val="75000"/>
+                    <a:lumOff val="25000"/>
+                  </a:schemeClr>
+                </a:solidFill>
+                <a:latin typeface="CMU Serif" panose="02000603000000000000" pitchFamily="2" charset="0"/>
+                <a:ea typeface="CMU Serif" panose="02000603000000000000" pitchFamily="2" charset="0"/>
+                <a:cs typeface="CMU Serif" panose="02000603000000000000" pitchFamily="2" charset="0"/>
+              </a:rPr>
+              <a:t>0</a:t>
+            </a:r>
+            <a:r>
+              <a:rPr lang="de-DE" sz="1100" i="1" dirty="0">
+                <a:solidFill>
+                  <a:schemeClr val="tx2">
+                    <a:lumMod val="75000"/>
+                    <a:lumOff val="25000"/>
+                  </a:schemeClr>
+                </a:solidFill>
+                <a:latin typeface="Latin Modern Math" panose="02000503000000000000" pitchFamily="50" charset="0"/>
+                <a:ea typeface="Latin Modern Math" panose="02000503000000000000" pitchFamily="50" charset="0"/>
+                <a:cs typeface="CMU Serif" panose="02000603000000000000" pitchFamily="2" charset="0"/>
+              </a:rPr>
+              <a:t> </a:t>
+            </a:r>
+            <a:r>
+              <a:rPr lang="de-DE" sz="1100" dirty="0">
+                <a:solidFill>
+                  <a:schemeClr val="tx2">
+                    <a:lumMod val="75000"/>
+                    <a:lumOff val="25000"/>
+                  </a:schemeClr>
+                </a:solidFill>
+                <a:latin typeface="CMU Serif" panose="02000603000000000000" pitchFamily="2" charset="0"/>
+                <a:ea typeface="CMU Serif" panose="02000603000000000000" pitchFamily="2" charset="0"/>
+                <a:cs typeface="CMU Serif" panose="02000603000000000000" pitchFamily="2" charset="0"/>
+              </a:rPr>
+              <a:t>=</a:t>
+            </a:r>
+            <a:r>
+              <a:rPr lang="de-DE" sz="1100" i="1" dirty="0">
+                <a:solidFill>
+                  <a:schemeClr val="tx2">
+                    <a:lumMod val="75000"/>
+                    <a:lumOff val="25000"/>
+                  </a:schemeClr>
+                </a:solidFill>
+                <a:latin typeface="CMU Serif" panose="02000603000000000000" pitchFamily="2" charset="0"/>
+                <a:ea typeface="CMU Serif" panose="02000603000000000000" pitchFamily="2" charset="0"/>
+                <a:cs typeface="CMU Serif" panose="02000603000000000000" pitchFamily="2" charset="0"/>
+              </a:rPr>
+              <a:t>A</a:t>
+            </a:r>
+            <a:r>
+              <a:rPr lang="de-DE" sz="1100" baseline="-25000" dirty="0">
+                <a:solidFill>
+                  <a:schemeClr val="tx2">
+                    <a:lumMod val="75000"/>
+                    <a:lumOff val="25000"/>
+                  </a:schemeClr>
+                </a:solidFill>
+                <a:latin typeface="CMU Serif" panose="02000603000000000000" pitchFamily="2" charset="0"/>
+                <a:ea typeface="CMU Serif" panose="02000603000000000000" pitchFamily="2" charset="0"/>
+                <a:cs typeface="CMU Serif" panose="02000603000000000000" pitchFamily="2" charset="0"/>
+              </a:rPr>
+              <a:t>0 </a:t>
+            </a:r>
+            <a:r>
+              <a:rPr lang="de-DE" sz="1100" dirty="0">
+                <a:solidFill>
+                  <a:schemeClr val="tx2">
+                    <a:lumMod val="75000"/>
+                    <a:lumOff val="25000"/>
+                  </a:schemeClr>
+                </a:solidFill>
+                <a:latin typeface="CMU Serif" panose="02000603000000000000" pitchFamily="2" charset="0"/>
+                <a:ea typeface="CMU Serif" panose="02000603000000000000" pitchFamily="2" charset="0"/>
+                <a:cs typeface="CMU Serif" panose="02000603000000000000" pitchFamily="2" charset="0"/>
+              </a:rPr>
+              <a:t>− </a:t>
+            </a:r>
+            <a:r>
+              <a:rPr lang="de-DE" sz="1100" i="1" dirty="0">
+                <a:solidFill>
+                  <a:schemeClr val="tx2">
+                    <a:lumMod val="75000"/>
+                    <a:lumOff val="25000"/>
+                  </a:schemeClr>
+                </a:solidFill>
+                <a:latin typeface="Latin Modern Math" panose="02000503000000000000" pitchFamily="50" charset="0"/>
+                <a:ea typeface="Latin Modern Math" panose="02000503000000000000" pitchFamily="50" charset="0"/>
+                <a:cs typeface="CMU Serif" panose="02000603000000000000" pitchFamily="2" charset="0"/>
+              </a:rPr>
+              <a:t>α</a:t>
+            </a:r>
+            <a:r>
+              <a:rPr lang="de-DE" sz="1100" dirty="0">
+                <a:solidFill>
+                  <a:schemeClr val="tx2">
+                    <a:lumMod val="75000"/>
+                    <a:lumOff val="25000"/>
+                  </a:schemeClr>
+                </a:solidFill>
+                <a:latin typeface="CMU Serif" panose="02000603000000000000" pitchFamily="2" charset="0"/>
+                <a:ea typeface="CMU Serif" panose="02000603000000000000" pitchFamily="2" charset="0"/>
+                <a:cs typeface="CMU Serif" panose="02000603000000000000" pitchFamily="2" charset="0"/>
+              </a:rPr>
+              <a:t>*</a:t>
+            </a:r>
+          </a:p>
+        </p:txBody>
+      </p:sp>
+      <p:sp>
+        <p:nvSpPr>
+          <p:cNvPr id="114" name="Textfeld 113">
+            <a:extLst>
+              <a:ext uri="{FF2B5EF4-FFF2-40B4-BE49-F238E27FC236}">
+                <a16:creationId xmlns:a16="http://schemas.microsoft.com/office/drawing/2014/main" id="{BCB4D91D-C06A-C935-D3EE-A2E534FBF164}"/>
+              </a:ext>
+            </a:extLst>
+          </p:cNvPr>
+          <p:cNvSpPr txBox="1"/>
+          <p:nvPr/>
+        </p:nvSpPr>
+        <p:spPr>
+          <a:xfrm>
+            <a:off x="1698598" y="1970501"/>
+            <a:ext cx="1165694" cy="261610"/>
+          </a:xfrm>
+          <a:prstGeom prst="rect">
+            <a:avLst/>
+          </a:prstGeom>
+          <a:noFill/>
+        </p:spPr>
+        <p:txBody>
+          <a:bodyPr wrap="square" rtlCol="0">
+            <a:spAutoFit/>
+          </a:bodyPr>
+          <a:lstStyle/>
+          <a:p>
+            <a:pPr algn="ctr"/>
+            <a:r>
+              <a:rPr lang="de-DE" sz="1100" i="1" dirty="0">
+                <a:solidFill>
+                  <a:schemeClr val="accent2">
+                    <a:lumMod val="75000"/>
+                  </a:schemeClr>
+                </a:solidFill>
+                <a:latin typeface="Latin Modern Math" panose="02000503000000000000" pitchFamily="50" charset="0"/>
+                <a:ea typeface="Latin Modern Math" panose="02000503000000000000" pitchFamily="50" charset="0"/>
+                <a:cs typeface="CMU Serif" panose="02000603000000000000" pitchFamily="2" charset="0"/>
+              </a:rPr>
+              <a:t>α</a:t>
+            </a:r>
+            <a:r>
+              <a:rPr lang="de-DE" sz="1100" baseline="-25000" dirty="0">
+                <a:solidFill>
+                  <a:schemeClr val="accent2">
+                    <a:lumMod val="75000"/>
+                  </a:schemeClr>
+                </a:solidFill>
+                <a:latin typeface="CMU Serif" panose="02000603000000000000" pitchFamily="2" charset="0"/>
+                <a:ea typeface="CMU Serif" panose="02000603000000000000" pitchFamily="2" charset="0"/>
+                <a:cs typeface="CMU Serif" panose="02000603000000000000" pitchFamily="2" charset="0"/>
+              </a:rPr>
+              <a:t>2</a:t>
+            </a:r>
+            <a:r>
+              <a:rPr lang="de-DE" sz="1100" i="1" dirty="0">
+                <a:solidFill>
+                  <a:schemeClr val="accent2">
+                    <a:lumMod val="75000"/>
+                  </a:schemeClr>
+                </a:solidFill>
+                <a:latin typeface="Latin Modern Math" panose="02000503000000000000" pitchFamily="50" charset="0"/>
+                <a:ea typeface="Latin Modern Math" panose="02000503000000000000" pitchFamily="50" charset="0"/>
+                <a:cs typeface="CMU Serif" panose="02000603000000000000" pitchFamily="2" charset="0"/>
+              </a:rPr>
+              <a:t> </a:t>
+            </a:r>
+            <a:r>
+              <a:rPr lang="de-DE" sz="1100" dirty="0">
+                <a:solidFill>
+                  <a:schemeClr val="accent2">
+                    <a:lumMod val="75000"/>
+                  </a:schemeClr>
+                </a:solidFill>
+                <a:latin typeface="CMU Serif" panose="02000603000000000000" pitchFamily="2" charset="0"/>
+                <a:ea typeface="CMU Serif" panose="02000603000000000000" pitchFamily="2" charset="0"/>
+                <a:cs typeface="CMU Serif" panose="02000603000000000000" pitchFamily="2" charset="0"/>
+              </a:rPr>
+              <a:t>=</a:t>
+            </a:r>
+            <a:r>
+              <a:rPr lang="de-DE" sz="1100" i="1" dirty="0">
+                <a:solidFill>
+                  <a:schemeClr val="accent2">
+                    <a:lumMod val="75000"/>
+                  </a:schemeClr>
+                </a:solidFill>
+                <a:latin typeface="CMU Serif" panose="02000603000000000000" pitchFamily="2" charset="0"/>
+                <a:ea typeface="CMU Serif" panose="02000603000000000000" pitchFamily="2" charset="0"/>
+                <a:cs typeface="CMU Serif" panose="02000603000000000000" pitchFamily="2" charset="0"/>
+              </a:rPr>
+              <a:t>A</a:t>
+            </a:r>
+            <a:r>
+              <a:rPr lang="de-DE" sz="1100" baseline="-25000" dirty="0">
+                <a:solidFill>
+                  <a:schemeClr val="accent2">
+                    <a:lumMod val="75000"/>
+                  </a:schemeClr>
+                </a:solidFill>
+                <a:latin typeface="CMU Serif" panose="02000603000000000000" pitchFamily="2" charset="0"/>
+                <a:ea typeface="CMU Serif" panose="02000603000000000000" pitchFamily="2" charset="0"/>
+                <a:cs typeface="CMU Serif" panose="02000603000000000000" pitchFamily="2" charset="0"/>
+              </a:rPr>
+              <a:t>2 </a:t>
+            </a:r>
+            <a:r>
+              <a:rPr lang="de-DE" sz="1100" dirty="0">
+                <a:solidFill>
+                  <a:schemeClr val="accent2">
+                    <a:lumMod val="75000"/>
+                  </a:schemeClr>
+                </a:solidFill>
+                <a:latin typeface="CMU Serif" panose="02000603000000000000" pitchFamily="2" charset="0"/>
+                <a:ea typeface="CMU Serif" panose="02000603000000000000" pitchFamily="2" charset="0"/>
+                <a:cs typeface="CMU Serif" panose="02000603000000000000" pitchFamily="2" charset="0"/>
+              </a:rPr>
+              <a:t>/3</a:t>
+            </a:r>
+          </a:p>
+        </p:txBody>
+      </p:sp>
     </p:spTree>
     <p:extLst>
       <p:ext uri="{BB962C8B-B14F-4D97-AF65-F5344CB8AC3E}">
@@ -5125,6 +7909,1401 @@
 </file>
 
 <file path=ppt/slides/slide3.xml><?xml version="1.0" encoding="utf-8"?>
+<p:sld xmlns:a="http://schemas.openxmlformats.org/drawingml/2006/main" xmlns:r="http://schemas.openxmlformats.org/officeDocument/2006/relationships" xmlns:p="http://schemas.openxmlformats.org/presentationml/2006/main">
+  <p:cSld>
+    <p:spTree>
+      <p:nvGrpSpPr>
+        <p:cNvPr id="1" name="">
+          <a:extLst>
+            <a:ext uri="{FF2B5EF4-FFF2-40B4-BE49-F238E27FC236}">
+              <a16:creationId xmlns:a16="http://schemas.microsoft.com/office/drawing/2014/main" id="{A95ABE8C-0631-F2E6-BDED-92AEB65BDE51}"/>
+            </a:ext>
+          </a:extLst>
+        </p:cNvPr>
+        <p:cNvGrpSpPr/>
+        <p:nvPr/>
+      </p:nvGrpSpPr>
+      <p:grpSpPr>
+        <a:xfrm>
+          <a:off x="0" y="0"/>
+          <a:ext cx="0" cy="0"/>
+          <a:chOff x="0" y="0"/>
+          <a:chExt cx="0" cy="0"/>
+        </a:xfrm>
+      </p:grpSpPr>
+      <p:grpSp>
+        <p:nvGrpSpPr>
+          <p:cNvPr id="14" name="Gruppieren 13">
+            <a:extLst>
+              <a:ext uri="{FF2B5EF4-FFF2-40B4-BE49-F238E27FC236}">
+                <a16:creationId xmlns:a16="http://schemas.microsoft.com/office/drawing/2014/main" id="{C93ACA81-9180-CFEB-5B4C-9444191A75D3}"/>
+              </a:ext>
+            </a:extLst>
+          </p:cNvPr>
+          <p:cNvGrpSpPr/>
+          <p:nvPr/>
+        </p:nvGrpSpPr>
+        <p:grpSpPr>
+          <a:xfrm>
+            <a:off x="3063700" y="1759457"/>
+            <a:ext cx="297655" cy="495659"/>
+            <a:chOff x="2818943" y="1913621"/>
+            <a:chExt cx="297655" cy="495659"/>
+          </a:xfrm>
+        </p:grpSpPr>
+        <p:cxnSp>
+          <p:nvCxnSpPr>
+            <p:cNvPr id="7" name="Gerader Verbinder 6">
+              <a:extLst>
+                <a:ext uri="{FF2B5EF4-FFF2-40B4-BE49-F238E27FC236}">
+                  <a16:creationId xmlns:a16="http://schemas.microsoft.com/office/drawing/2014/main" id="{BADDE350-52D7-B9CA-ED85-7891713AC68F}"/>
+                </a:ext>
+              </a:extLst>
+            </p:cNvPr>
+            <p:cNvCxnSpPr>
+              <a:cxnSpLocks/>
+            </p:cNvCxnSpPr>
+            <p:nvPr/>
+          </p:nvCxnSpPr>
+          <p:spPr>
+            <a:xfrm>
+              <a:off x="2917031" y="2152650"/>
+              <a:ext cx="132274" cy="0"/>
+            </a:xfrm>
+            <a:prstGeom prst="line">
+              <a:avLst/>
+            </a:prstGeom>
+            <a:ln w="9525" cap="rnd">
+              <a:round/>
+            </a:ln>
+          </p:spPr>
+          <p:style>
+            <a:lnRef idx="2">
+              <a:schemeClr val="dk1"/>
+            </a:lnRef>
+            <a:fillRef idx="0">
+              <a:schemeClr val="dk1"/>
+            </a:fillRef>
+            <a:effectRef idx="1">
+              <a:schemeClr val="dk1"/>
+            </a:effectRef>
+            <a:fontRef idx="minor">
+              <a:schemeClr val="tx1"/>
+            </a:fontRef>
+          </p:style>
+        </p:cxnSp>
+        <p:sp>
+          <p:nvSpPr>
+            <p:cNvPr id="9" name="Textfeld 8">
+              <a:extLst>
+                <a:ext uri="{FF2B5EF4-FFF2-40B4-BE49-F238E27FC236}">
+                  <a16:creationId xmlns:a16="http://schemas.microsoft.com/office/drawing/2014/main" id="{C6FD2DB6-E6D6-E278-CB11-2E5423938AAD}"/>
+                </a:ext>
+              </a:extLst>
+            </p:cNvPr>
+            <p:cNvSpPr txBox="1"/>
+            <p:nvPr/>
+          </p:nvSpPr>
+          <p:spPr>
+            <a:xfrm>
+              <a:off x="2821323" y="1913621"/>
+              <a:ext cx="295275" cy="307777"/>
+            </a:xfrm>
+            <a:prstGeom prst="rect">
+              <a:avLst/>
+            </a:prstGeom>
+            <a:noFill/>
+          </p:spPr>
+          <p:txBody>
+            <a:bodyPr wrap="square" rtlCol="0">
+              <a:spAutoFit/>
+            </a:bodyPr>
+            <a:lstStyle/>
+            <a:p>
+              <a:pPr algn="ctr"/>
+              <a:r>
+                <a:rPr lang="de-DE" sz="1400" i="1" dirty="0">
+                  <a:latin typeface="CMU Serif" panose="02000603000000000000" pitchFamily="2" charset="0"/>
+                  <a:ea typeface="CMU Serif" panose="02000603000000000000" pitchFamily="2" charset="0"/>
+                  <a:cs typeface="CMU Serif" panose="02000603000000000000" pitchFamily="2" charset="0"/>
+                </a:rPr>
+                <a:t>x</a:t>
+              </a:r>
+            </a:p>
+          </p:txBody>
+        </p:sp>
+        <p:sp>
+          <p:nvSpPr>
+            <p:cNvPr id="11" name="Textfeld 10">
+              <a:extLst>
+                <a:ext uri="{FF2B5EF4-FFF2-40B4-BE49-F238E27FC236}">
+                  <a16:creationId xmlns:a16="http://schemas.microsoft.com/office/drawing/2014/main" id="{B38EA8C7-0D88-F005-D19B-3C1245AC0656}"/>
+                </a:ext>
+              </a:extLst>
+            </p:cNvPr>
+            <p:cNvSpPr txBox="1"/>
+            <p:nvPr/>
+          </p:nvSpPr>
+          <p:spPr>
+            <a:xfrm>
+              <a:off x="2818943" y="2101503"/>
+              <a:ext cx="295275" cy="307777"/>
+            </a:xfrm>
+            <a:prstGeom prst="rect">
+              <a:avLst/>
+            </a:prstGeom>
+            <a:noFill/>
+          </p:spPr>
+          <p:txBody>
+            <a:bodyPr wrap="square" rtlCol="0">
+              <a:spAutoFit/>
+            </a:bodyPr>
+            <a:lstStyle/>
+            <a:p>
+              <a:pPr algn="ctr"/>
+              <a:r>
+                <a:rPr lang="de-DE" sz="1400" i="1" dirty="0">
+                  <a:latin typeface="CMU Serif" panose="02000603000000000000" pitchFamily="2" charset="0"/>
+                  <a:ea typeface="CMU Serif" panose="02000603000000000000" pitchFamily="2" charset="0"/>
+                  <a:cs typeface="CMU Serif" panose="02000603000000000000" pitchFamily="2" charset="0"/>
+                </a:rPr>
+                <a:t>t</a:t>
+              </a:r>
+            </a:p>
+          </p:txBody>
+        </p:sp>
+        <p:cxnSp>
+          <p:nvCxnSpPr>
+            <p:cNvPr id="12" name="Gerader Verbinder 11">
+              <a:extLst>
+                <a:ext uri="{FF2B5EF4-FFF2-40B4-BE49-F238E27FC236}">
+                  <a16:creationId xmlns:a16="http://schemas.microsoft.com/office/drawing/2014/main" id="{C6BC13BE-4DA4-6279-A038-0B0ADD496EFE}"/>
+                </a:ext>
+              </a:extLst>
+            </p:cNvPr>
+            <p:cNvCxnSpPr>
+              <a:cxnSpLocks/>
+            </p:cNvCxnSpPr>
+            <p:nvPr/>
+          </p:nvCxnSpPr>
+          <p:spPr>
+            <a:xfrm>
+              <a:off x="2961354" y="2006371"/>
+              <a:ext cx="45088" cy="0"/>
+            </a:xfrm>
+            <a:prstGeom prst="line">
+              <a:avLst/>
+            </a:prstGeom>
+            <a:ln w="6350" cap="sq">
+              <a:round/>
+            </a:ln>
+          </p:spPr>
+          <p:style>
+            <a:lnRef idx="2">
+              <a:schemeClr val="dk1"/>
+            </a:lnRef>
+            <a:fillRef idx="0">
+              <a:schemeClr val="dk1"/>
+            </a:fillRef>
+            <a:effectRef idx="1">
+              <a:schemeClr val="dk1"/>
+            </a:effectRef>
+            <a:fontRef idx="minor">
+              <a:schemeClr val="tx1"/>
+            </a:fontRef>
+          </p:style>
+        </p:cxnSp>
+      </p:grpSp>
+      <p:grpSp>
+        <p:nvGrpSpPr>
+          <p:cNvPr id="15" name="Gruppieren 14">
+            <a:extLst>
+              <a:ext uri="{FF2B5EF4-FFF2-40B4-BE49-F238E27FC236}">
+                <a16:creationId xmlns:a16="http://schemas.microsoft.com/office/drawing/2014/main" id="{AE38ADD2-05CC-AA48-7A27-10E90F077F6A}"/>
+              </a:ext>
+            </a:extLst>
+          </p:cNvPr>
+          <p:cNvGrpSpPr/>
+          <p:nvPr/>
+        </p:nvGrpSpPr>
+        <p:grpSpPr>
+          <a:xfrm>
+            <a:off x="214518" y="746425"/>
+            <a:ext cx="370706" cy="492860"/>
+            <a:chOff x="2792428" y="1913091"/>
+            <a:chExt cx="370706" cy="492860"/>
+          </a:xfrm>
+        </p:grpSpPr>
+        <p:cxnSp>
+          <p:nvCxnSpPr>
+            <p:cNvPr id="16" name="Gerader Verbinder 15">
+              <a:extLst>
+                <a:ext uri="{FF2B5EF4-FFF2-40B4-BE49-F238E27FC236}">
+                  <a16:creationId xmlns:a16="http://schemas.microsoft.com/office/drawing/2014/main" id="{62767AD4-7226-FC79-7A90-EF04635B0611}"/>
+                </a:ext>
+              </a:extLst>
+            </p:cNvPr>
+            <p:cNvCxnSpPr>
+              <a:cxnSpLocks/>
+            </p:cNvCxnSpPr>
+            <p:nvPr/>
+          </p:nvCxnSpPr>
+          <p:spPr>
+            <a:xfrm>
+              <a:off x="2917031" y="2152650"/>
+              <a:ext cx="134145" cy="0"/>
+            </a:xfrm>
+            <a:prstGeom prst="line">
+              <a:avLst/>
+            </a:prstGeom>
+            <a:ln w="9525" cap="rnd">
+              <a:round/>
+            </a:ln>
+          </p:spPr>
+          <p:style>
+            <a:lnRef idx="2">
+              <a:schemeClr val="dk1"/>
+            </a:lnRef>
+            <a:fillRef idx="0">
+              <a:schemeClr val="dk1"/>
+            </a:fillRef>
+            <a:effectRef idx="1">
+              <a:schemeClr val="dk1"/>
+            </a:effectRef>
+            <a:fontRef idx="minor">
+              <a:schemeClr val="tx1"/>
+            </a:fontRef>
+          </p:style>
+        </p:cxnSp>
+        <p:sp>
+          <p:nvSpPr>
+            <p:cNvPr id="17" name="Textfeld 16">
+              <a:extLst>
+                <a:ext uri="{FF2B5EF4-FFF2-40B4-BE49-F238E27FC236}">
+                  <a16:creationId xmlns:a16="http://schemas.microsoft.com/office/drawing/2014/main" id="{BD690850-6E7E-FD04-A6FE-3F9B54320004}"/>
+                </a:ext>
+              </a:extLst>
+            </p:cNvPr>
+            <p:cNvSpPr txBox="1"/>
+            <p:nvPr/>
+          </p:nvSpPr>
+          <p:spPr>
+            <a:xfrm>
+              <a:off x="2792428" y="1913091"/>
+              <a:ext cx="370706" cy="307777"/>
+            </a:xfrm>
+            <a:prstGeom prst="rect">
+              <a:avLst/>
+            </a:prstGeom>
+            <a:noFill/>
+          </p:spPr>
+          <p:txBody>
+            <a:bodyPr wrap="square" rtlCol="0">
+              <a:spAutoFit/>
+            </a:bodyPr>
+            <a:lstStyle/>
+            <a:p>
+              <a:pPr algn="ctr"/>
+              <a:r>
+                <a:rPr lang="de-DE" sz="1400" i="1" dirty="0" err="1">
+                  <a:latin typeface="Latin Modern Math" panose="02000503000000000000" pitchFamily="50" charset="0"/>
+                  <a:ea typeface="Latin Modern Math" panose="02000503000000000000" pitchFamily="50" charset="0"/>
+                  <a:cs typeface="CMU Serif" panose="02000603000000000000" pitchFamily="2" charset="0"/>
+                </a:rPr>
+                <a:t>γ</a:t>
+              </a:r>
+              <a:r>
+                <a:rPr lang="de-DE" sz="1400" i="1" baseline="-25000" dirty="0" err="1">
+                  <a:latin typeface="CMU Serif" panose="02000603000000000000" pitchFamily="2" charset="0"/>
+                  <a:ea typeface="CMU Serif" panose="02000603000000000000" pitchFamily="2" charset="0"/>
+                  <a:cs typeface="CMU Serif" panose="02000603000000000000" pitchFamily="2" charset="0"/>
+                </a:rPr>
+                <a:t>i</a:t>
+              </a:r>
+              <a:endParaRPr lang="de-DE" sz="1400" i="1" baseline="-25000" dirty="0">
+                <a:latin typeface="CMU Serif" panose="02000603000000000000" pitchFamily="2" charset="0"/>
+                <a:ea typeface="CMU Serif" panose="02000603000000000000" pitchFamily="2" charset="0"/>
+                <a:cs typeface="CMU Serif" panose="02000603000000000000" pitchFamily="2" charset="0"/>
+              </a:endParaRPr>
+            </a:p>
+          </p:txBody>
+        </p:sp>
+        <p:sp>
+          <p:nvSpPr>
+            <p:cNvPr id="18" name="Textfeld 17">
+              <a:extLst>
+                <a:ext uri="{FF2B5EF4-FFF2-40B4-BE49-F238E27FC236}">
+                  <a16:creationId xmlns:a16="http://schemas.microsoft.com/office/drawing/2014/main" id="{3CF0E126-A898-772F-2820-C997606DA49A}"/>
+                </a:ext>
+              </a:extLst>
+            </p:cNvPr>
+            <p:cNvSpPr txBox="1"/>
+            <p:nvPr/>
+          </p:nvSpPr>
+          <p:spPr>
+            <a:xfrm>
+              <a:off x="2815033" y="2098174"/>
+              <a:ext cx="295275" cy="307777"/>
+            </a:xfrm>
+            <a:prstGeom prst="rect">
+              <a:avLst/>
+            </a:prstGeom>
+            <a:noFill/>
+          </p:spPr>
+          <p:txBody>
+            <a:bodyPr wrap="square" rtlCol="0">
+              <a:spAutoFit/>
+            </a:bodyPr>
+            <a:lstStyle/>
+            <a:p>
+              <a:pPr algn="ctr"/>
+              <a:r>
+                <a:rPr lang="de-DE" sz="1400" i="1" dirty="0">
+                  <a:latin typeface="CMU Serif" panose="02000603000000000000" pitchFamily="2" charset="0"/>
+                  <a:ea typeface="CMU Serif" panose="02000603000000000000" pitchFamily="2" charset="0"/>
+                  <a:cs typeface="CMU Serif" panose="02000603000000000000" pitchFamily="2" charset="0"/>
+                </a:rPr>
+                <a:t>t</a:t>
+              </a:r>
+            </a:p>
+          </p:txBody>
+        </p:sp>
+      </p:grpSp>
+      <p:cxnSp>
+        <p:nvCxnSpPr>
+          <p:cNvPr id="3" name="Gerade Verbindung mit Pfeil 2">
+            <a:extLst>
+              <a:ext uri="{FF2B5EF4-FFF2-40B4-BE49-F238E27FC236}">
+                <a16:creationId xmlns:a16="http://schemas.microsoft.com/office/drawing/2014/main" id="{4942828F-CF00-632D-A0D4-FF13B839B253}"/>
+              </a:ext>
+            </a:extLst>
+          </p:cNvPr>
+          <p:cNvCxnSpPr>
+            <a:cxnSpLocks/>
+          </p:cNvCxnSpPr>
+          <p:nvPr/>
+        </p:nvCxnSpPr>
+        <p:spPr>
+          <a:xfrm flipV="1">
+            <a:off x="584660" y="921543"/>
+            <a:ext cx="0" cy="1824039"/>
+          </a:xfrm>
+          <a:prstGeom prst="straightConnector1">
+            <a:avLst/>
+          </a:prstGeom>
+          <a:ln cap="rnd">
+            <a:round/>
+            <a:tailEnd type="triangle"/>
+          </a:ln>
+        </p:spPr>
+        <p:style>
+          <a:lnRef idx="2">
+            <a:schemeClr val="dk1"/>
+          </a:lnRef>
+          <a:fillRef idx="0">
+            <a:schemeClr val="dk1"/>
+          </a:fillRef>
+          <a:effectRef idx="1">
+            <a:schemeClr val="dk1"/>
+          </a:effectRef>
+          <a:fontRef idx="minor">
+            <a:schemeClr val="tx1"/>
+          </a:fontRef>
+        </p:style>
+      </p:cxnSp>
+      <p:cxnSp>
+        <p:nvCxnSpPr>
+          <p:cNvPr id="4" name="Gerade Verbindung mit Pfeil 3">
+            <a:extLst>
+              <a:ext uri="{FF2B5EF4-FFF2-40B4-BE49-F238E27FC236}">
+                <a16:creationId xmlns:a16="http://schemas.microsoft.com/office/drawing/2014/main" id="{FD7BE870-A661-B8B4-06EA-D9500116FD98}"/>
+              </a:ext>
+            </a:extLst>
+          </p:cNvPr>
+          <p:cNvCxnSpPr>
+            <a:cxnSpLocks/>
+          </p:cNvCxnSpPr>
+          <p:nvPr/>
+        </p:nvCxnSpPr>
+        <p:spPr>
+          <a:xfrm>
+            <a:off x="584660" y="2000020"/>
+            <a:ext cx="2506536" cy="0"/>
+          </a:xfrm>
+          <a:prstGeom prst="straightConnector1">
+            <a:avLst/>
+          </a:prstGeom>
+          <a:ln cap="rnd">
+            <a:round/>
+            <a:tailEnd type="triangle"/>
+          </a:ln>
+        </p:spPr>
+        <p:style>
+          <a:lnRef idx="2">
+            <a:schemeClr val="dk1"/>
+          </a:lnRef>
+          <a:fillRef idx="0">
+            <a:schemeClr val="dk1"/>
+          </a:fillRef>
+          <a:effectRef idx="1">
+            <a:schemeClr val="dk1"/>
+          </a:effectRef>
+          <a:fontRef idx="minor">
+            <a:schemeClr val="tx1"/>
+          </a:fontRef>
+        </p:style>
+      </p:cxnSp>
+      <p:cxnSp>
+        <p:nvCxnSpPr>
+          <p:cNvPr id="35" name="Gerader Verbinder 34">
+            <a:extLst>
+              <a:ext uri="{FF2B5EF4-FFF2-40B4-BE49-F238E27FC236}">
+                <a16:creationId xmlns:a16="http://schemas.microsoft.com/office/drawing/2014/main" id="{A696138A-8C91-CE31-9F4E-1C93777C8E82}"/>
+              </a:ext>
+            </a:extLst>
+          </p:cNvPr>
+          <p:cNvCxnSpPr>
+            <a:cxnSpLocks/>
+          </p:cNvCxnSpPr>
+          <p:nvPr/>
+        </p:nvCxnSpPr>
+        <p:spPr>
+          <a:xfrm flipV="1">
+            <a:off x="2858293" y="1943117"/>
+            <a:ext cx="0" cy="109521"/>
+          </a:xfrm>
+          <a:prstGeom prst="line">
+            <a:avLst/>
+          </a:prstGeom>
+          <a:ln w="12700" cap="rnd">
+            <a:solidFill>
+              <a:schemeClr val="tx1"/>
+            </a:solidFill>
+            <a:prstDash val="solid"/>
+            <a:round/>
+          </a:ln>
+        </p:spPr>
+        <p:style>
+          <a:lnRef idx="2">
+            <a:schemeClr val="accent1"/>
+          </a:lnRef>
+          <a:fillRef idx="0">
+            <a:schemeClr val="accent1"/>
+          </a:fillRef>
+          <a:effectRef idx="1">
+            <a:schemeClr val="accent1"/>
+          </a:effectRef>
+          <a:fontRef idx="minor">
+            <a:schemeClr val="tx1"/>
+          </a:fontRef>
+        </p:style>
+      </p:cxnSp>
+      <p:sp>
+        <p:nvSpPr>
+          <p:cNvPr id="47" name="Textfeld 46">
+            <a:extLst>
+              <a:ext uri="{FF2B5EF4-FFF2-40B4-BE49-F238E27FC236}">
+                <a16:creationId xmlns:a16="http://schemas.microsoft.com/office/drawing/2014/main" id="{2831359E-5A88-CB77-964F-68B78AD9610D}"/>
+              </a:ext>
+            </a:extLst>
+          </p:cNvPr>
+          <p:cNvSpPr txBox="1"/>
+          <p:nvPr/>
+        </p:nvSpPr>
+        <p:spPr>
+          <a:xfrm>
+            <a:off x="2712839" y="2038660"/>
+            <a:ext cx="295275" cy="307777"/>
+          </a:xfrm>
+          <a:prstGeom prst="rect">
+            <a:avLst/>
+          </a:prstGeom>
+          <a:noFill/>
+        </p:spPr>
+        <p:txBody>
+          <a:bodyPr wrap="square" rtlCol="0">
+            <a:spAutoFit/>
+          </a:bodyPr>
+          <a:lstStyle/>
+          <a:p>
+            <a:pPr algn="ctr"/>
+            <a:r>
+              <a:rPr lang="de-DE" sz="1400" dirty="0">
+                <a:latin typeface="CMU Serif" panose="02000603000000000000" pitchFamily="2" charset="0"/>
+                <a:ea typeface="CMU Serif" panose="02000603000000000000" pitchFamily="2" charset="0"/>
+                <a:cs typeface="CMU Serif" panose="02000603000000000000" pitchFamily="2" charset="0"/>
+              </a:rPr>
+              <a:t>1</a:t>
+            </a:r>
+          </a:p>
+        </p:txBody>
+      </p:sp>
+      <p:sp>
+        <p:nvSpPr>
+          <p:cNvPr id="2" name="Freihandform: Form 1">
+            <a:extLst>
+              <a:ext uri="{FF2B5EF4-FFF2-40B4-BE49-F238E27FC236}">
+                <a16:creationId xmlns:a16="http://schemas.microsoft.com/office/drawing/2014/main" id="{279C83AE-48A4-A4D6-AE0B-B5B64A0D5186}"/>
+              </a:ext>
+            </a:extLst>
+          </p:cNvPr>
+          <p:cNvSpPr/>
+          <p:nvPr/>
+        </p:nvSpPr>
+        <p:spPr>
+          <a:xfrm>
+            <a:off x="585786" y="1277924"/>
+            <a:ext cx="2273301" cy="720740"/>
+          </a:xfrm>
+          <a:custGeom>
+            <a:avLst/>
+            <a:gdLst>
+              <a:gd name="csX0" fmla="*/ 0 w 2273300"/>
+              <a:gd name="csY0" fmla="*/ 784225 h 787400"/>
+              <a:gd name="csX1" fmla="*/ 1165225 w 2273300"/>
+              <a:gd name="csY1" fmla="*/ 0 h 787400"/>
+              <a:gd name="csX2" fmla="*/ 2273300 w 2273300"/>
+              <a:gd name="csY2" fmla="*/ 787400 h 787400"/>
+              <a:gd name="csX0" fmla="*/ 0 w 2273300"/>
+              <a:gd name="csY0" fmla="*/ 784225 h 787400"/>
+              <a:gd name="csX1" fmla="*/ 1165225 w 2273300"/>
+              <a:gd name="csY1" fmla="*/ 0 h 787400"/>
+              <a:gd name="csX2" fmla="*/ 2273300 w 2273300"/>
+              <a:gd name="csY2" fmla="*/ 787400 h 787400"/>
+              <a:gd name="csX0" fmla="*/ 0 w 2273300"/>
+              <a:gd name="csY0" fmla="*/ 784225 h 787400"/>
+              <a:gd name="csX1" fmla="*/ 1165225 w 2273300"/>
+              <a:gd name="csY1" fmla="*/ 0 h 787400"/>
+              <a:gd name="csX2" fmla="*/ 2273300 w 2273300"/>
+              <a:gd name="csY2" fmla="*/ 787400 h 787400"/>
+              <a:gd name="csX0" fmla="*/ 0 w 2273300"/>
+              <a:gd name="csY0" fmla="*/ 784225 h 787400"/>
+              <a:gd name="csX1" fmla="*/ 1165225 w 2273300"/>
+              <a:gd name="csY1" fmla="*/ 0 h 787400"/>
+              <a:gd name="csX2" fmla="*/ 2273300 w 2273300"/>
+              <a:gd name="csY2" fmla="*/ 787400 h 787400"/>
+              <a:gd name="csX0" fmla="*/ 0 w 2273300"/>
+              <a:gd name="csY0" fmla="*/ 787400 h 790575"/>
+              <a:gd name="csX1" fmla="*/ 1136650 w 2273300"/>
+              <a:gd name="csY1" fmla="*/ 0 h 790575"/>
+              <a:gd name="csX2" fmla="*/ 2273300 w 2273300"/>
+              <a:gd name="csY2" fmla="*/ 790575 h 790575"/>
+              <a:gd name="csX0" fmla="*/ 0 w 2273300"/>
+              <a:gd name="csY0" fmla="*/ 787418 h 790593"/>
+              <a:gd name="csX1" fmla="*/ 1136650 w 2273300"/>
+              <a:gd name="csY1" fmla="*/ 18 h 790593"/>
+              <a:gd name="csX2" fmla="*/ 2273300 w 2273300"/>
+              <a:gd name="csY2" fmla="*/ 790593 h 790593"/>
+              <a:gd name="csX0" fmla="*/ 0 w 2273300"/>
+              <a:gd name="csY0" fmla="*/ 717575 h 720750"/>
+              <a:gd name="csX1" fmla="*/ 1136650 w 2273300"/>
+              <a:gd name="csY1" fmla="*/ 25 h 720750"/>
+              <a:gd name="csX2" fmla="*/ 2273300 w 2273300"/>
+              <a:gd name="csY2" fmla="*/ 720750 h 720750"/>
+              <a:gd name="csX0" fmla="*/ 20 w 2273320"/>
+              <a:gd name="csY0" fmla="*/ 717575 h 720750"/>
+              <a:gd name="csX1" fmla="*/ 1136670 w 2273320"/>
+              <a:gd name="csY1" fmla="*/ 25 h 720750"/>
+              <a:gd name="csX2" fmla="*/ 2273320 w 2273320"/>
+              <a:gd name="csY2" fmla="*/ 720750 h 720750"/>
+              <a:gd name="csX0" fmla="*/ 20 w 2273320"/>
+              <a:gd name="csY0" fmla="*/ 717568 h 720743"/>
+              <a:gd name="csX1" fmla="*/ 1136670 w 2273320"/>
+              <a:gd name="csY1" fmla="*/ 18 h 720743"/>
+              <a:gd name="csX2" fmla="*/ 2273320 w 2273320"/>
+              <a:gd name="csY2" fmla="*/ 720743 h 720743"/>
+              <a:gd name="csX0" fmla="*/ 20 w 2273320"/>
+              <a:gd name="csY0" fmla="*/ 717565 h 720740"/>
+              <a:gd name="csX1" fmla="*/ 1136670 w 2273320"/>
+              <a:gd name="csY1" fmla="*/ 15 h 720740"/>
+              <a:gd name="csX2" fmla="*/ 2273320 w 2273320"/>
+              <a:gd name="csY2" fmla="*/ 720740 h 720740"/>
+              <a:gd name="csX0" fmla="*/ 1 w 2273301"/>
+              <a:gd name="csY0" fmla="*/ 717565 h 720740"/>
+              <a:gd name="csX1" fmla="*/ 1136651 w 2273301"/>
+              <a:gd name="csY1" fmla="*/ 15 h 720740"/>
+              <a:gd name="csX2" fmla="*/ 2273301 w 2273301"/>
+              <a:gd name="csY2" fmla="*/ 720740 h 720740"/>
+              <a:gd name="csX0" fmla="*/ 1 w 2273301"/>
+              <a:gd name="csY0" fmla="*/ 717565 h 720740"/>
+              <a:gd name="csX1" fmla="*/ 1146176 w 2273301"/>
+              <a:gd name="csY1" fmla="*/ 15 h 720740"/>
+              <a:gd name="csX2" fmla="*/ 2273301 w 2273301"/>
+              <a:gd name="csY2" fmla="*/ 720740 h 720740"/>
+            </a:gdLst>
+            <a:ahLst/>
+            <a:cxnLst>
+              <a:cxn ang="0">
+                <a:pos x="csX0" y="csY0"/>
+              </a:cxn>
+              <a:cxn ang="0">
+                <a:pos x="csX1" y="csY1"/>
+              </a:cxn>
+              <a:cxn ang="0">
+                <a:pos x="csX2" y="csY2"/>
+              </a:cxn>
+            </a:cxnLst>
+            <a:rect l="l" t="t" r="r" b="b"/>
+            <a:pathLst>
+              <a:path w="2273301" h="720740">
+                <a:moveTo>
+                  <a:pt x="1" y="717565"/>
+                </a:moveTo>
+                <a:cubicBezTo>
+                  <a:pt x="-528" y="334713"/>
+                  <a:pt x="494243" y="2661"/>
+                  <a:pt x="1146176" y="15"/>
+                </a:cubicBezTo>
+                <a:cubicBezTo>
+                  <a:pt x="1798109" y="-2631"/>
+                  <a:pt x="2270655" y="352704"/>
+                  <a:pt x="2273301" y="720740"/>
+                </a:cubicBezTo>
+              </a:path>
+            </a:pathLst>
+          </a:custGeom>
+          <a:noFill/>
+          <a:ln cap="rnd">
+            <a:solidFill>
+              <a:schemeClr val="accent6">
+                <a:lumMod val="75000"/>
+              </a:schemeClr>
+            </a:solidFill>
+            <a:round/>
+          </a:ln>
+        </p:spPr>
+        <p:style>
+          <a:lnRef idx="2">
+            <a:schemeClr val="accent1">
+              <a:shade val="15000"/>
+            </a:schemeClr>
+          </a:lnRef>
+          <a:fillRef idx="1">
+            <a:schemeClr val="accent1"/>
+          </a:fillRef>
+          <a:effectRef idx="0">
+            <a:schemeClr val="accent1"/>
+          </a:effectRef>
+          <a:fontRef idx="minor">
+            <a:schemeClr val="lt1"/>
+          </a:fontRef>
+        </p:style>
+        <p:txBody>
+          <a:bodyPr rtlCol="0" anchor="ctr"/>
+          <a:lstStyle/>
+          <a:p>
+            <a:pPr algn="ctr"/>
+            <a:endParaRPr lang="de-DE"/>
+          </a:p>
+        </p:txBody>
+      </p:sp>
+      <p:sp>
+        <p:nvSpPr>
+          <p:cNvPr id="5" name="Freihandform: Form 4">
+            <a:extLst>
+              <a:ext uri="{FF2B5EF4-FFF2-40B4-BE49-F238E27FC236}">
+                <a16:creationId xmlns:a16="http://schemas.microsoft.com/office/drawing/2014/main" id="{BE39D794-1B22-2E30-B374-B02D30D978C4}"/>
+              </a:ext>
+            </a:extLst>
+          </p:cNvPr>
+          <p:cNvSpPr/>
+          <p:nvPr/>
+        </p:nvSpPr>
+        <p:spPr>
+          <a:xfrm>
+            <a:off x="741362" y="954088"/>
+            <a:ext cx="2117725" cy="1044575"/>
+          </a:xfrm>
+          <a:custGeom>
+            <a:avLst/>
+            <a:gdLst>
+              <a:gd name="csX0" fmla="*/ 0 w 2117725"/>
+              <a:gd name="csY0" fmla="*/ 0 h 1044575"/>
+              <a:gd name="csX1" fmla="*/ 993775 w 2117725"/>
+              <a:gd name="csY1" fmla="*/ 615950 h 1044575"/>
+              <a:gd name="csX2" fmla="*/ 2117725 w 2117725"/>
+              <a:gd name="csY2" fmla="*/ 1044575 h 1044575"/>
+              <a:gd name="csX0" fmla="*/ 0 w 2117725"/>
+              <a:gd name="csY0" fmla="*/ 0 h 1044575"/>
+              <a:gd name="csX1" fmla="*/ 993775 w 2117725"/>
+              <a:gd name="csY1" fmla="*/ 615950 h 1044575"/>
+              <a:gd name="csX2" fmla="*/ 2117725 w 2117725"/>
+              <a:gd name="csY2" fmla="*/ 1044575 h 1044575"/>
+              <a:gd name="csX0" fmla="*/ 0 w 2117725"/>
+              <a:gd name="csY0" fmla="*/ 0 h 1044575"/>
+              <a:gd name="csX1" fmla="*/ 993775 w 2117725"/>
+              <a:gd name="csY1" fmla="*/ 615950 h 1044575"/>
+              <a:gd name="csX2" fmla="*/ 2117725 w 2117725"/>
+              <a:gd name="csY2" fmla="*/ 1044575 h 1044575"/>
+              <a:gd name="csX0" fmla="*/ 0 w 2117725"/>
+              <a:gd name="csY0" fmla="*/ 0 h 1044575"/>
+              <a:gd name="csX1" fmla="*/ 993775 w 2117725"/>
+              <a:gd name="csY1" fmla="*/ 615950 h 1044575"/>
+              <a:gd name="csX2" fmla="*/ 2117725 w 2117725"/>
+              <a:gd name="csY2" fmla="*/ 1044575 h 1044575"/>
+              <a:gd name="csX0" fmla="*/ 0 w 2117725"/>
+              <a:gd name="csY0" fmla="*/ 0 h 1044575"/>
+              <a:gd name="csX1" fmla="*/ 990600 w 2117725"/>
+              <a:gd name="csY1" fmla="*/ 584200 h 1044575"/>
+              <a:gd name="csX2" fmla="*/ 2117725 w 2117725"/>
+              <a:gd name="csY2" fmla="*/ 1044575 h 1044575"/>
+              <a:gd name="csX0" fmla="*/ 0 w 2117725"/>
+              <a:gd name="csY0" fmla="*/ 0 h 1044575"/>
+              <a:gd name="csX1" fmla="*/ 1022350 w 2117725"/>
+              <a:gd name="csY1" fmla="*/ 593725 h 1044575"/>
+              <a:gd name="csX2" fmla="*/ 2117725 w 2117725"/>
+              <a:gd name="csY2" fmla="*/ 1044575 h 1044575"/>
+              <a:gd name="csX0" fmla="*/ 0 w 2117725"/>
+              <a:gd name="csY0" fmla="*/ 0 h 1044575"/>
+              <a:gd name="csX1" fmla="*/ 1022350 w 2117725"/>
+              <a:gd name="csY1" fmla="*/ 593725 h 1044575"/>
+              <a:gd name="csX2" fmla="*/ 2117725 w 2117725"/>
+              <a:gd name="csY2" fmla="*/ 1044575 h 1044575"/>
+              <a:gd name="csX0" fmla="*/ 0 w 2117725"/>
+              <a:gd name="csY0" fmla="*/ 0 h 1044575"/>
+              <a:gd name="csX1" fmla="*/ 1022350 w 2117725"/>
+              <a:gd name="csY1" fmla="*/ 593725 h 1044575"/>
+              <a:gd name="csX2" fmla="*/ 2117725 w 2117725"/>
+              <a:gd name="csY2" fmla="*/ 1044575 h 1044575"/>
+              <a:gd name="csX0" fmla="*/ 0 w 2117725"/>
+              <a:gd name="csY0" fmla="*/ 0 h 1044575"/>
+              <a:gd name="csX1" fmla="*/ 1022350 w 2117725"/>
+              <a:gd name="csY1" fmla="*/ 593725 h 1044575"/>
+              <a:gd name="csX2" fmla="*/ 2117725 w 2117725"/>
+              <a:gd name="csY2" fmla="*/ 1044575 h 1044575"/>
+              <a:gd name="csX0" fmla="*/ 0 w 2117725"/>
+              <a:gd name="csY0" fmla="*/ 0 h 1044575"/>
+              <a:gd name="csX1" fmla="*/ 1022350 w 2117725"/>
+              <a:gd name="csY1" fmla="*/ 593725 h 1044575"/>
+              <a:gd name="csX2" fmla="*/ 2117725 w 2117725"/>
+              <a:gd name="csY2" fmla="*/ 1044575 h 1044575"/>
+            </a:gdLst>
+            <a:ahLst/>
+            <a:cxnLst>
+              <a:cxn ang="0">
+                <a:pos x="csX0" y="csY0"/>
+              </a:cxn>
+              <a:cxn ang="0">
+                <a:pos x="csX1" y="csY1"/>
+              </a:cxn>
+              <a:cxn ang="0">
+                <a:pos x="csX2" y="csY2"/>
+              </a:cxn>
+            </a:cxnLst>
+            <a:rect l="l" t="t" r="r" b="b"/>
+            <a:pathLst>
+              <a:path w="2117725" h="1044575">
+                <a:moveTo>
+                  <a:pt x="0" y="0"/>
+                </a:moveTo>
+                <a:cubicBezTo>
+                  <a:pt x="82285" y="411427"/>
+                  <a:pt x="555096" y="489479"/>
+                  <a:pt x="1022350" y="593725"/>
+                </a:cubicBezTo>
+                <a:cubicBezTo>
+                  <a:pt x="1489604" y="697971"/>
+                  <a:pt x="2070629" y="762000"/>
+                  <a:pt x="2117725" y="1044575"/>
+                </a:cubicBezTo>
+              </a:path>
+            </a:pathLst>
+          </a:custGeom>
+          <a:noFill/>
+          <a:ln cap="rnd">
+            <a:solidFill>
+              <a:schemeClr val="tx2">
+                <a:lumMod val="75000"/>
+                <a:lumOff val="25000"/>
+              </a:schemeClr>
+            </a:solidFill>
+            <a:round/>
+          </a:ln>
+        </p:spPr>
+        <p:style>
+          <a:lnRef idx="2">
+            <a:schemeClr val="accent1">
+              <a:shade val="15000"/>
+            </a:schemeClr>
+          </a:lnRef>
+          <a:fillRef idx="1">
+            <a:schemeClr val="accent1"/>
+          </a:fillRef>
+          <a:effectRef idx="0">
+            <a:schemeClr val="accent1"/>
+          </a:effectRef>
+          <a:fontRef idx="minor">
+            <a:schemeClr val="lt1"/>
+          </a:fontRef>
+        </p:style>
+        <p:txBody>
+          <a:bodyPr rtlCol="0" anchor="ctr"/>
+          <a:lstStyle/>
+          <a:p>
+            <a:pPr algn="ctr"/>
+            <a:endParaRPr lang="de-DE"/>
+          </a:p>
+        </p:txBody>
+      </p:sp>
+      <p:sp>
+        <p:nvSpPr>
+          <p:cNvPr id="6" name="Freihandform: Form 5">
+            <a:extLst>
+              <a:ext uri="{FF2B5EF4-FFF2-40B4-BE49-F238E27FC236}">
+                <a16:creationId xmlns:a16="http://schemas.microsoft.com/office/drawing/2014/main" id="{8B356C88-0CDA-6570-3EC9-4DE57FD943A6}"/>
+              </a:ext>
+            </a:extLst>
+          </p:cNvPr>
+          <p:cNvSpPr/>
+          <p:nvPr/>
+        </p:nvSpPr>
+        <p:spPr>
+          <a:xfrm>
+            <a:off x="585787" y="1607331"/>
+            <a:ext cx="2273300" cy="786621"/>
+          </a:xfrm>
+          <a:custGeom>
+            <a:avLst/>
+            <a:gdLst>
+              <a:gd name="csX0" fmla="*/ 0 w 2273300"/>
+              <a:gd name="csY0" fmla="*/ 422275 h 841375"/>
+              <a:gd name="csX1" fmla="*/ 488950 w 2273300"/>
+              <a:gd name="csY1" fmla="*/ 0 h 841375"/>
+              <a:gd name="csX2" fmla="*/ 1155700 w 2273300"/>
+              <a:gd name="csY2" fmla="*/ 419100 h 841375"/>
+              <a:gd name="csX3" fmla="*/ 1749425 w 2273300"/>
+              <a:gd name="csY3" fmla="*/ 841375 h 841375"/>
+              <a:gd name="csX4" fmla="*/ 2273300 w 2273300"/>
+              <a:gd name="csY4" fmla="*/ 419100 h 841375"/>
+              <a:gd name="csX0" fmla="*/ 0 w 2273300"/>
+              <a:gd name="csY0" fmla="*/ 415132 h 834232"/>
+              <a:gd name="csX1" fmla="*/ 534194 w 2273300"/>
+              <a:gd name="csY1" fmla="*/ 1 h 834232"/>
+              <a:gd name="csX2" fmla="*/ 1155700 w 2273300"/>
+              <a:gd name="csY2" fmla="*/ 411957 h 834232"/>
+              <a:gd name="csX3" fmla="*/ 1749425 w 2273300"/>
+              <a:gd name="csY3" fmla="*/ 834232 h 834232"/>
+              <a:gd name="csX4" fmla="*/ 2273300 w 2273300"/>
+              <a:gd name="csY4" fmla="*/ 411957 h 834232"/>
+              <a:gd name="csX0" fmla="*/ 0 w 2273300"/>
+              <a:gd name="csY0" fmla="*/ 412751 h 831851"/>
+              <a:gd name="csX1" fmla="*/ 584200 w 2273300"/>
+              <a:gd name="csY1" fmla="*/ 1 h 831851"/>
+              <a:gd name="csX2" fmla="*/ 1155700 w 2273300"/>
+              <a:gd name="csY2" fmla="*/ 409576 h 831851"/>
+              <a:gd name="csX3" fmla="*/ 1749425 w 2273300"/>
+              <a:gd name="csY3" fmla="*/ 831851 h 831851"/>
+              <a:gd name="csX4" fmla="*/ 2273300 w 2273300"/>
+              <a:gd name="csY4" fmla="*/ 409576 h 831851"/>
+              <a:gd name="csX0" fmla="*/ 0 w 2273300"/>
+              <a:gd name="csY0" fmla="*/ 412751 h 831851"/>
+              <a:gd name="csX1" fmla="*/ 584200 w 2273300"/>
+              <a:gd name="csY1" fmla="*/ 1 h 831851"/>
+              <a:gd name="csX2" fmla="*/ 1165225 w 2273300"/>
+              <a:gd name="csY2" fmla="*/ 414339 h 831851"/>
+              <a:gd name="csX3" fmla="*/ 1749425 w 2273300"/>
+              <a:gd name="csY3" fmla="*/ 831851 h 831851"/>
+              <a:gd name="csX4" fmla="*/ 2273300 w 2273300"/>
+              <a:gd name="csY4" fmla="*/ 409576 h 831851"/>
+              <a:gd name="csX0" fmla="*/ 0 w 2273300"/>
+              <a:gd name="csY0" fmla="*/ 412751 h 831851"/>
+              <a:gd name="csX1" fmla="*/ 584200 w 2273300"/>
+              <a:gd name="csY1" fmla="*/ 1 h 831851"/>
+              <a:gd name="csX2" fmla="*/ 1165225 w 2273300"/>
+              <a:gd name="csY2" fmla="*/ 414339 h 831851"/>
+              <a:gd name="csX3" fmla="*/ 1749425 w 2273300"/>
+              <a:gd name="csY3" fmla="*/ 831851 h 831851"/>
+              <a:gd name="csX4" fmla="*/ 2273300 w 2273300"/>
+              <a:gd name="csY4" fmla="*/ 409576 h 831851"/>
+              <a:gd name="csX0" fmla="*/ 0 w 2273300"/>
+              <a:gd name="csY0" fmla="*/ 396083 h 815183"/>
+              <a:gd name="csX1" fmla="*/ 562768 w 2273300"/>
+              <a:gd name="csY1" fmla="*/ 1 h 815183"/>
+              <a:gd name="csX2" fmla="*/ 1165225 w 2273300"/>
+              <a:gd name="csY2" fmla="*/ 397671 h 815183"/>
+              <a:gd name="csX3" fmla="*/ 1749425 w 2273300"/>
+              <a:gd name="csY3" fmla="*/ 815183 h 815183"/>
+              <a:gd name="csX4" fmla="*/ 2273300 w 2273300"/>
+              <a:gd name="csY4" fmla="*/ 392908 h 815183"/>
+              <a:gd name="csX0" fmla="*/ 0 w 2273300"/>
+              <a:gd name="csY0" fmla="*/ 396083 h 815183"/>
+              <a:gd name="csX1" fmla="*/ 562768 w 2273300"/>
+              <a:gd name="csY1" fmla="*/ 1 h 815183"/>
+              <a:gd name="csX2" fmla="*/ 1165225 w 2273300"/>
+              <a:gd name="csY2" fmla="*/ 397671 h 815183"/>
+              <a:gd name="csX3" fmla="*/ 1749425 w 2273300"/>
+              <a:gd name="csY3" fmla="*/ 815183 h 815183"/>
+              <a:gd name="csX4" fmla="*/ 2273300 w 2273300"/>
+              <a:gd name="csY4" fmla="*/ 392908 h 815183"/>
+              <a:gd name="csX0" fmla="*/ 0 w 2273300"/>
+              <a:gd name="csY0" fmla="*/ 396083 h 815183"/>
+              <a:gd name="csX1" fmla="*/ 562768 w 2273300"/>
+              <a:gd name="csY1" fmla="*/ 1 h 815183"/>
+              <a:gd name="csX2" fmla="*/ 1165225 w 2273300"/>
+              <a:gd name="csY2" fmla="*/ 397671 h 815183"/>
+              <a:gd name="csX3" fmla="*/ 1749425 w 2273300"/>
+              <a:gd name="csY3" fmla="*/ 815183 h 815183"/>
+              <a:gd name="csX4" fmla="*/ 2273300 w 2273300"/>
+              <a:gd name="csY4" fmla="*/ 392908 h 815183"/>
+              <a:gd name="csX0" fmla="*/ 0 w 2273300"/>
+              <a:gd name="csY0" fmla="*/ 396083 h 815183"/>
+              <a:gd name="csX1" fmla="*/ 562768 w 2273300"/>
+              <a:gd name="csY1" fmla="*/ 1 h 815183"/>
+              <a:gd name="csX2" fmla="*/ 1165225 w 2273300"/>
+              <a:gd name="csY2" fmla="*/ 397671 h 815183"/>
+              <a:gd name="csX3" fmla="*/ 1749425 w 2273300"/>
+              <a:gd name="csY3" fmla="*/ 815183 h 815183"/>
+              <a:gd name="csX4" fmla="*/ 2273300 w 2273300"/>
+              <a:gd name="csY4" fmla="*/ 392908 h 815183"/>
+              <a:gd name="csX0" fmla="*/ 0 w 2273300"/>
+              <a:gd name="csY0" fmla="*/ 396083 h 815183"/>
+              <a:gd name="csX1" fmla="*/ 562768 w 2273300"/>
+              <a:gd name="csY1" fmla="*/ 1 h 815183"/>
+              <a:gd name="csX2" fmla="*/ 1165225 w 2273300"/>
+              <a:gd name="csY2" fmla="*/ 397671 h 815183"/>
+              <a:gd name="csX3" fmla="*/ 1749425 w 2273300"/>
+              <a:gd name="csY3" fmla="*/ 815183 h 815183"/>
+              <a:gd name="csX4" fmla="*/ 2273300 w 2273300"/>
+              <a:gd name="csY4" fmla="*/ 392908 h 815183"/>
+              <a:gd name="csX0" fmla="*/ 0 w 2273300"/>
+              <a:gd name="csY0" fmla="*/ 396083 h 791371"/>
+              <a:gd name="csX1" fmla="*/ 562768 w 2273300"/>
+              <a:gd name="csY1" fmla="*/ 1 h 791371"/>
+              <a:gd name="csX2" fmla="*/ 1165225 w 2273300"/>
+              <a:gd name="csY2" fmla="*/ 397671 h 791371"/>
+              <a:gd name="csX3" fmla="*/ 1751806 w 2273300"/>
+              <a:gd name="csY3" fmla="*/ 791371 h 791371"/>
+              <a:gd name="csX4" fmla="*/ 2273300 w 2273300"/>
+              <a:gd name="csY4" fmla="*/ 392908 h 791371"/>
+              <a:gd name="csX0" fmla="*/ 0 w 2273300"/>
+              <a:gd name="csY0" fmla="*/ 396083 h 791371"/>
+              <a:gd name="csX1" fmla="*/ 562768 w 2273300"/>
+              <a:gd name="csY1" fmla="*/ 1 h 791371"/>
+              <a:gd name="csX2" fmla="*/ 1165225 w 2273300"/>
+              <a:gd name="csY2" fmla="*/ 397671 h 791371"/>
+              <a:gd name="csX3" fmla="*/ 1751806 w 2273300"/>
+              <a:gd name="csY3" fmla="*/ 791371 h 791371"/>
+              <a:gd name="csX4" fmla="*/ 2273300 w 2273300"/>
+              <a:gd name="csY4" fmla="*/ 392908 h 791371"/>
+              <a:gd name="csX0" fmla="*/ 0 w 2273300"/>
+              <a:gd name="csY0" fmla="*/ 396083 h 791371"/>
+              <a:gd name="csX1" fmla="*/ 562768 w 2273300"/>
+              <a:gd name="csY1" fmla="*/ 1 h 791371"/>
+              <a:gd name="csX2" fmla="*/ 1165225 w 2273300"/>
+              <a:gd name="csY2" fmla="*/ 397671 h 791371"/>
+              <a:gd name="csX3" fmla="*/ 1751806 w 2273300"/>
+              <a:gd name="csY3" fmla="*/ 791371 h 791371"/>
+              <a:gd name="csX4" fmla="*/ 2273300 w 2273300"/>
+              <a:gd name="csY4" fmla="*/ 392908 h 791371"/>
+              <a:gd name="csX0" fmla="*/ 0 w 2273300"/>
+              <a:gd name="csY0" fmla="*/ 396106 h 791394"/>
+              <a:gd name="csX1" fmla="*/ 562768 w 2273300"/>
+              <a:gd name="csY1" fmla="*/ 24 h 791394"/>
+              <a:gd name="csX2" fmla="*/ 1165225 w 2273300"/>
+              <a:gd name="csY2" fmla="*/ 397694 h 791394"/>
+              <a:gd name="csX3" fmla="*/ 1751806 w 2273300"/>
+              <a:gd name="csY3" fmla="*/ 791394 h 791394"/>
+              <a:gd name="csX4" fmla="*/ 2273300 w 2273300"/>
+              <a:gd name="csY4" fmla="*/ 392931 h 791394"/>
+              <a:gd name="csX0" fmla="*/ 0 w 2273300"/>
+              <a:gd name="csY0" fmla="*/ 396106 h 791394"/>
+              <a:gd name="csX1" fmla="*/ 562768 w 2273300"/>
+              <a:gd name="csY1" fmla="*/ 24 h 791394"/>
+              <a:gd name="csX2" fmla="*/ 1165225 w 2273300"/>
+              <a:gd name="csY2" fmla="*/ 397694 h 791394"/>
+              <a:gd name="csX3" fmla="*/ 1751806 w 2273300"/>
+              <a:gd name="csY3" fmla="*/ 791394 h 791394"/>
+              <a:gd name="csX4" fmla="*/ 2273300 w 2273300"/>
+              <a:gd name="csY4" fmla="*/ 392931 h 791394"/>
+              <a:gd name="csX0" fmla="*/ 0 w 2273300"/>
+              <a:gd name="csY0" fmla="*/ 396106 h 791394"/>
+              <a:gd name="csX1" fmla="*/ 562768 w 2273300"/>
+              <a:gd name="csY1" fmla="*/ 24 h 791394"/>
+              <a:gd name="csX2" fmla="*/ 1165225 w 2273300"/>
+              <a:gd name="csY2" fmla="*/ 397694 h 791394"/>
+              <a:gd name="csX3" fmla="*/ 1751806 w 2273300"/>
+              <a:gd name="csY3" fmla="*/ 791394 h 791394"/>
+              <a:gd name="csX4" fmla="*/ 2273300 w 2273300"/>
+              <a:gd name="csY4" fmla="*/ 392931 h 791394"/>
+              <a:gd name="csX0" fmla="*/ 0 w 2273300"/>
+              <a:gd name="csY0" fmla="*/ 396096 h 791384"/>
+              <a:gd name="csX1" fmla="*/ 562768 w 2273300"/>
+              <a:gd name="csY1" fmla="*/ 14 h 791384"/>
+              <a:gd name="csX2" fmla="*/ 1165225 w 2273300"/>
+              <a:gd name="csY2" fmla="*/ 397684 h 791384"/>
+              <a:gd name="csX3" fmla="*/ 1751806 w 2273300"/>
+              <a:gd name="csY3" fmla="*/ 791384 h 791384"/>
+              <a:gd name="csX4" fmla="*/ 2273300 w 2273300"/>
+              <a:gd name="csY4" fmla="*/ 392921 h 791384"/>
+              <a:gd name="csX0" fmla="*/ 0 w 2273300"/>
+              <a:gd name="csY0" fmla="*/ 396096 h 791384"/>
+              <a:gd name="csX1" fmla="*/ 562768 w 2273300"/>
+              <a:gd name="csY1" fmla="*/ 14 h 791384"/>
+              <a:gd name="csX2" fmla="*/ 1165225 w 2273300"/>
+              <a:gd name="csY2" fmla="*/ 397684 h 791384"/>
+              <a:gd name="csX3" fmla="*/ 1751806 w 2273300"/>
+              <a:gd name="csY3" fmla="*/ 791384 h 791384"/>
+              <a:gd name="csX4" fmla="*/ 2273300 w 2273300"/>
+              <a:gd name="csY4" fmla="*/ 392921 h 791384"/>
+              <a:gd name="csX0" fmla="*/ 0 w 2273300"/>
+              <a:gd name="csY0" fmla="*/ 396095 h 791383"/>
+              <a:gd name="csX1" fmla="*/ 562768 w 2273300"/>
+              <a:gd name="csY1" fmla="*/ 13 h 791383"/>
+              <a:gd name="csX2" fmla="*/ 1165225 w 2273300"/>
+              <a:gd name="csY2" fmla="*/ 397683 h 791383"/>
+              <a:gd name="csX3" fmla="*/ 1727993 w 2273300"/>
+              <a:gd name="csY3" fmla="*/ 791383 h 791383"/>
+              <a:gd name="csX4" fmla="*/ 2273300 w 2273300"/>
+              <a:gd name="csY4" fmla="*/ 392920 h 791383"/>
+              <a:gd name="csX0" fmla="*/ 0 w 2273300"/>
+              <a:gd name="csY0" fmla="*/ 396097 h 791385"/>
+              <a:gd name="csX1" fmla="*/ 562768 w 2273300"/>
+              <a:gd name="csY1" fmla="*/ 15 h 791385"/>
+              <a:gd name="csX2" fmla="*/ 1165225 w 2273300"/>
+              <a:gd name="csY2" fmla="*/ 397685 h 791385"/>
+              <a:gd name="csX3" fmla="*/ 1727993 w 2273300"/>
+              <a:gd name="csY3" fmla="*/ 791385 h 791385"/>
+              <a:gd name="csX4" fmla="*/ 2273300 w 2273300"/>
+              <a:gd name="csY4" fmla="*/ 392922 h 791385"/>
+              <a:gd name="csX0" fmla="*/ 0 w 2273300"/>
+              <a:gd name="csY0" fmla="*/ 391333 h 786621"/>
+              <a:gd name="csX1" fmla="*/ 586581 w 2273300"/>
+              <a:gd name="csY1" fmla="*/ 13 h 786621"/>
+              <a:gd name="csX2" fmla="*/ 1165225 w 2273300"/>
+              <a:gd name="csY2" fmla="*/ 392921 h 786621"/>
+              <a:gd name="csX3" fmla="*/ 1727993 w 2273300"/>
+              <a:gd name="csY3" fmla="*/ 786621 h 786621"/>
+              <a:gd name="csX4" fmla="*/ 2273300 w 2273300"/>
+              <a:gd name="csY4" fmla="*/ 388158 h 786621"/>
+              <a:gd name="csX0" fmla="*/ 0 w 2273300"/>
+              <a:gd name="csY0" fmla="*/ 391333 h 786621"/>
+              <a:gd name="csX1" fmla="*/ 586581 w 2273300"/>
+              <a:gd name="csY1" fmla="*/ 13 h 786621"/>
+              <a:gd name="csX2" fmla="*/ 1165225 w 2273300"/>
+              <a:gd name="csY2" fmla="*/ 392921 h 786621"/>
+              <a:gd name="csX3" fmla="*/ 1727993 w 2273300"/>
+              <a:gd name="csY3" fmla="*/ 786621 h 786621"/>
+              <a:gd name="csX4" fmla="*/ 2273300 w 2273300"/>
+              <a:gd name="csY4" fmla="*/ 388158 h 786621"/>
+              <a:gd name="csX0" fmla="*/ 0 w 2273300"/>
+              <a:gd name="csY0" fmla="*/ 391333 h 786621"/>
+              <a:gd name="csX1" fmla="*/ 586581 w 2273300"/>
+              <a:gd name="csY1" fmla="*/ 13 h 786621"/>
+              <a:gd name="csX2" fmla="*/ 1165225 w 2273300"/>
+              <a:gd name="csY2" fmla="*/ 392921 h 786621"/>
+              <a:gd name="csX3" fmla="*/ 1727993 w 2273300"/>
+              <a:gd name="csY3" fmla="*/ 786621 h 786621"/>
+              <a:gd name="csX4" fmla="*/ 2273300 w 2273300"/>
+              <a:gd name="csY4" fmla="*/ 388158 h 786621"/>
+            </a:gdLst>
+            <a:ahLst/>
+            <a:cxnLst>
+              <a:cxn ang="0">
+                <a:pos x="csX0" y="csY0"/>
+              </a:cxn>
+              <a:cxn ang="0">
+                <a:pos x="csX1" y="csY1"/>
+              </a:cxn>
+              <a:cxn ang="0">
+                <a:pos x="csX2" y="csY2"/>
+              </a:cxn>
+              <a:cxn ang="0">
+                <a:pos x="csX3" y="csY3"/>
+              </a:cxn>
+              <a:cxn ang="0">
+                <a:pos x="csX4" y="csY4"/>
+              </a:cxn>
+            </a:cxnLst>
+            <a:rect l="l" t="t" r="r" b="b"/>
+            <a:pathLst>
+              <a:path w="2273300" h="786621">
+                <a:moveTo>
+                  <a:pt x="0" y="391333"/>
+                </a:moveTo>
+                <a:cubicBezTo>
+                  <a:pt x="145785" y="209035"/>
+                  <a:pt x="344752" y="2130"/>
+                  <a:pt x="586581" y="13"/>
+                </a:cubicBezTo>
+                <a:cubicBezTo>
+                  <a:pt x="828410" y="-2104"/>
+                  <a:pt x="1051190" y="261819"/>
+                  <a:pt x="1165225" y="392921"/>
+                </a:cubicBezTo>
+                <a:cubicBezTo>
+                  <a:pt x="1279260" y="524023"/>
+                  <a:pt x="1470288" y="786621"/>
+                  <a:pt x="1727993" y="786621"/>
+                </a:cubicBezTo>
+                <a:cubicBezTo>
+                  <a:pt x="1985698" y="786621"/>
+                  <a:pt x="2121165" y="580245"/>
+                  <a:pt x="2273300" y="388158"/>
+                </a:cubicBezTo>
+              </a:path>
+            </a:pathLst>
+          </a:custGeom>
+          <a:noFill/>
+          <a:ln cap="rnd">
+            <a:solidFill>
+              <a:schemeClr val="accent2">
+                <a:lumMod val="75000"/>
+              </a:schemeClr>
+            </a:solidFill>
+            <a:round/>
+          </a:ln>
+        </p:spPr>
+        <p:style>
+          <a:lnRef idx="2">
+            <a:schemeClr val="accent1">
+              <a:shade val="15000"/>
+            </a:schemeClr>
+          </a:lnRef>
+          <a:fillRef idx="1">
+            <a:schemeClr val="accent1"/>
+          </a:fillRef>
+          <a:effectRef idx="0">
+            <a:schemeClr val="accent1"/>
+          </a:effectRef>
+          <a:fontRef idx="minor">
+            <a:schemeClr val="lt1"/>
+          </a:fontRef>
+        </p:style>
+        <p:txBody>
+          <a:bodyPr rtlCol="0" anchor="ctr"/>
+          <a:lstStyle/>
+          <a:p>
+            <a:pPr algn="ctr"/>
+            <a:endParaRPr lang="de-DE"/>
+          </a:p>
+        </p:txBody>
+      </p:sp>
+      <p:sp>
+        <p:nvSpPr>
+          <p:cNvPr id="8" name="Textfeld 7">
+            <a:extLst>
+              <a:ext uri="{FF2B5EF4-FFF2-40B4-BE49-F238E27FC236}">
+                <a16:creationId xmlns:a16="http://schemas.microsoft.com/office/drawing/2014/main" id="{3E8DB379-2808-7EE7-2DF2-97C15FE30FFF}"/>
+              </a:ext>
+            </a:extLst>
+          </p:cNvPr>
+          <p:cNvSpPr txBox="1"/>
+          <p:nvPr/>
+        </p:nvSpPr>
+        <p:spPr>
+          <a:xfrm>
+            <a:off x="754647" y="863458"/>
+            <a:ext cx="512970" cy="261610"/>
+          </a:xfrm>
+          <a:prstGeom prst="rect">
+            <a:avLst/>
+          </a:prstGeom>
+          <a:noFill/>
+        </p:spPr>
+        <p:txBody>
+          <a:bodyPr wrap="square" rtlCol="0">
+            <a:spAutoFit/>
+          </a:bodyPr>
+          <a:lstStyle/>
+          <a:p>
+            <a:pPr algn="ctr"/>
+            <a:r>
+              <a:rPr lang="de-DE" sz="1100" i="1" dirty="0">
+                <a:solidFill>
+                  <a:schemeClr val="tx2">
+                    <a:lumMod val="75000"/>
+                    <a:lumOff val="25000"/>
+                  </a:schemeClr>
+                </a:solidFill>
+                <a:latin typeface="CMU Serif" panose="02000603000000000000" pitchFamily="2" charset="0"/>
+                <a:ea typeface="CMU Serif" panose="02000603000000000000" pitchFamily="2" charset="0"/>
+                <a:cs typeface="CMU Serif" panose="02000603000000000000" pitchFamily="2" charset="0"/>
+              </a:rPr>
+              <a:t>i</a:t>
+            </a:r>
+            <a:r>
+              <a:rPr lang="de-DE" sz="1100" dirty="0">
+                <a:solidFill>
+                  <a:schemeClr val="tx2">
+                    <a:lumMod val="75000"/>
+                    <a:lumOff val="25000"/>
+                  </a:schemeClr>
+                </a:solidFill>
+                <a:latin typeface="CMU Serif" panose="02000603000000000000" pitchFamily="2" charset="0"/>
+                <a:ea typeface="CMU Serif" panose="02000603000000000000" pitchFamily="2" charset="0"/>
+                <a:cs typeface="CMU Serif" panose="02000603000000000000" pitchFamily="2" charset="0"/>
+              </a:rPr>
+              <a:t> = 0</a:t>
+            </a:r>
+          </a:p>
+        </p:txBody>
+      </p:sp>
+      <p:sp>
+        <p:nvSpPr>
+          <p:cNvPr id="10" name="Textfeld 9">
+            <a:extLst>
+              <a:ext uri="{FF2B5EF4-FFF2-40B4-BE49-F238E27FC236}">
+                <a16:creationId xmlns:a16="http://schemas.microsoft.com/office/drawing/2014/main" id="{8C14636E-63D0-C4C7-97CD-E04B6B239B81}"/>
+              </a:ext>
+            </a:extLst>
+          </p:cNvPr>
+          <p:cNvSpPr txBox="1"/>
+          <p:nvPr/>
+        </p:nvSpPr>
+        <p:spPr>
+          <a:xfrm>
+            <a:off x="1646237" y="1022829"/>
+            <a:ext cx="1264548" cy="261610"/>
+          </a:xfrm>
+          <a:prstGeom prst="rect">
+            <a:avLst/>
+          </a:prstGeom>
+          <a:noFill/>
+        </p:spPr>
+        <p:txBody>
+          <a:bodyPr wrap="square" rtlCol="0">
+            <a:spAutoFit/>
+          </a:bodyPr>
+          <a:lstStyle/>
+          <a:p>
+            <a:pPr algn="ctr"/>
+            <a:r>
+              <a:rPr lang="de-DE" sz="1100" i="1" dirty="0">
+                <a:solidFill>
+                  <a:schemeClr val="accent6">
+                    <a:lumMod val="75000"/>
+                  </a:schemeClr>
+                </a:solidFill>
+                <a:latin typeface="CMU Serif" panose="02000603000000000000" pitchFamily="2" charset="0"/>
+                <a:ea typeface="CMU Serif" panose="02000603000000000000" pitchFamily="2" charset="0"/>
+                <a:cs typeface="CMU Serif" panose="02000603000000000000" pitchFamily="2" charset="0"/>
+              </a:rPr>
+              <a:t>i</a:t>
+            </a:r>
+            <a:r>
+              <a:rPr lang="de-DE" sz="1100" dirty="0">
+                <a:solidFill>
+                  <a:schemeClr val="accent6">
+                    <a:lumMod val="75000"/>
+                  </a:schemeClr>
+                </a:solidFill>
+                <a:latin typeface="CMU Serif" panose="02000603000000000000" pitchFamily="2" charset="0"/>
+                <a:ea typeface="CMU Serif" panose="02000603000000000000" pitchFamily="2" charset="0"/>
+                <a:cs typeface="CMU Serif" panose="02000603000000000000" pitchFamily="2" charset="0"/>
+              </a:rPr>
+              <a:t> = 1  (elliptisch)</a:t>
+            </a:r>
+          </a:p>
+        </p:txBody>
+      </p:sp>
+      <p:sp>
+        <p:nvSpPr>
+          <p:cNvPr id="22" name="Textfeld 21">
+            <a:extLst>
+              <a:ext uri="{FF2B5EF4-FFF2-40B4-BE49-F238E27FC236}">
+                <a16:creationId xmlns:a16="http://schemas.microsoft.com/office/drawing/2014/main" id="{EE15E482-E8F9-3ABC-42EF-7B801811ED51}"/>
+              </a:ext>
+            </a:extLst>
+          </p:cNvPr>
+          <p:cNvSpPr txBox="1"/>
+          <p:nvPr/>
+        </p:nvSpPr>
+        <p:spPr>
+          <a:xfrm>
+            <a:off x="1324958" y="2052638"/>
+            <a:ext cx="512970" cy="261610"/>
+          </a:xfrm>
+          <a:prstGeom prst="rect">
+            <a:avLst/>
+          </a:prstGeom>
+          <a:noFill/>
+        </p:spPr>
+        <p:txBody>
+          <a:bodyPr wrap="square" rtlCol="0">
+            <a:spAutoFit/>
+          </a:bodyPr>
+          <a:lstStyle/>
+          <a:p>
+            <a:pPr algn="ctr"/>
+            <a:r>
+              <a:rPr lang="de-DE" sz="1100" i="1" dirty="0">
+                <a:solidFill>
+                  <a:schemeClr val="accent2">
+                    <a:lumMod val="75000"/>
+                  </a:schemeClr>
+                </a:solidFill>
+                <a:latin typeface="CMU Serif" panose="02000603000000000000" pitchFamily="2" charset="0"/>
+                <a:ea typeface="CMU Serif" panose="02000603000000000000" pitchFamily="2" charset="0"/>
+                <a:cs typeface="CMU Serif" panose="02000603000000000000" pitchFamily="2" charset="0"/>
+              </a:rPr>
+              <a:t>i</a:t>
+            </a:r>
+            <a:r>
+              <a:rPr lang="de-DE" sz="1100" dirty="0">
+                <a:solidFill>
+                  <a:schemeClr val="accent2">
+                    <a:lumMod val="75000"/>
+                  </a:schemeClr>
+                </a:solidFill>
+                <a:latin typeface="CMU Serif" panose="02000603000000000000" pitchFamily="2" charset="0"/>
+                <a:ea typeface="CMU Serif" panose="02000603000000000000" pitchFamily="2" charset="0"/>
+                <a:cs typeface="CMU Serif" panose="02000603000000000000" pitchFamily="2" charset="0"/>
+              </a:rPr>
+              <a:t> = 2</a:t>
+            </a:r>
+          </a:p>
+        </p:txBody>
+      </p:sp>
+    </p:spTree>
+    <p:extLst>
+      <p:ext uri="{BB962C8B-B14F-4D97-AF65-F5344CB8AC3E}">
+        <p14:creationId xmlns:p14="http://schemas.microsoft.com/office/powerpoint/2010/main" val="1300493935"/>
+      </p:ext>
+    </p:extLst>
+  </p:cSld>
+  <p:clrMapOvr>
+    <a:masterClrMapping/>
+  </p:clrMapOvr>
+</p:sld>
+</file>
+
+<file path=ppt/slides/slide4.xml><?xml version="1.0" encoding="utf-8"?>
+<p:sld xmlns:a="http://schemas.openxmlformats.org/drawingml/2006/main" xmlns:r="http://schemas.openxmlformats.org/officeDocument/2006/relationships" xmlns:p="http://schemas.openxmlformats.org/presentationml/2006/main">
+  <p:cSld>
+    <p:spTree>
+      <p:nvGrpSpPr>
+        <p:cNvPr id="1" name="">
+          <a:extLst>
+            <a:ext uri="{FF2B5EF4-FFF2-40B4-BE49-F238E27FC236}">
+              <a16:creationId xmlns:a16="http://schemas.microsoft.com/office/drawing/2014/main" id="{4AEBE6B5-B784-7829-6FC5-E4C259D78CBC}"/>
+            </a:ext>
+          </a:extLst>
+        </p:cNvPr>
+        <p:cNvGrpSpPr/>
+        <p:nvPr/>
+      </p:nvGrpSpPr>
+      <p:grpSpPr>
+        <a:xfrm>
+          <a:off x="0" y="0"/>
+          <a:ext cx="0" cy="0"/>
+          <a:chOff x="0" y="0"/>
+          <a:chExt cx="0" cy="0"/>
+        </a:xfrm>
+      </p:grpSpPr>
+    </p:spTree>
+    <p:extLst>
+      <p:ext uri="{BB962C8B-B14F-4D97-AF65-F5344CB8AC3E}">
+        <p14:creationId xmlns:p14="http://schemas.microsoft.com/office/powerpoint/2010/main" val="3351771347"/>
+      </p:ext>
+    </p:extLst>
+  </p:cSld>
+  <p:clrMapOvr>
+    <a:masterClrMapping/>
+  </p:clrMapOvr>
+</p:sld>
+</file>
+
+<file path=ppt/slides/slide5.xml><?xml version="1.0" encoding="utf-8"?>
 <p:sld xmlns:a="http://schemas.openxmlformats.org/drawingml/2006/main" xmlns:r="http://schemas.openxmlformats.org/officeDocument/2006/relationships" xmlns:p="http://schemas.openxmlformats.org/presentationml/2006/main">
   <p:cSld>
     <p:spTree>
@@ -11506,7 +15685,7 @@
 </p:sld>
 </file>
 
-<file path=ppt/slides/slide4.xml><?xml version="1.0" encoding="utf-8"?>
+<file path=ppt/slides/slide6.xml><?xml version="1.0" encoding="utf-8"?>
 <p:sld xmlns:a="http://schemas.openxmlformats.org/drawingml/2006/main" xmlns:r="http://schemas.openxmlformats.org/officeDocument/2006/relationships" xmlns:p="http://schemas.openxmlformats.org/presentationml/2006/main">
   <p:cSld>
     <p:spTree>
@@ -13481,7 +17660,7 @@
 </p:sld>
 </file>
 
-<file path=ppt/slides/slide5.xml><?xml version="1.0" encoding="utf-8"?>
+<file path=ppt/slides/slide7.xml><?xml version="1.0" encoding="utf-8"?>
 <p:sld xmlns:a="http://schemas.openxmlformats.org/drawingml/2006/main" xmlns:r="http://schemas.openxmlformats.org/officeDocument/2006/relationships" xmlns:p="http://schemas.openxmlformats.org/presentationml/2006/main">
   <p:cSld>
     <p:spTree>
@@ -14245,7 +18424,7 @@
 </p:sld>
 </file>
 
-<file path=ppt/slides/slide6.xml><?xml version="1.0" encoding="utf-8"?>
+<file path=ppt/slides/slide8.xml><?xml version="1.0" encoding="utf-8"?>
 <p:sld xmlns:a="http://schemas.openxmlformats.org/drawingml/2006/main" xmlns:r="http://schemas.openxmlformats.org/officeDocument/2006/relationships" xmlns:p="http://schemas.openxmlformats.org/presentationml/2006/main">
   <p:cSld>
     <p:spTree>
@@ -18264,7 +22443,7 @@
 </p:sld>
 </file>
 
-<file path=ppt/slides/slide7.xml><?xml version="1.0" encoding="utf-8"?>
+<file path=ppt/slides/slide9.xml><?xml version="1.0" encoding="utf-8"?>
 <p:sld xmlns:a="http://schemas.openxmlformats.org/drawingml/2006/main" xmlns:r="http://schemas.openxmlformats.org/officeDocument/2006/relationships" xmlns:p="http://schemas.openxmlformats.org/presentationml/2006/main">
   <p:cSld>
     <p:spTree>

</xml_diff>